<commit_message>
docs: add PDF presentation files and update README links
</commit_message>
<xml_diff>
--- a/presentation/Smart_Inventory_Tracking_Presentation_Part_1.pptx
+++ b/presentation/Smart_Inventory_Tracking_Presentation_Part_1.pptx
@@ -5,32 +5,31 @@
     <p:sldMasterId id="2147483722" r:id="rId4"/>
   </p:sldMasterIdLst>
   <p:notesMasterIdLst>
-    <p:notesMasterId r:id="rId28"/>
+    <p:notesMasterId r:id="rId27"/>
   </p:notesMasterIdLst>
   <p:sldIdLst>
     <p:sldId id="320" r:id="rId5"/>
-    <p:sldId id="332" r:id="rId6"/>
-    <p:sldId id="341" r:id="rId7"/>
-    <p:sldId id="335" r:id="rId8"/>
-    <p:sldId id="337" r:id="rId9"/>
-    <p:sldId id="342" r:id="rId10"/>
-    <p:sldId id="343" r:id="rId11"/>
-    <p:sldId id="338" r:id="rId12"/>
-    <p:sldId id="344" r:id="rId13"/>
-    <p:sldId id="345" r:id="rId14"/>
-    <p:sldId id="377" r:id="rId15"/>
-    <p:sldId id="340" r:id="rId16"/>
-    <p:sldId id="350" r:id="rId17"/>
-    <p:sldId id="365" r:id="rId18"/>
-    <p:sldId id="349" r:id="rId19"/>
-    <p:sldId id="367" r:id="rId20"/>
-    <p:sldId id="368" r:id="rId21"/>
-    <p:sldId id="369" r:id="rId22"/>
-    <p:sldId id="370" r:id="rId23"/>
-    <p:sldId id="371" r:id="rId24"/>
-    <p:sldId id="372" r:id="rId25"/>
-    <p:sldId id="373" r:id="rId26"/>
-    <p:sldId id="334" r:id="rId27"/>
+    <p:sldId id="341" r:id="rId6"/>
+    <p:sldId id="335" r:id="rId7"/>
+    <p:sldId id="337" r:id="rId8"/>
+    <p:sldId id="342" r:id="rId9"/>
+    <p:sldId id="343" r:id="rId10"/>
+    <p:sldId id="338" r:id="rId11"/>
+    <p:sldId id="344" r:id="rId12"/>
+    <p:sldId id="345" r:id="rId13"/>
+    <p:sldId id="377" r:id="rId14"/>
+    <p:sldId id="340" r:id="rId15"/>
+    <p:sldId id="350" r:id="rId16"/>
+    <p:sldId id="365" r:id="rId17"/>
+    <p:sldId id="349" r:id="rId18"/>
+    <p:sldId id="367" r:id="rId19"/>
+    <p:sldId id="368" r:id="rId20"/>
+    <p:sldId id="369" r:id="rId21"/>
+    <p:sldId id="370" r:id="rId22"/>
+    <p:sldId id="371" r:id="rId23"/>
+    <p:sldId id="372" r:id="rId24"/>
+    <p:sldId id="373" r:id="rId25"/>
+    <p:sldId id="334" r:id="rId26"/>
   </p:sldIdLst>
   <p:sldSz cx="12192000" cy="6858000"/>
   <p:notesSz cx="6858000" cy="9144000"/>
@@ -3125,1330 +3124,7 @@
 </dgm:colorsDef>
 </file>
 
-<file path=ppt/diagrams/colors5.xml><?xml version="1.0" encoding="utf-8"?>
-<dgm:colorsDef xmlns:dgm="http://schemas.openxmlformats.org/drawingml/2006/diagram" xmlns:a="http://schemas.openxmlformats.org/drawingml/2006/main" uniqueId="urn:microsoft.com/office/officeart/2005/8/colors/accent1_2">
-  <dgm:title val=""/>
-  <dgm:desc val=""/>
-  <dgm:catLst>
-    <dgm:cat type="accent1" pri="11200"/>
-  </dgm:catLst>
-  <dgm:styleLbl name="node0">
-    <dgm:fillClrLst meth="repeat">
-      <a:schemeClr val="accent1"/>
-    </dgm:fillClrLst>
-    <dgm:linClrLst meth="repeat">
-      <a:schemeClr val="lt1"/>
-    </dgm:linClrLst>
-    <dgm:effectClrLst/>
-    <dgm:txLinClrLst/>
-    <dgm:txFillClrLst/>
-    <dgm:txEffectClrLst/>
-  </dgm:styleLbl>
-  <dgm:styleLbl name="alignNode1">
-    <dgm:fillClrLst meth="repeat">
-      <a:schemeClr val="accent1"/>
-    </dgm:fillClrLst>
-    <dgm:linClrLst meth="repeat">
-      <a:schemeClr val="accent1"/>
-    </dgm:linClrLst>
-    <dgm:effectClrLst/>
-    <dgm:txLinClrLst/>
-    <dgm:txFillClrLst/>
-    <dgm:txEffectClrLst/>
-  </dgm:styleLbl>
-  <dgm:styleLbl name="node1">
-    <dgm:fillClrLst meth="repeat">
-      <a:schemeClr val="accent1"/>
-    </dgm:fillClrLst>
-    <dgm:linClrLst meth="repeat">
-      <a:schemeClr val="lt1"/>
-    </dgm:linClrLst>
-    <dgm:effectClrLst/>
-    <dgm:txLinClrLst/>
-    <dgm:txFillClrLst/>
-    <dgm:txEffectClrLst/>
-  </dgm:styleLbl>
-  <dgm:styleLbl name="lnNode1">
-    <dgm:fillClrLst meth="repeat">
-      <a:schemeClr val="accent1"/>
-    </dgm:fillClrLst>
-    <dgm:linClrLst meth="repeat">
-      <a:schemeClr val="lt1"/>
-    </dgm:linClrLst>
-    <dgm:effectClrLst/>
-    <dgm:txLinClrLst/>
-    <dgm:txFillClrLst/>
-    <dgm:txEffectClrLst/>
-  </dgm:styleLbl>
-  <dgm:styleLbl name="vennNode1">
-    <dgm:fillClrLst meth="repeat">
-      <a:schemeClr val="accent1">
-        <a:alpha val="50000"/>
-      </a:schemeClr>
-    </dgm:fillClrLst>
-    <dgm:linClrLst meth="repeat">
-      <a:schemeClr val="lt1"/>
-    </dgm:linClrLst>
-    <dgm:effectClrLst/>
-    <dgm:txLinClrLst/>
-    <dgm:txFillClrLst/>
-    <dgm:txEffectClrLst/>
-  </dgm:styleLbl>
-  <dgm:styleLbl name="node2">
-    <dgm:fillClrLst meth="repeat">
-      <a:schemeClr val="accent1"/>
-    </dgm:fillClrLst>
-    <dgm:linClrLst meth="repeat">
-      <a:schemeClr val="lt1"/>
-    </dgm:linClrLst>
-    <dgm:effectClrLst/>
-    <dgm:txLinClrLst/>
-    <dgm:txFillClrLst/>
-    <dgm:txEffectClrLst/>
-  </dgm:styleLbl>
-  <dgm:styleLbl name="node3">
-    <dgm:fillClrLst meth="repeat">
-      <a:schemeClr val="accent1"/>
-    </dgm:fillClrLst>
-    <dgm:linClrLst meth="repeat">
-      <a:schemeClr val="lt1"/>
-    </dgm:linClrLst>
-    <dgm:effectClrLst/>
-    <dgm:txLinClrLst/>
-    <dgm:txFillClrLst/>
-    <dgm:txEffectClrLst/>
-  </dgm:styleLbl>
-  <dgm:styleLbl name="node4">
-    <dgm:fillClrLst meth="repeat">
-      <a:schemeClr val="accent1"/>
-    </dgm:fillClrLst>
-    <dgm:linClrLst meth="repeat">
-      <a:schemeClr val="lt1"/>
-    </dgm:linClrLst>
-    <dgm:effectClrLst/>
-    <dgm:txLinClrLst/>
-    <dgm:txFillClrLst/>
-    <dgm:txEffectClrLst/>
-  </dgm:styleLbl>
-  <dgm:styleLbl name="fgImgPlace1">
-    <dgm:fillClrLst meth="repeat">
-      <a:schemeClr val="accent1">
-        <a:tint val="50000"/>
-      </a:schemeClr>
-    </dgm:fillClrLst>
-    <dgm:linClrLst meth="repeat">
-      <a:schemeClr val="lt1"/>
-    </dgm:linClrLst>
-    <dgm:effectClrLst/>
-    <dgm:txLinClrLst/>
-    <dgm:txFillClrLst meth="repeat">
-      <a:schemeClr val="lt1"/>
-    </dgm:txFillClrLst>
-    <dgm:txEffectClrLst/>
-  </dgm:styleLbl>
-  <dgm:styleLbl name="alignImgPlace1">
-    <dgm:fillClrLst meth="repeat">
-      <a:schemeClr val="accent1">
-        <a:tint val="50000"/>
-      </a:schemeClr>
-    </dgm:fillClrLst>
-    <dgm:linClrLst meth="repeat">
-      <a:schemeClr val="lt1"/>
-    </dgm:linClrLst>
-    <dgm:effectClrLst/>
-    <dgm:txLinClrLst/>
-    <dgm:txFillClrLst meth="repeat">
-      <a:schemeClr val="lt1"/>
-    </dgm:txFillClrLst>
-    <dgm:txEffectClrLst/>
-  </dgm:styleLbl>
-  <dgm:styleLbl name="bgImgPlace1">
-    <dgm:fillClrLst meth="repeat">
-      <a:schemeClr val="accent1">
-        <a:tint val="50000"/>
-      </a:schemeClr>
-    </dgm:fillClrLst>
-    <dgm:linClrLst meth="repeat">
-      <a:schemeClr val="lt1"/>
-    </dgm:linClrLst>
-    <dgm:effectClrLst/>
-    <dgm:txLinClrLst/>
-    <dgm:txFillClrLst meth="repeat">
-      <a:schemeClr val="lt1"/>
-    </dgm:txFillClrLst>
-    <dgm:txEffectClrLst/>
-  </dgm:styleLbl>
-  <dgm:styleLbl name="sibTrans2D1">
-    <dgm:fillClrLst meth="repeat">
-      <a:schemeClr val="accent1">
-        <a:tint val="60000"/>
-      </a:schemeClr>
-    </dgm:fillClrLst>
-    <dgm:linClrLst meth="repeat">
-      <a:schemeClr val="accent1">
-        <a:tint val="60000"/>
-      </a:schemeClr>
-    </dgm:linClrLst>
-    <dgm:effectClrLst/>
-    <dgm:txLinClrLst/>
-    <dgm:txFillClrLst/>
-    <dgm:txEffectClrLst/>
-  </dgm:styleLbl>
-  <dgm:styleLbl name="fgSibTrans2D1">
-    <dgm:fillClrLst meth="repeat">
-      <a:schemeClr val="accent1">
-        <a:tint val="60000"/>
-      </a:schemeClr>
-    </dgm:fillClrLst>
-    <dgm:linClrLst meth="repeat">
-      <a:schemeClr val="accent1">
-        <a:tint val="60000"/>
-      </a:schemeClr>
-    </dgm:linClrLst>
-    <dgm:effectClrLst/>
-    <dgm:txLinClrLst/>
-    <dgm:txFillClrLst/>
-    <dgm:txEffectClrLst/>
-  </dgm:styleLbl>
-  <dgm:styleLbl name="bgSibTrans2D1">
-    <dgm:fillClrLst meth="repeat">
-      <a:schemeClr val="accent1">
-        <a:tint val="60000"/>
-      </a:schemeClr>
-    </dgm:fillClrLst>
-    <dgm:linClrLst meth="repeat">
-      <a:schemeClr val="accent1">
-        <a:tint val="60000"/>
-      </a:schemeClr>
-    </dgm:linClrLst>
-    <dgm:effectClrLst/>
-    <dgm:txLinClrLst/>
-    <dgm:txFillClrLst/>
-    <dgm:txEffectClrLst/>
-  </dgm:styleLbl>
-  <dgm:styleLbl name="sibTrans1D1">
-    <dgm:fillClrLst meth="repeat">
-      <a:schemeClr val="accent1"/>
-    </dgm:fillClrLst>
-    <dgm:linClrLst meth="repeat">
-      <a:schemeClr val="accent1"/>
-    </dgm:linClrLst>
-    <dgm:effectClrLst/>
-    <dgm:txLinClrLst/>
-    <dgm:txFillClrLst meth="repeat">
-      <a:schemeClr val="tx1"/>
-    </dgm:txFillClrLst>
-    <dgm:txEffectClrLst/>
-  </dgm:styleLbl>
-  <dgm:styleLbl name="callout">
-    <dgm:fillClrLst meth="repeat">
-      <a:schemeClr val="accent1"/>
-    </dgm:fillClrLst>
-    <dgm:linClrLst meth="repeat">
-      <a:schemeClr val="accent1">
-        <a:tint val="50000"/>
-      </a:schemeClr>
-    </dgm:linClrLst>
-    <dgm:effectClrLst/>
-    <dgm:txLinClrLst/>
-    <dgm:txFillClrLst meth="repeat">
-      <a:schemeClr val="tx1"/>
-    </dgm:txFillClrLst>
-    <dgm:txEffectClrLst/>
-  </dgm:styleLbl>
-  <dgm:styleLbl name="asst0">
-    <dgm:fillClrLst meth="repeat">
-      <a:schemeClr val="accent1"/>
-    </dgm:fillClrLst>
-    <dgm:linClrLst meth="repeat">
-      <a:schemeClr val="lt1"/>
-    </dgm:linClrLst>
-    <dgm:effectClrLst/>
-    <dgm:txLinClrLst/>
-    <dgm:txFillClrLst/>
-    <dgm:txEffectClrLst/>
-  </dgm:styleLbl>
-  <dgm:styleLbl name="asst1">
-    <dgm:fillClrLst meth="repeat">
-      <a:schemeClr val="accent1"/>
-    </dgm:fillClrLst>
-    <dgm:linClrLst meth="repeat">
-      <a:schemeClr val="lt1"/>
-    </dgm:linClrLst>
-    <dgm:effectClrLst/>
-    <dgm:txLinClrLst/>
-    <dgm:txFillClrLst/>
-    <dgm:txEffectClrLst/>
-  </dgm:styleLbl>
-  <dgm:styleLbl name="asst2">
-    <dgm:fillClrLst meth="repeat">
-      <a:schemeClr val="accent1"/>
-    </dgm:fillClrLst>
-    <dgm:linClrLst meth="repeat">
-      <a:schemeClr val="lt1"/>
-    </dgm:linClrLst>
-    <dgm:effectClrLst/>
-    <dgm:txLinClrLst/>
-    <dgm:txFillClrLst/>
-    <dgm:txEffectClrLst/>
-  </dgm:styleLbl>
-  <dgm:styleLbl name="asst3">
-    <dgm:fillClrLst meth="repeat">
-      <a:schemeClr val="accent1"/>
-    </dgm:fillClrLst>
-    <dgm:linClrLst meth="repeat">
-      <a:schemeClr val="lt1"/>
-    </dgm:linClrLst>
-    <dgm:effectClrLst/>
-    <dgm:txLinClrLst/>
-    <dgm:txFillClrLst/>
-    <dgm:txEffectClrLst/>
-  </dgm:styleLbl>
-  <dgm:styleLbl name="asst4">
-    <dgm:fillClrLst meth="repeat">
-      <a:schemeClr val="accent1"/>
-    </dgm:fillClrLst>
-    <dgm:linClrLst meth="repeat">
-      <a:schemeClr val="lt1"/>
-    </dgm:linClrLst>
-    <dgm:effectClrLst/>
-    <dgm:txLinClrLst/>
-    <dgm:txFillClrLst/>
-    <dgm:txEffectClrLst/>
-  </dgm:styleLbl>
-  <dgm:styleLbl name="parChTrans2D1">
-    <dgm:fillClrLst meth="repeat">
-      <a:schemeClr val="accent1">
-        <a:tint val="60000"/>
-      </a:schemeClr>
-    </dgm:fillClrLst>
-    <dgm:linClrLst meth="repeat">
-      <a:schemeClr val="accent1">
-        <a:tint val="60000"/>
-      </a:schemeClr>
-    </dgm:linClrLst>
-    <dgm:effectClrLst/>
-    <dgm:txLinClrLst/>
-    <dgm:txFillClrLst meth="repeat">
-      <a:schemeClr val="lt1"/>
-    </dgm:txFillClrLst>
-    <dgm:txEffectClrLst/>
-  </dgm:styleLbl>
-  <dgm:styleLbl name="parChTrans2D2">
-    <dgm:fillClrLst meth="repeat">
-      <a:schemeClr val="accent1"/>
-    </dgm:fillClrLst>
-    <dgm:linClrLst meth="repeat">
-      <a:schemeClr val="accent1"/>
-    </dgm:linClrLst>
-    <dgm:effectClrLst/>
-    <dgm:txLinClrLst/>
-    <dgm:txFillClrLst meth="repeat">
-      <a:schemeClr val="lt1"/>
-    </dgm:txFillClrLst>
-    <dgm:txEffectClrLst/>
-  </dgm:styleLbl>
-  <dgm:styleLbl name="parChTrans2D3">
-    <dgm:fillClrLst meth="repeat">
-      <a:schemeClr val="accent1"/>
-    </dgm:fillClrLst>
-    <dgm:linClrLst meth="repeat">
-      <a:schemeClr val="accent1"/>
-    </dgm:linClrLst>
-    <dgm:effectClrLst/>
-    <dgm:txLinClrLst/>
-    <dgm:txFillClrLst meth="repeat">
-      <a:schemeClr val="lt1"/>
-    </dgm:txFillClrLst>
-    <dgm:txEffectClrLst/>
-  </dgm:styleLbl>
-  <dgm:styleLbl name="parChTrans2D4">
-    <dgm:fillClrLst meth="repeat">
-      <a:schemeClr val="accent1"/>
-    </dgm:fillClrLst>
-    <dgm:linClrLst meth="repeat">
-      <a:schemeClr val="accent1"/>
-    </dgm:linClrLst>
-    <dgm:effectClrLst/>
-    <dgm:txLinClrLst/>
-    <dgm:txFillClrLst meth="repeat">
-      <a:schemeClr val="lt1"/>
-    </dgm:txFillClrLst>
-    <dgm:txEffectClrLst/>
-  </dgm:styleLbl>
-  <dgm:styleLbl name="parChTrans1D1">
-    <dgm:fillClrLst meth="repeat">
-      <a:schemeClr val="accent1"/>
-    </dgm:fillClrLst>
-    <dgm:linClrLst meth="repeat">
-      <a:schemeClr val="accent1">
-        <a:shade val="60000"/>
-      </a:schemeClr>
-    </dgm:linClrLst>
-    <dgm:effectClrLst/>
-    <dgm:txLinClrLst/>
-    <dgm:txFillClrLst meth="repeat">
-      <a:schemeClr val="tx1"/>
-    </dgm:txFillClrLst>
-    <dgm:txEffectClrLst/>
-  </dgm:styleLbl>
-  <dgm:styleLbl name="parChTrans1D2">
-    <dgm:fillClrLst meth="repeat">
-      <a:schemeClr val="accent1"/>
-    </dgm:fillClrLst>
-    <dgm:linClrLst meth="repeat">
-      <a:schemeClr val="accent1">
-        <a:shade val="60000"/>
-      </a:schemeClr>
-    </dgm:linClrLst>
-    <dgm:effectClrLst/>
-    <dgm:txLinClrLst/>
-    <dgm:txFillClrLst meth="repeat">
-      <a:schemeClr val="tx1"/>
-    </dgm:txFillClrLst>
-    <dgm:txEffectClrLst/>
-  </dgm:styleLbl>
-  <dgm:styleLbl name="parChTrans1D3">
-    <dgm:fillClrLst meth="repeat">
-      <a:schemeClr val="accent1"/>
-    </dgm:fillClrLst>
-    <dgm:linClrLst meth="repeat">
-      <a:schemeClr val="accent1">
-        <a:shade val="80000"/>
-      </a:schemeClr>
-    </dgm:linClrLst>
-    <dgm:effectClrLst/>
-    <dgm:txLinClrLst/>
-    <dgm:txFillClrLst meth="repeat">
-      <a:schemeClr val="tx1"/>
-    </dgm:txFillClrLst>
-    <dgm:txEffectClrLst/>
-  </dgm:styleLbl>
-  <dgm:styleLbl name="parChTrans1D4">
-    <dgm:fillClrLst meth="repeat">
-      <a:schemeClr val="accent1"/>
-    </dgm:fillClrLst>
-    <dgm:linClrLst meth="repeat">
-      <a:schemeClr val="accent1">
-        <a:shade val="80000"/>
-      </a:schemeClr>
-    </dgm:linClrLst>
-    <dgm:effectClrLst/>
-    <dgm:txLinClrLst/>
-    <dgm:txFillClrLst meth="repeat">
-      <a:schemeClr val="tx1"/>
-    </dgm:txFillClrLst>
-    <dgm:txEffectClrLst/>
-  </dgm:styleLbl>
-  <dgm:styleLbl name="fgAcc1">
-    <dgm:fillClrLst meth="repeat">
-      <a:schemeClr val="lt1">
-        <a:alpha val="90000"/>
-      </a:schemeClr>
-    </dgm:fillClrLst>
-    <dgm:linClrLst meth="repeat">
-      <a:schemeClr val="accent1"/>
-    </dgm:linClrLst>
-    <dgm:effectClrLst/>
-    <dgm:txLinClrLst/>
-    <dgm:txFillClrLst meth="repeat">
-      <a:schemeClr val="dk1"/>
-    </dgm:txFillClrLst>
-    <dgm:txEffectClrLst/>
-  </dgm:styleLbl>
-  <dgm:styleLbl name="conFgAcc1">
-    <dgm:fillClrLst meth="repeat">
-      <a:schemeClr val="lt1">
-        <a:alpha val="90000"/>
-      </a:schemeClr>
-    </dgm:fillClrLst>
-    <dgm:linClrLst meth="repeat">
-      <a:schemeClr val="accent1"/>
-    </dgm:linClrLst>
-    <dgm:effectClrLst/>
-    <dgm:txLinClrLst/>
-    <dgm:txFillClrLst meth="repeat">
-      <a:schemeClr val="dk1"/>
-    </dgm:txFillClrLst>
-    <dgm:txEffectClrLst/>
-  </dgm:styleLbl>
-  <dgm:styleLbl name="alignAcc1">
-    <dgm:fillClrLst meth="repeat">
-      <a:schemeClr val="lt1">
-        <a:alpha val="90000"/>
-      </a:schemeClr>
-    </dgm:fillClrLst>
-    <dgm:linClrLst meth="repeat">
-      <a:schemeClr val="accent1"/>
-    </dgm:linClrLst>
-    <dgm:effectClrLst/>
-    <dgm:txLinClrLst/>
-    <dgm:txFillClrLst meth="repeat">
-      <a:schemeClr val="dk1"/>
-    </dgm:txFillClrLst>
-    <dgm:txEffectClrLst/>
-  </dgm:styleLbl>
-  <dgm:styleLbl name="trAlignAcc1">
-    <dgm:fillClrLst meth="repeat">
-      <a:schemeClr val="lt1">
-        <a:alpha val="40000"/>
-      </a:schemeClr>
-    </dgm:fillClrLst>
-    <dgm:linClrLst meth="repeat">
-      <a:schemeClr val="accent1"/>
-    </dgm:linClrLst>
-    <dgm:effectClrLst/>
-    <dgm:txLinClrLst/>
-    <dgm:txFillClrLst meth="repeat">
-      <a:schemeClr val="dk1"/>
-    </dgm:txFillClrLst>
-    <dgm:txEffectClrLst/>
-  </dgm:styleLbl>
-  <dgm:styleLbl name="bgAcc1">
-    <dgm:fillClrLst meth="repeat">
-      <a:schemeClr val="lt1">
-        <a:alpha val="90000"/>
-      </a:schemeClr>
-    </dgm:fillClrLst>
-    <dgm:linClrLst meth="repeat">
-      <a:schemeClr val="accent1"/>
-    </dgm:linClrLst>
-    <dgm:effectClrLst/>
-    <dgm:txLinClrLst/>
-    <dgm:txFillClrLst meth="repeat">
-      <a:schemeClr val="dk1"/>
-    </dgm:txFillClrLst>
-    <dgm:txEffectClrLst/>
-  </dgm:styleLbl>
-  <dgm:styleLbl name="solidFgAcc1">
-    <dgm:fillClrLst meth="repeat">
-      <a:schemeClr val="lt1"/>
-    </dgm:fillClrLst>
-    <dgm:linClrLst meth="repeat">
-      <a:schemeClr val="accent1"/>
-    </dgm:linClrLst>
-    <dgm:effectClrLst/>
-    <dgm:txLinClrLst/>
-    <dgm:txFillClrLst meth="repeat">
-      <a:schemeClr val="dk1"/>
-    </dgm:txFillClrLst>
-    <dgm:txEffectClrLst/>
-  </dgm:styleLbl>
-  <dgm:styleLbl name="solidAlignAcc1">
-    <dgm:fillClrLst meth="repeat">
-      <a:schemeClr val="lt1"/>
-    </dgm:fillClrLst>
-    <dgm:linClrLst meth="repeat">
-      <a:schemeClr val="accent1"/>
-    </dgm:linClrLst>
-    <dgm:effectClrLst/>
-    <dgm:txLinClrLst/>
-    <dgm:txFillClrLst meth="repeat">
-      <a:schemeClr val="dk1"/>
-    </dgm:txFillClrLst>
-    <dgm:txEffectClrLst/>
-  </dgm:styleLbl>
-  <dgm:styleLbl name="solidBgAcc1">
-    <dgm:fillClrLst meth="repeat">
-      <a:schemeClr val="lt1"/>
-    </dgm:fillClrLst>
-    <dgm:linClrLst meth="repeat">
-      <a:schemeClr val="accent1"/>
-    </dgm:linClrLst>
-    <dgm:effectClrLst/>
-    <dgm:txLinClrLst/>
-    <dgm:txFillClrLst meth="repeat">
-      <a:schemeClr val="dk1"/>
-    </dgm:txFillClrLst>
-    <dgm:txEffectClrLst/>
-  </dgm:styleLbl>
-  <dgm:styleLbl name="fgAccFollowNode1">
-    <dgm:fillClrLst meth="repeat">
-      <a:schemeClr val="accent1">
-        <a:alpha val="90000"/>
-        <a:tint val="40000"/>
-      </a:schemeClr>
-    </dgm:fillClrLst>
-    <dgm:linClrLst meth="repeat">
-      <a:schemeClr val="accent1">
-        <a:alpha val="90000"/>
-        <a:tint val="40000"/>
-      </a:schemeClr>
-    </dgm:linClrLst>
-    <dgm:effectClrLst/>
-    <dgm:txLinClrLst/>
-    <dgm:txFillClrLst meth="repeat">
-      <a:schemeClr val="dk1"/>
-    </dgm:txFillClrLst>
-    <dgm:txEffectClrLst/>
-  </dgm:styleLbl>
-  <dgm:styleLbl name="alignAccFollowNode1">
-    <dgm:fillClrLst meth="repeat">
-      <a:schemeClr val="accent1">
-        <a:alpha val="90000"/>
-        <a:tint val="40000"/>
-      </a:schemeClr>
-    </dgm:fillClrLst>
-    <dgm:linClrLst meth="repeat">
-      <a:schemeClr val="accent1">
-        <a:alpha val="90000"/>
-        <a:tint val="40000"/>
-      </a:schemeClr>
-    </dgm:linClrLst>
-    <dgm:effectClrLst/>
-    <dgm:txLinClrLst/>
-    <dgm:txFillClrLst meth="repeat">
-      <a:schemeClr val="dk1"/>
-    </dgm:txFillClrLst>
-    <dgm:txEffectClrLst/>
-  </dgm:styleLbl>
-  <dgm:styleLbl name="bgAccFollowNode1">
-    <dgm:fillClrLst meth="repeat">
-      <a:schemeClr val="accent1">
-        <a:alpha val="90000"/>
-        <a:tint val="40000"/>
-      </a:schemeClr>
-    </dgm:fillClrLst>
-    <dgm:linClrLst meth="repeat">
-      <a:schemeClr val="accent1">
-        <a:alpha val="90000"/>
-        <a:tint val="40000"/>
-      </a:schemeClr>
-    </dgm:linClrLst>
-    <dgm:effectClrLst/>
-    <dgm:txLinClrLst/>
-    <dgm:txFillClrLst meth="repeat">
-      <a:schemeClr val="dk1"/>
-    </dgm:txFillClrLst>
-    <dgm:txEffectClrLst/>
-  </dgm:styleLbl>
-  <dgm:styleLbl name="fgAcc0">
-    <dgm:fillClrLst meth="repeat">
-      <a:schemeClr val="lt1">
-        <a:alpha val="90000"/>
-      </a:schemeClr>
-    </dgm:fillClrLst>
-    <dgm:linClrLst meth="repeat">
-      <a:schemeClr val="accent1"/>
-    </dgm:linClrLst>
-    <dgm:effectClrLst/>
-    <dgm:txLinClrLst/>
-    <dgm:txFillClrLst meth="repeat">
-      <a:schemeClr val="dk1"/>
-    </dgm:txFillClrLst>
-    <dgm:txEffectClrLst/>
-  </dgm:styleLbl>
-  <dgm:styleLbl name="fgAcc2">
-    <dgm:fillClrLst meth="repeat">
-      <a:schemeClr val="lt1">
-        <a:alpha val="90000"/>
-      </a:schemeClr>
-    </dgm:fillClrLst>
-    <dgm:linClrLst meth="repeat">
-      <a:schemeClr val="accent1"/>
-    </dgm:linClrLst>
-    <dgm:effectClrLst/>
-    <dgm:txLinClrLst/>
-    <dgm:txFillClrLst meth="repeat">
-      <a:schemeClr val="dk1"/>
-    </dgm:txFillClrLst>
-    <dgm:txEffectClrLst/>
-  </dgm:styleLbl>
-  <dgm:styleLbl name="fgAcc3">
-    <dgm:fillClrLst meth="repeat">
-      <a:schemeClr val="lt1">
-        <a:alpha val="90000"/>
-      </a:schemeClr>
-    </dgm:fillClrLst>
-    <dgm:linClrLst meth="repeat">
-      <a:schemeClr val="accent1"/>
-    </dgm:linClrLst>
-    <dgm:effectClrLst/>
-    <dgm:txLinClrLst/>
-    <dgm:txFillClrLst meth="repeat">
-      <a:schemeClr val="dk1"/>
-    </dgm:txFillClrLst>
-    <dgm:txEffectClrLst/>
-  </dgm:styleLbl>
-  <dgm:styleLbl name="fgAcc4">
-    <dgm:fillClrLst meth="repeat">
-      <a:schemeClr val="lt1">
-        <a:alpha val="90000"/>
-      </a:schemeClr>
-    </dgm:fillClrLst>
-    <dgm:linClrLst meth="repeat">
-      <a:schemeClr val="accent1"/>
-    </dgm:linClrLst>
-    <dgm:effectClrLst/>
-    <dgm:txLinClrLst/>
-    <dgm:txFillClrLst meth="repeat">
-      <a:schemeClr val="dk1"/>
-    </dgm:txFillClrLst>
-    <dgm:txEffectClrLst/>
-  </dgm:styleLbl>
-  <dgm:styleLbl name="bgShp">
-    <dgm:fillClrLst meth="repeat">
-      <a:schemeClr val="accent1">
-        <a:tint val="40000"/>
-      </a:schemeClr>
-    </dgm:fillClrLst>
-    <dgm:linClrLst meth="repeat">
-      <a:schemeClr val="accent1"/>
-    </dgm:linClrLst>
-    <dgm:effectClrLst/>
-    <dgm:txLinClrLst/>
-    <dgm:txFillClrLst meth="repeat">
-      <a:schemeClr val="dk1"/>
-    </dgm:txFillClrLst>
-    <dgm:txEffectClrLst/>
-  </dgm:styleLbl>
-  <dgm:styleLbl name="dkBgShp">
-    <dgm:fillClrLst meth="repeat">
-      <a:schemeClr val="accent1">
-        <a:shade val="80000"/>
-      </a:schemeClr>
-    </dgm:fillClrLst>
-    <dgm:linClrLst meth="repeat">
-      <a:schemeClr val="accent1"/>
-    </dgm:linClrLst>
-    <dgm:effectClrLst/>
-    <dgm:txLinClrLst/>
-    <dgm:txFillClrLst meth="repeat">
-      <a:schemeClr val="lt1"/>
-    </dgm:txFillClrLst>
-    <dgm:txEffectClrLst/>
-  </dgm:styleLbl>
-  <dgm:styleLbl name="trBgShp">
-    <dgm:fillClrLst meth="repeat">
-      <a:schemeClr val="accent1">
-        <a:tint val="50000"/>
-        <a:alpha val="40000"/>
-      </a:schemeClr>
-    </dgm:fillClrLst>
-    <dgm:linClrLst meth="repeat">
-      <a:schemeClr val="accent1"/>
-    </dgm:linClrLst>
-    <dgm:effectClrLst/>
-    <dgm:txLinClrLst/>
-    <dgm:txFillClrLst meth="repeat">
-      <a:schemeClr val="lt1"/>
-    </dgm:txFillClrLst>
-    <dgm:txEffectClrLst/>
-  </dgm:styleLbl>
-  <dgm:styleLbl name="fgShp">
-    <dgm:fillClrLst meth="repeat">
-      <a:schemeClr val="accent1">
-        <a:tint val="60000"/>
-      </a:schemeClr>
-    </dgm:fillClrLst>
-    <dgm:linClrLst meth="repeat">
-      <a:schemeClr val="lt1"/>
-    </dgm:linClrLst>
-    <dgm:effectClrLst/>
-    <dgm:txLinClrLst/>
-    <dgm:txFillClrLst meth="repeat">
-      <a:schemeClr val="dk1"/>
-    </dgm:txFillClrLst>
-    <dgm:txEffectClrLst/>
-  </dgm:styleLbl>
-  <dgm:styleLbl name="revTx">
-    <dgm:fillClrLst meth="repeat">
-      <a:schemeClr val="lt1">
-        <a:alpha val="0"/>
-      </a:schemeClr>
-    </dgm:fillClrLst>
-    <dgm:linClrLst meth="repeat">
-      <a:schemeClr val="dk1">
-        <a:alpha val="0"/>
-      </a:schemeClr>
-    </dgm:linClrLst>
-    <dgm:effectClrLst/>
-    <dgm:txLinClrLst/>
-    <dgm:txFillClrLst meth="repeat">
-      <a:schemeClr val="tx1"/>
-    </dgm:txFillClrLst>
-    <dgm:txEffectClrLst/>
-  </dgm:styleLbl>
-</dgm:colorsDef>
-</file>
-
 <file path=ppt/diagrams/data1.xml><?xml version="1.0" encoding="utf-8"?>
-<dgm:dataModel xmlns:dgm="http://schemas.openxmlformats.org/drawingml/2006/diagram" xmlns:a="http://schemas.openxmlformats.org/drawingml/2006/main">
-  <dgm:ptLst>
-    <dgm:pt modelId="{85358FEE-5166-4D38-9D85-71D80C5C502D}" type="doc">
-      <dgm:prSet loTypeId="urn:microsoft.com/office/officeart/2005/8/layout/default" loCatId="list" qsTypeId="urn:microsoft.com/office/officeart/2005/8/quickstyle/simple1" qsCatId="simple" csTypeId="urn:microsoft.com/office/officeart/2005/8/colors/accent1_2" csCatId="accent1" phldr="1"/>
-      <dgm:spPr/>
-      <dgm:t>
-        <a:bodyPr/>
-        <a:lstStyle/>
-        <a:p>
-          <a:endParaRPr lang="en-US"/>
-        </a:p>
-      </dgm:t>
-    </dgm:pt>
-    <dgm:pt modelId="{5197C46A-B0E8-481A-8143-8EC30D90A406}">
-      <dgm:prSet/>
-      <dgm:spPr>
-        <a:ln>
-          <a:noFill/>
-        </a:ln>
-        <a:effectLst>
-          <a:innerShdw blurRad="254000" dist="50800" dir="13500000">
-            <a:prstClr val="black">
-              <a:alpha val="27000"/>
-            </a:prstClr>
-          </a:innerShdw>
-          <a:reflection blurRad="25400" stA="49000" endPos="32000" dir="5400000" sy="-100000" algn="bl" rotWithShape="0"/>
-        </a:effectLst>
-      </dgm:spPr>
-      <dgm:t>
-        <a:bodyPr/>
-        <a:lstStyle/>
-        <a:p>
-          <a:r>
-            <a:rPr lang="en-US" dirty="0"/>
-            <a:t>Introduction</a:t>
-          </a:r>
-        </a:p>
-      </dgm:t>
-    </dgm:pt>
-    <dgm:pt modelId="{B3544C39-7DCC-40DF-95F8-631AA62E7E2D}" type="parTrans" cxnId="{DFBC712A-C677-4B40-BEC4-54063A650FE9}">
-      <dgm:prSet/>
-      <dgm:spPr/>
-      <dgm:t>
-        <a:bodyPr/>
-        <a:lstStyle/>
-        <a:p>
-          <a:endParaRPr lang="en-US"/>
-        </a:p>
-      </dgm:t>
-    </dgm:pt>
-    <dgm:pt modelId="{A3201115-E425-40B3-B948-9947EB63EA0F}" type="sibTrans" cxnId="{DFBC712A-C677-4B40-BEC4-54063A650FE9}">
-      <dgm:prSet/>
-      <dgm:spPr/>
-      <dgm:t>
-        <a:bodyPr/>
-        <a:lstStyle/>
-        <a:p>
-          <a:endParaRPr lang="en-US"/>
-        </a:p>
-      </dgm:t>
-    </dgm:pt>
-    <dgm:pt modelId="{B4887A73-5D38-43AB-AEF2-A676D3A9E860}">
-      <dgm:prSet/>
-      <dgm:spPr>
-        <a:ln>
-          <a:noFill/>
-        </a:ln>
-        <a:effectLst>
-          <a:innerShdw blurRad="254000" dist="50800" dir="13500000">
-            <a:prstClr val="black">
-              <a:alpha val="27000"/>
-            </a:prstClr>
-          </a:innerShdw>
-          <a:reflection blurRad="25400" stA="49000" endPos="32000" dir="5400000" sy="-100000" algn="bl" rotWithShape="0"/>
-        </a:effectLst>
-      </dgm:spPr>
-      <dgm:t>
-        <a:bodyPr/>
-        <a:lstStyle/>
-        <a:p>
-          <a:r>
-            <a:rPr lang="en-US" dirty="0"/>
-            <a:t>Research findings</a:t>
-          </a:r>
-        </a:p>
-      </dgm:t>
-    </dgm:pt>
-    <dgm:pt modelId="{2B7EFAB9-5D85-4ED8-99EA-822BD92AEBC2}" type="parTrans" cxnId="{B77FC2F5-0387-4DC0-A9DD-1C3BA15D6463}">
-      <dgm:prSet/>
-      <dgm:spPr/>
-      <dgm:t>
-        <a:bodyPr/>
-        <a:lstStyle/>
-        <a:p>
-          <a:endParaRPr lang="en-US"/>
-        </a:p>
-      </dgm:t>
-    </dgm:pt>
-    <dgm:pt modelId="{E88BC292-8678-49B4-B3C1-EE081B91CC2E}" type="sibTrans" cxnId="{B77FC2F5-0387-4DC0-A9DD-1C3BA15D6463}">
-      <dgm:prSet/>
-      <dgm:spPr/>
-      <dgm:t>
-        <a:bodyPr/>
-        <a:lstStyle/>
-        <a:p>
-          <a:endParaRPr lang="en-US"/>
-        </a:p>
-      </dgm:t>
-    </dgm:pt>
-    <dgm:pt modelId="{24EFE574-27F4-400F-9368-C67CB42C9D30}">
-      <dgm:prSet/>
-      <dgm:spPr>
-        <a:ln>
-          <a:noFill/>
-        </a:ln>
-        <a:effectLst>
-          <a:innerShdw blurRad="254000" dist="50800" dir="13500000">
-            <a:prstClr val="black">
-              <a:alpha val="27000"/>
-            </a:prstClr>
-          </a:innerShdw>
-          <a:reflection blurRad="25400" stA="49000" endPos="32000" dir="5400000" sy="-100000" algn="bl" rotWithShape="0"/>
-        </a:effectLst>
-      </dgm:spPr>
-      <dgm:t>
-        <a:bodyPr/>
-        <a:lstStyle/>
-        <a:p>
-          <a:r>
-            <a:rPr lang="en-US" dirty="0"/>
-            <a:t>Suggested solution</a:t>
-          </a:r>
-        </a:p>
-      </dgm:t>
-    </dgm:pt>
-    <dgm:pt modelId="{E00D0D16-2603-4527-9905-C13E1BB4232D}" type="parTrans" cxnId="{00BE41E3-0F0B-43BA-B13B-54CE171B6132}">
-      <dgm:prSet/>
-      <dgm:spPr/>
-      <dgm:t>
-        <a:bodyPr/>
-        <a:lstStyle/>
-        <a:p>
-          <a:endParaRPr lang="en-US"/>
-        </a:p>
-      </dgm:t>
-    </dgm:pt>
-    <dgm:pt modelId="{17871445-21B0-4A04-85D6-1AD0EC876AA6}" type="sibTrans" cxnId="{00BE41E3-0F0B-43BA-B13B-54CE171B6132}">
-      <dgm:prSet/>
-      <dgm:spPr/>
-      <dgm:t>
-        <a:bodyPr/>
-        <a:lstStyle/>
-        <a:p>
-          <a:endParaRPr lang="en-US"/>
-        </a:p>
-      </dgm:t>
-    </dgm:pt>
-    <dgm:pt modelId="{FDB4F61C-2D10-4B28-8D83-ACC57B0CE71F}">
-      <dgm:prSet/>
-      <dgm:spPr>
-        <a:ln>
-          <a:noFill/>
-        </a:ln>
-        <a:effectLst>
-          <a:innerShdw blurRad="254000" dist="50800" dir="13500000">
-            <a:prstClr val="black">
-              <a:alpha val="27000"/>
-            </a:prstClr>
-          </a:innerShdw>
-          <a:reflection blurRad="25400" stA="49000" endPos="32000" dir="5400000" sy="-100000" algn="bl" rotWithShape="0"/>
-        </a:effectLst>
-      </dgm:spPr>
-      <dgm:t>
-        <a:bodyPr/>
-        <a:lstStyle/>
-        <a:p>
-          <a:r>
-            <a:rPr lang="en-US"/>
-            <a:t>Targeted users</a:t>
-          </a:r>
-        </a:p>
-      </dgm:t>
-    </dgm:pt>
-    <dgm:pt modelId="{EF523B93-9849-4B9A-BB74-265863880145}" type="parTrans" cxnId="{FE44FBC9-446D-45E6-8E87-BF0EEC9C1CF3}">
-      <dgm:prSet/>
-      <dgm:spPr/>
-      <dgm:t>
-        <a:bodyPr/>
-        <a:lstStyle/>
-        <a:p>
-          <a:endParaRPr lang="en-US"/>
-        </a:p>
-      </dgm:t>
-    </dgm:pt>
-    <dgm:pt modelId="{937E5F42-3571-49C3-84C8-80D7F17F879A}" type="sibTrans" cxnId="{FE44FBC9-446D-45E6-8E87-BF0EEC9C1CF3}">
-      <dgm:prSet/>
-      <dgm:spPr/>
-      <dgm:t>
-        <a:bodyPr/>
-        <a:lstStyle/>
-        <a:p>
-          <a:endParaRPr lang="en-US"/>
-        </a:p>
-      </dgm:t>
-    </dgm:pt>
-    <dgm:pt modelId="{1C299DDC-C502-440D-A0A6-5249AC30317D}">
-      <dgm:prSet/>
-      <dgm:spPr>
-        <a:ln>
-          <a:noFill/>
-        </a:ln>
-        <a:effectLst>
-          <a:innerShdw blurRad="254000" dist="50800" dir="13500000">
-            <a:prstClr val="black">
-              <a:alpha val="27000"/>
-            </a:prstClr>
-          </a:innerShdw>
-          <a:reflection blurRad="25400" stA="49000" endPos="32000" dir="5400000" sy="-100000" algn="bl" rotWithShape="0"/>
-        </a:effectLst>
-      </dgm:spPr>
-      <dgm:t>
-        <a:bodyPr/>
-        <a:lstStyle/>
-        <a:p>
-          <a:r>
-            <a:rPr lang="en-US"/>
-            <a:t>Requirements and Analysis </a:t>
-          </a:r>
-        </a:p>
-      </dgm:t>
-    </dgm:pt>
-    <dgm:pt modelId="{8D3523A2-66C6-413D-9026-079600253F8E}" type="parTrans" cxnId="{078E7264-2C85-43E0-8300-C1C0F9C75FC9}">
-      <dgm:prSet/>
-      <dgm:spPr/>
-      <dgm:t>
-        <a:bodyPr/>
-        <a:lstStyle/>
-        <a:p>
-          <a:endParaRPr lang="en-US"/>
-        </a:p>
-      </dgm:t>
-    </dgm:pt>
-    <dgm:pt modelId="{CFA157E6-3DB2-4A8B-B555-13AEEEF379AE}" type="sibTrans" cxnId="{078E7264-2C85-43E0-8300-C1C0F9C75FC9}">
-      <dgm:prSet/>
-      <dgm:spPr/>
-      <dgm:t>
-        <a:bodyPr/>
-        <a:lstStyle/>
-        <a:p>
-          <a:endParaRPr lang="en-US"/>
-        </a:p>
-      </dgm:t>
-    </dgm:pt>
-    <dgm:pt modelId="{EC403972-E464-4B83-83AB-27C31261A46D}">
-      <dgm:prSet/>
-      <dgm:spPr>
-        <a:ln>
-          <a:noFill/>
-        </a:ln>
-        <a:effectLst>
-          <a:innerShdw blurRad="254000" dist="50800" dir="13500000">
-            <a:prstClr val="black">
-              <a:alpha val="27000"/>
-            </a:prstClr>
-          </a:innerShdw>
-          <a:reflection blurRad="25400" stA="49000" endPos="32000" dir="5400000" sy="-100000" algn="bl" rotWithShape="0"/>
-        </a:effectLst>
-      </dgm:spPr>
-      <dgm:t>
-        <a:bodyPr/>
-        <a:lstStyle/>
-        <a:p>
-          <a:r>
-            <a:rPr lang="en-US"/>
-            <a:t>System design</a:t>
-          </a:r>
-        </a:p>
-      </dgm:t>
-    </dgm:pt>
-    <dgm:pt modelId="{786FD988-06F4-4038-816A-0F8AB405702B}" type="parTrans" cxnId="{6685EEED-9E40-42B5-ABCB-006A4478FA7D}">
-      <dgm:prSet/>
-      <dgm:spPr/>
-      <dgm:t>
-        <a:bodyPr/>
-        <a:lstStyle/>
-        <a:p>
-          <a:endParaRPr lang="en-US"/>
-        </a:p>
-      </dgm:t>
-    </dgm:pt>
-    <dgm:pt modelId="{C66FF3A5-764B-4291-A960-3238727D0F1F}" type="sibTrans" cxnId="{6685EEED-9E40-42B5-ABCB-006A4478FA7D}">
-      <dgm:prSet/>
-      <dgm:spPr/>
-      <dgm:t>
-        <a:bodyPr/>
-        <a:lstStyle/>
-        <a:p>
-          <a:endParaRPr lang="en-US"/>
-        </a:p>
-      </dgm:t>
-    </dgm:pt>
-    <dgm:pt modelId="{C212B3FE-3971-4173-B30C-8ED9C61A5E2E}">
-      <dgm:prSet/>
-      <dgm:spPr>
-        <a:ln>
-          <a:noFill/>
-        </a:ln>
-        <a:effectLst>
-          <a:innerShdw blurRad="254000" dist="50800" dir="13500000">
-            <a:prstClr val="black">
-              <a:alpha val="27000"/>
-            </a:prstClr>
-          </a:innerShdw>
-          <a:reflection blurRad="25400" stA="49000" endPos="32000" dir="5400000" sy="-100000" algn="bl" rotWithShape="0"/>
-        </a:effectLst>
-      </dgm:spPr>
-      <dgm:t>
-        <a:bodyPr/>
-        <a:lstStyle/>
-        <a:p>
-          <a:r>
-            <a:rPr lang="en-US" dirty="0"/>
-            <a:t>User Interface</a:t>
-          </a:r>
-        </a:p>
-      </dgm:t>
-    </dgm:pt>
-    <dgm:pt modelId="{E789F0B7-64AE-4C9F-A205-AA6B89C90792}" type="parTrans" cxnId="{C4C4E803-4558-4760-B7B2-8A253BB361D3}">
-      <dgm:prSet/>
-      <dgm:spPr/>
-      <dgm:t>
-        <a:bodyPr/>
-        <a:lstStyle/>
-        <a:p>
-          <a:endParaRPr lang="en-US"/>
-        </a:p>
-      </dgm:t>
-    </dgm:pt>
-    <dgm:pt modelId="{990537B4-3200-47B0-90FA-CC2C99CA6C27}" type="sibTrans" cxnId="{C4C4E803-4558-4760-B7B2-8A253BB361D3}">
-      <dgm:prSet/>
-      <dgm:spPr/>
-      <dgm:t>
-        <a:bodyPr/>
-        <a:lstStyle/>
-        <a:p>
-          <a:endParaRPr lang="en-US"/>
-        </a:p>
-      </dgm:t>
-    </dgm:pt>
-    <dgm:pt modelId="{632E09CA-5B77-4DA7-9AC2-214C797B1182}">
-      <dgm:prSet/>
-      <dgm:spPr>
-        <a:ln>
-          <a:noFill/>
-        </a:ln>
-        <a:effectLst>
-          <a:innerShdw blurRad="254000" dist="50800" dir="13500000">
-            <a:prstClr val="black">
-              <a:alpha val="27000"/>
-            </a:prstClr>
-          </a:innerShdw>
-          <a:reflection blurRad="25400" stA="49000" endPos="32000" dir="5400000" sy="-100000" algn="bl" rotWithShape="0"/>
-        </a:effectLst>
-      </dgm:spPr>
-      <dgm:t>
-        <a:bodyPr/>
-        <a:lstStyle/>
-        <a:p>
-          <a:r>
-            <a:rPr lang="en-US" dirty="0"/>
-            <a:t>Project aims </a:t>
-          </a:r>
-        </a:p>
-      </dgm:t>
-    </dgm:pt>
-    <dgm:pt modelId="{A3611616-A016-424D-A9A4-E63140D6D508}" type="parTrans" cxnId="{A3456E38-0F48-41C0-AECB-FD1C27692347}">
-      <dgm:prSet/>
-      <dgm:spPr/>
-      <dgm:t>
-        <a:bodyPr/>
-        <a:lstStyle/>
-        <a:p>
-          <a:endParaRPr lang="en-US"/>
-        </a:p>
-      </dgm:t>
-    </dgm:pt>
-    <dgm:pt modelId="{086435BD-2187-4897-8CB0-2E0E533425B6}" type="sibTrans" cxnId="{A3456E38-0F48-41C0-AECB-FD1C27692347}">
-      <dgm:prSet/>
-      <dgm:spPr/>
-      <dgm:t>
-        <a:bodyPr/>
-        <a:lstStyle/>
-        <a:p>
-          <a:endParaRPr lang="en-US"/>
-        </a:p>
-      </dgm:t>
-    </dgm:pt>
-    <dgm:pt modelId="{4964C97D-336D-4286-8217-8E1FB6AED3FF}" type="pres">
-      <dgm:prSet presAssocID="{85358FEE-5166-4D38-9D85-71D80C5C502D}" presName="diagram" presStyleCnt="0">
-        <dgm:presLayoutVars>
-          <dgm:dir/>
-          <dgm:resizeHandles val="exact"/>
-        </dgm:presLayoutVars>
-      </dgm:prSet>
-      <dgm:spPr/>
-    </dgm:pt>
-    <dgm:pt modelId="{C13BC9FE-150B-405B-AA42-9942A508A8EB}" type="pres">
-      <dgm:prSet presAssocID="{5197C46A-B0E8-481A-8143-8EC30D90A406}" presName="node" presStyleLbl="node1" presStyleIdx="0" presStyleCnt="8">
-        <dgm:presLayoutVars>
-          <dgm:bulletEnabled val="1"/>
-        </dgm:presLayoutVars>
-      </dgm:prSet>
-      <dgm:spPr>
-        <a:prstGeom prst="roundRect">
-          <a:avLst/>
-        </a:prstGeom>
-      </dgm:spPr>
-    </dgm:pt>
-    <dgm:pt modelId="{B3B42306-AD48-4F77-8471-6FA7E3FC32CD}" type="pres">
-      <dgm:prSet presAssocID="{A3201115-E425-40B3-B948-9947EB63EA0F}" presName="sibTrans" presStyleCnt="0"/>
-      <dgm:spPr/>
-    </dgm:pt>
-    <dgm:pt modelId="{2D62EE5F-3CDD-4EED-8C71-9932C2AFCD18}" type="pres">
-      <dgm:prSet presAssocID="{632E09CA-5B77-4DA7-9AC2-214C797B1182}" presName="node" presStyleLbl="node1" presStyleIdx="1" presStyleCnt="8">
-        <dgm:presLayoutVars>
-          <dgm:bulletEnabled val="1"/>
-        </dgm:presLayoutVars>
-      </dgm:prSet>
-      <dgm:spPr>
-        <a:prstGeom prst="roundRect">
-          <a:avLst/>
-        </a:prstGeom>
-      </dgm:spPr>
-    </dgm:pt>
-    <dgm:pt modelId="{FC48F3B1-5C46-4A6D-AB05-21A64807E509}" type="pres">
-      <dgm:prSet presAssocID="{086435BD-2187-4897-8CB0-2E0E533425B6}" presName="sibTrans" presStyleCnt="0"/>
-      <dgm:spPr/>
-    </dgm:pt>
-    <dgm:pt modelId="{CFC0049C-4AC3-4ED4-9B3A-75F5CC3D9CE0}" type="pres">
-      <dgm:prSet presAssocID="{B4887A73-5D38-43AB-AEF2-A676D3A9E860}" presName="node" presStyleLbl="node1" presStyleIdx="2" presStyleCnt="8">
-        <dgm:presLayoutVars>
-          <dgm:bulletEnabled val="1"/>
-        </dgm:presLayoutVars>
-      </dgm:prSet>
-      <dgm:spPr>
-        <a:prstGeom prst="roundRect">
-          <a:avLst/>
-        </a:prstGeom>
-      </dgm:spPr>
-    </dgm:pt>
-    <dgm:pt modelId="{A6F3BB20-1510-4443-923C-06D294A57C3C}" type="pres">
-      <dgm:prSet presAssocID="{E88BC292-8678-49B4-B3C1-EE081B91CC2E}" presName="sibTrans" presStyleCnt="0"/>
-      <dgm:spPr/>
-    </dgm:pt>
-    <dgm:pt modelId="{C0336292-3D01-4662-AF09-5047347BD433}" type="pres">
-      <dgm:prSet presAssocID="{24EFE574-27F4-400F-9368-C67CB42C9D30}" presName="node" presStyleLbl="node1" presStyleIdx="3" presStyleCnt="8">
-        <dgm:presLayoutVars>
-          <dgm:bulletEnabled val="1"/>
-        </dgm:presLayoutVars>
-      </dgm:prSet>
-      <dgm:spPr>
-        <a:prstGeom prst="roundRect">
-          <a:avLst/>
-        </a:prstGeom>
-      </dgm:spPr>
-    </dgm:pt>
-    <dgm:pt modelId="{3A28AFDA-3EA5-44DA-8B31-E28E1201469C}" type="pres">
-      <dgm:prSet presAssocID="{17871445-21B0-4A04-85D6-1AD0EC876AA6}" presName="sibTrans" presStyleCnt="0"/>
-      <dgm:spPr/>
-    </dgm:pt>
-    <dgm:pt modelId="{E1A1B507-79E9-4472-8FBC-379558576FEC}" type="pres">
-      <dgm:prSet presAssocID="{FDB4F61C-2D10-4B28-8D83-ACC57B0CE71F}" presName="node" presStyleLbl="node1" presStyleIdx="4" presStyleCnt="8">
-        <dgm:presLayoutVars>
-          <dgm:bulletEnabled val="1"/>
-        </dgm:presLayoutVars>
-      </dgm:prSet>
-      <dgm:spPr>
-        <a:prstGeom prst="roundRect">
-          <a:avLst/>
-        </a:prstGeom>
-      </dgm:spPr>
-    </dgm:pt>
-    <dgm:pt modelId="{83E4C39D-ECF5-4C90-870B-BB3F1F2E3E9C}" type="pres">
-      <dgm:prSet presAssocID="{937E5F42-3571-49C3-84C8-80D7F17F879A}" presName="sibTrans" presStyleCnt="0"/>
-      <dgm:spPr/>
-    </dgm:pt>
-    <dgm:pt modelId="{A7447721-ED1A-49D0-A6E3-809B43652FFF}" type="pres">
-      <dgm:prSet presAssocID="{1C299DDC-C502-440D-A0A6-5249AC30317D}" presName="node" presStyleLbl="node1" presStyleIdx="5" presStyleCnt="8">
-        <dgm:presLayoutVars>
-          <dgm:bulletEnabled val="1"/>
-        </dgm:presLayoutVars>
-      </dgm:prSet>
-      <dgm:spPr>
-        <a:prstGeom prst="roundRect">
-          <a:avLst/>
-        </a:prstGeom>
-      </dgm:spPr>
-    </dgm:pt>
-    <dgm:pt modelId="{9D0D2638-4EE1-4E94-BE1B-92F8B9B184AD}" type="pres">
-      <dgm:prSet presAssocID="{CFA157E6-3DB2-4A8B-B555-13AEEEF379AE}" presName="sibTrans" presStyleCnt="0"/>
-      <dgm:spPr/>
-    </dgm:pt>
-    <dgm:pt modelId="{272BBDD3-22E0-4B3B-B560-9152EBE6038B}" type="pres">
-      <dgm:prSet presAssocID="{EC403972-E464-4B83-83AB-27C31261A46D}" presName="node" presStyleLbl="node1" presStyleIdx="6" presStyleCnt="8">
-        <dgm:presLayoutVars>
-          <dgm:bulletEnabled val="1"/>
-        </dgm:presLayoutVars>
-      </dgm:prSet>
-      <dgm:spPr>
-        <a:prstGeom prst="roundRect">
-          <a:avLst/>
-        </a:prstGeom>
-      </dgm:spPr>
-    </dgm:pt>
-    <dgm:pt modelId="{7D0CC747-39C7-4262-959A-72385B156AC6}" type="pres">
-      <dgm:prSet presAssocID="{C66FF3A5-764B-4291-A960-3238727D0F1F}" presName="sibTrans" presStyleCnt="0"/>
-      <dgm:spPr/>
-    </dgm:pt>
-    <dgm:pt modelId="{C4DBC421-0D16-4716-AD59-2ACBF3AE62C0}" type="pres">
-      <dgm:prSet presAssocID="{C212B3FE-3971-4173-B30C-8ED9C61A5E2E}" presName="node" presStyleLbl="node1" presStyleIdx="7" presStyleCnt="8">
-        <dgm:presLayoutVars>
-          <dgm:bulletEnabled val="1"/>
-        </dgm:presLayoutVars>
-      </dgm:prSet>
-      <dgm:spPr>
-        <a:prstGeom prst="roundRect">
-          <a:avLst/>
-        </a:prstGeom>
-      </dgm:spPr>
-    </dgm:pt>
-  </dgm:ptLst>
-  <dgm:cxnLst>
-    <dgm:cxn modelId="{C4C4E803-4558-4760-B7B2-8A253BB361D3}" srcId="{85358FEE-5166-4D38-9D85-71D80C5C502D}" destId="{C212B3FE-3971-4173-B30C-8ED9C61A5E2E}" srcOrd="7" destOrd="0" parTransId="{E789F0B7-64AE-4C9F-A205-AA6B89C90792}" sibTransId="{990537B4-3200-47B0-90FA-CC2C99CA6C27}"/>
-    <dgm:cxn modelId="{DFBC712A-C677-4B40-BEC4-54063A650FE9}" srcId="{85358FEE-5166-4D38-9D85-71D80C5C502D}" destId="{5197C46A-B0E8-481A-8143-8EC30D90A406}" srcOrd="0" destOrd="0" parTransId="{B3544C39-7DCC-40DF-95F8-631AA62E7E2D}" sibTransId="{A3201115-E425-40B3-B948-9947EB63EA0F}"/>
-    <dgm:cxn modelId="{EF59622B-B12A-4FA2-A466-91D959B01B2F}" type="presOf" srcId="{1C299DDC-C502-440D-A0A6-5249AC30317D}" destId="{A7447721-ED1A-49D0-A6E3-809B43652FFF}" srcOrd="0" destOrd="0" presId="urn:microsoft.com/office/officeart/2005/8/layout/default"/>
-    <dgm:cxn modelId="{A3456E38-0F48-41C0-AECB-FD1C27692347}" srcId="{85358FEE-5166-4D38-9D85-71D80C5C502D}" destId="{632E09CA-5B77-4DA7-9AC2-214C797B1182}" srcOrd="1" destOrd="0" parTransId="{A3611616-A016-424D-A9A4-E63140D6D508}" sibTransId="{086435BD-2187-4897-8CB0-2E0E533425B6}"/>
-    <dgm:cxn modelId="{C37D3E5C-7936-4238-9044-CB9EB8C1F222}" type="presOf" srcId="{B4887A73-5D38-43AB-AEF2-A676D3A9E860}" destId="{CFC0049C-4AC3-4ED4-9B3A-75F5CC3D9CE0}" srcOrd="0" destOrd="0" presId="urn:microsoft.com/office/officeart/2005/8/layout/default"/>
-    <dgm:cxn modelId="{078E7264-2C85-43E0-8300-C1C0F9C75FC9}" srcId="{85358FEE-5166-4D38-9D85-71D80C5C502D}" destId="{1C299DDC-C502-440D-A0A6-5249AC30317D}" srcOrd="5" destOrd="0" parTransId="{8D3523A2-66C6-413D-9026-079600253F8E}" sibTransId="{CFA157E6-3DB2-4A8B-B555-13AEEEF379AE}"/>
-    <dgm:cxn modelId="{32EF1978-699B-4695-821C-DC85406B8795}" type="presOf" srcId="{24EFE574-27F4-400F-9368-C67CB42C9D30}" destId="{C0336292-3D01-4662-AF09-5047347BD433}" srcOrd="0" destOrd="0" presId="urn:microsoft.com/office/officeart/2005/8/layout/default"/>
-    <dgm:cxn modelId="{A65BC579-6D27-40D1-A12B-0778D87876A1}" type="presOf" srcId="{C212B3FE-3971-4173-B30C-8ED9C61A5E2E}" destId="{C4DBC421-0D16-4716-AD59-2ACBF3AE62C0}" srcOrd="0" destOrd="0" presId="urn:microsoft.com/office/officeart/2005/8/layout/default"/>
-    <dgm:cxn modelId="{8A86A182-FD53-45BA-B815-CBFA94EF756C}" type="presOf" srcId="{FDB4F61C-2D10-4B28-8D83-ACC57B0CE71F}" destId="{E1A1B507-79E9-4472-8FBC-379558576FEC}" srcOrd="0" destOrd="0" presId="urn:microsoft.com/office/officeart/2005/8/layout/default"/>
-    <dgm:cxn modelId="{CA94A1C2-4F25-46D7-87A7-8BEA65E72AEE}" type="presOf" srcId="{85358FEE-5166-4D38-9D85-71D80C5C502D}" destId="{4964C97D-336D-4286-8217-8E1FB6AED3FF}" srcOrd="0" destOrd="0" presId="urn:microsoft.com/office/officeart/2005/8/layout/default"/>
-    <dgm:cxn modelId="{FE44FBC9-446D-45E6-8E87-BF0EEC9C1CF3}" srcId="{85358FEE-5166-4D38-9D85-71D80C5C502D}" destId="{FDB4F61C-2D10-4B28-8D83-ACC57B0CE71F}" srcOrd="4" destOrd="0" parTransId="{EF523B93-9849-4B9A-BB74-265863880145}" sibTransId="{937E5F42-3571-49C3-84C8-80D7F17F879A}"/>
-    <dgm:cxn modelId="{F264A9D1-3776-4BAF-B329-6C6DE6FEBE7D}" type="presOf" srcId="{EC403972-E464-4B83-83AB-27C31261A46D}" destId="{272BBDD3-22E0-4B3B-B560-9152EBE6038B}" srcOrd="0" destOrd="0" presId="urn:microsoft.com/office/officeart/2005/8/layout/default"/>
-    <dgm:cxn modelId="{CA190FD5-88C0-4E62-8D2D-31245894C7F1}" type="presOf" srcId="{5197C46A-B0E8-481A-8143-8EC30D90A406}" destId="{C13BC9FE-150B-405B-AA42-9942A508A8EB}" srcOrd="0" destOrd="0" presId="urn:microsoft.com/office/officeart/2005/8/layout/default"/>
-    <dgm:cxn modelId="{00BE41E3-0F0B-43BA-B13B-54CE171B6132}" srcId="{85358FEE-5166-4D38-9D85-71D80C5C502D}" destId="{24EFE574-27F4-400F-9368-C67CB42C9D30}" srcOrd="3" destOrd="0" parTransId="{E00D0D16-2603-4527-9905-C13E1BB4232D}" sibTransId="{17871445-21B0-4A04-85D6-1AD0EC876AA6}"/>
-    <dgm:cxn modelId="{6685EEED-9E40-42B5-ABCB-006A4478FA7D}" srcId="{85358FEE-5166-4D38-9D85-71D80C5C502D}" destId="{EC403972-E464-4B83-83AB-27C31261A46D}" srcOrd="6" destOrd="0" parTransId="{786FD988-06F4-4038-816A-0F8AB405702B}" sibTransId="{C66FF3A5-764B-4291-A960-3238727D0F1F}"/>
-    <dgm:cxn modelId="{68C6F5EF-41FF-4AB1-AB1C-A5BEA0408096}" type="presOf" srcId="{632E09CA-5B77-4DA7-9AC2-214C797B1182}" destId="{2D62EE5F-3CDD-4EED-8C71-9932C2AFCD18}" srcOrd="0" destOrd="0" presId="urn:microsoft.com/office/officeart/2005/8/layout/default"/>
-    <dgm:cxn modelId="{B77FC2F5-0387-4DC0-A9DD-1C3BA15D6463}" srcId="{85358FEE-5166-4D38-9D85-71D80C5C502D}" destId="{B4887A73-5D38-43AB-AEF2-A676D3A9E860}" srcOrd="2" destOrd="0" parTransId="{2B7EFAB9-5D85-4ED8-99EA-822BD92AEBC2}" sibTransId="{E88BC292-8678-49B4-B3C1-EE081B91CC2E}"/>
-    <dgm:cxn modelId="{52A17DD1-EAF0-4C31-8DD3-0E1755C744B6}" type="presParOf" srcId="{4964C97D-336D-4286-8217-8E1FB6AED3FF}" destId="{C13BC9FE-150B-405B-AA42-9942A508A8EB}" srcOrd="0" destOrd="0" presId="urn:microsoft.com/office/officeart/2005/8/layout/default"/>
-    <dgm:cxn modelId="{9F54435A-5271-472E-81F7-66051CF3FFEC}" type="presParOf" srcId="{4964C97D-336D-4286-8217-8E1FB6AED3FF}" destId="{B3B42306-AD48-4F77-8471-6FA7E3FC32CD}" srcOrd="1" destOrd="0" presId="urn:microsoft.com/office/officeart/2005/8/layout/default"/>
-    <dgm:cxn modelId="{E8061D46-4936-49CF-A664-31DEFCF8271B}" type="presParOf" srcId="{4964C97D-336D-4286-8217-8E1FB6AED3FF}" destId="{2D62EE5F-3CDD-4EED-8C71-9932C2AFCD18}" srcOrd="2" destOrd="0" presId="urn:microsoft.com/office/officeart/2005/8/layout/default"/>
-    <dgm:cxn modelId="{5C555054-5CC0-46BF-B6D6-E5991DE058CD}" type="presParOf" srcId="{4964C97D-336D-4286-8217-8E1FB6AED3FF}" destId="{FC48F3B1-5C46-4A6D-AB05-21A64807E509}" srcOrd="3" destOrd="0" presId="urn:microsoft.com/office/officeart/2005/8/layout/default"/>
-    <dgm:cxn modelId="{3576F3CF-30C4-42AD-9B9F-106057808811}" type="presParOf" srcId="{4964C97D-336D-4286-8217-8E1FB6AED3FF}" destId="{CFC0049C-4AC3-4ED4-9B3A-75F5CC3D9CE0}" srcOrd="4" destOrd="0" presId="urn:microsoft.com/office/officeart/2005/8/layout/default"/>
-    <dgm:cxn modelId="{7E208725-05F1-4161-9958-4185EA38098D}" type="presParOf" srcId="{4964C97D-336D-4286-8217-8E1FB6AED3FF}" destId="{A6F3BB20-1510-4443-923C-06D294A57C3C}" srcOrd="5" destOrd="0" presId="urn:microsoft.com/office/officeart/2005/8/layout/default"/>
-    <dgm:cxn modelId="{FA38C07A-BCA7-4A68-9E90-50B85029929B}" type="presParOf" srcId="{4964C97D-336D-4286-8217-8E1FB6AED3FF}" destId="{C0336292-3D01-4662-AF09-5047347BD433}" srcOrd="6" destOrd="0" presId="urn:microsoft.com/office/officeart/2005/8/layout/default"/>
-    <dgm:cxn modelId="{926E21BC-255F-45F1-A7BD-A08B80C9EA5E}" type="presParOf" srcId="{4964C97D-336D-4286-8217-8E1FB6AED3FF}" destId="{3A28AFDA-3EA5-44DA-8B31-E28E1201469C}" srcOrd="7" destOrd="0" presId="urn:microsoft.com/office/officeart/2005/8/layout/default"/>
-    <dgm:cxn modelId="{7943600E-78A6-40A8-8F83-84222A07F3AA}" type="presParOf" srcId="{4964C97D-336D-4286-8217-8E1FB6AED3FF}" destId="{E1A1B507-79E9-4472-8FBC-379558576FEC}" srcOrd="8" destOrd="0" presId="urn:microsoft.com/office/officeart/2005/8/layout/default"/>
-    <dgm:cxn modelId="{00562C77-A9CF-47F1-9DD7-39741E0F20CB}" type="presParOf" srcId="{4964C97D-336D-4286-8217-8E1FB6AED3FF}" destId="{83E4C39D-ECF5-4C90-870B-BB3F1F2E3E9C}" srcOrd="9" destOrd="0" presId="urn:microsoft.com/office/officeart/2005/8/layout/default"/>
-    <dgm:cxn modelId="{6E90EE9D-9670-45B1-A55C-EFF922D9F96C}" type="presParOf" srcId="{4964C97D-336D-4286-8217-8E1FB6AED3FF}" destId="{A7447721-ED1A-49D0-A6E3-809B43652FFF}" srcOrd="10" destOrd="0" presId="urn:microsoft.com/office/officeart/2005/8/layout/default"/>
-    <dgm:cxn modelId="{3B0CBAA9-ECEB-46ED-8CF7-3B3E8DB9C455}" type="presParOf" srcId="{4964C97D-336D-4286-8217-8E1FB6AED3FF}" destId="{9D0D2638-4EE1-4E94-BE1B-92F8B9B184AD}" srcOrd="11" destOrd="0" presId="urn:microsoft.com/office/officeart/2005/8/layout/default"/>
-    <dgm:cxn modelId="{A17A6720-E8F5-43D7-A166-79921EB170BA}" type="presParOf" srcId="{4964C97D-336D-4286-8217-8E1FB6AED3FF}" destId="{272BBDD3-22E0-4B3B-B560-9152EBE6038B}" srcOrd="12" destOrd="0" presId="urn:microsoft.com/office/officeart/2005/8/layout/default"/>
-    <dgm:cxn modelId="{2CFE0F48-5B53-46D3-901D-F680D6E51597}" type="presParOf" srcId="{4964C97D-336D-4286-8217-8E1FB6AED3FF}" destId="{7D0CC747-39C7-4262-959A-72385B156AC6}" srcOrd="13" destOrd="0" presId="urn:microsoft.com/office/officeart/2005/8/layout/default"/>
-    <dgm:cxn modelId="{E6E884B6-5E9C-409A-9408-F4AF9E45CE75}" type="presParOf" srcId="{4964C97D-336D-4286-8217-8E1FB6AED3FF}" destId="{C4DBC421-0D16-4716-AD59-2ACBF3AE62C0}" srcOrd="14" destOrd="0" presId="urn:microsoft.com/office/officeart/2005/8/layout/default"/>
-  </dgm:cxnLst>
-  <dgm:bg/>
-  <dgm:whole/>
-  <dgm:extLst>
-    <a:ext uri="http://schemas.microsoft.com/office/drawing/2008/diagram">
-      <dsp:dataModelExt xmlns:dsp="http://schemas.microsoft.com/office/drawing/2008/diagram" relId="rId6" minVer="http://schemas.openxmlformats.org/drawingml/2006/diagram"/>
-    </a:ext>
-  </dgm:extLst>
-</dgm:dataModel>
-</file>
-
-<file path=ppt/diagrams/data2.xml><?xml version="1.0" encoding="utf-8"?>
 <dgm:dataModel xmlns:dgm="http://schemas.openxmlformats.org/drawingml/2006/diagram" xmlns:a="http://schemas.openxmlformats.org/drawingml/2006/main">
   <dgm:ptLst>
     <dgm:pt modelId="{40C9FB0B-122F-4452-8093-5CEFD4BBB50A}" type="doc">
@@ -5088,7 +3764,7 @@
 </dgm:dataModel>
 </file>
 
-<file path=ppt/diagrams/data3.xml><?xml version="1.0" encoding="utf-8"?>
+<file path=ppt/diagrams/data2.xml><?xml version="1.0" encoding="utf-8"?>
 <dgm:dataModel xmlns:dgm="http://schemas.openxmlformats.org/drawingml/2006/diagram" xmlns:a="http://schemas.openxmlformats.org/drawingml/2006/main">
   <dgm:ptLst>
     <dgm:pt modelId="{3311DD0E-DFF5-419B-9978-21D0CCF33EB7}" type="doc">
@@ -5422,7 +4098,7 @@
 </dgm:dataModel>
 </file>
 
-<file path=ppt/diagrams/data4.xml><?xml version="1.0" encoding="utf-8"?>
+<file path=ppt/diagrams/data3.xml><?xml version="1.0" encoding="utf-8"?>
 <dgm:dataModel xmlns:dgm="http://schemas.openxmlformats.org/drawingml/2006/diagram" xmlns:a="http://schemas.openxmlformats.org/drawingml/2006/main">
   <dgm:ptLst>
     <dgm:pt modelId="{52F01361-C1E9-444F-BD14-3A74C517F71B}" type="doc">
@@ -6321,7 +4997,7 @@
 </dgm:dataModel>
 </file>
 
-<file path=ppt/diagrams/data5.xml><?xml version="1.0" encoding="utf-8"?>
+<file path=ppt/diagrams/data4.xml><?xml version="1.0" encoding="utf-8"?>
 <dgm:dataModel xmlns:dgm="http://schemas.openxmlformats.org/drawingml/2006/diagram" xmlns:a="http://schemas.openxmlformats.org/drawingml/2006/main">
   <dgm:ptLst>
     <dgm:pt modelId="{ECE029AC-0454-47D9-9938-15C3039DF6DC}" type="doc">
@@ -7133,634 +5809,6 @@
       <dsp:cNvGrpSpPr/>
     </dsp:nvGrpSpPr>
     <dsp:grpSpPr/>
-    <dsp:sp modelId="{C13BC9FE-150B-405B-AA42-9942A508A8EB}">
-      <dsp:nvSpPr>
-        <dsp:cNvPr id="0" name=""/>
-        <dsp:cNvSpPr/>
-      </dsp:nvSpPr>
-      <dsp:spPr>
-        <a:xfrm>
-          <a:off x="2955" y="207120"/>
-          <a:ext cx="2344753" cy="1406852"/>
-        </a:xfrm>
-        <a:prstGeom prst="roundRect">
-          <a:avLst/>
-        </a:prstGeom>
-        <a:solidFill>
-          <a:schemeClr val="accent1">
-            <a:hueOff val="0"/>
-            <a:satOff val="0"/>
-            <a:lumOff val="0"/>
-            <a:alphaOff val="0"/>
-          </a:schemeClr>
-        </a:solidFill>
-        <a:ln w="15875" cap="flat" cmpd="sng" algn="ctr">
-          <a:noFill/>
-          <a:prstDash val="solid"/>
-        </a:ln>
-        <a:effectLst>
-          <a:innerShdw blurRad="254000" dist="50800" dir="13500000">
-            <a:prstClr val="black">
-              <a:alpha val="27000"/>
-            </a:prstClr>
-          </a:innerShdw>
-          <a:reflection blurRad="25400" stA="49000" endPos="32000" dir="5400000" sy="-100000" algn="bl" rotWithShape="0"/>
-        </a:effectLst>
-      </dsp:spPr>
-      <dsp:style>
-        <a:lnRef idx="2">
-          <a:scrgbClr r="0" g="0" b="0"/>
-        </a:lnRef>
-        <a:fillRef idx="1">
-          <a:scrgbClr r="0" g="0" b="0"/>
-        </a:fillRef>
-        <a:effectRef idx="0">
-          <a:scrgbClr r="0" g="0" b="0"/>
-        </a:effectRef>
-        <a:fontRef idx="minor">
-          <a:schemeClr val="lt1"/>
-        </a:fontRef>
-      </dsp:style>
-      <dsp:txBody>
-        <a:bodyPr spcFirstLastPara="0" vert="horz" wrap="square" lIns="110490" tIns="110490" rIns="110490" bIns="110490" numCol="1" spcCol="1270" anchor="ctr" anchorCtr="0">
-          <a:noAutofit/>
-        </a:bodyPr>
-        <a:lstStyle/>
-        <a:p>
-          <a:pPr marL="0" lvl="0" indent="0" algn="ctr" defTabSz="1289050">
-            <a:lnSpc>
-              <a:spcPct val="90000"/>
-            </a:lnSpc>
-            <a:spcBef>
-              <a:spcPct val="0"/>
-            </a:spcBef>
-            <a:spcAft>
-              <a:spcPct val="35000"/>
-            </a:spcAft>
-            <a:buNone/>
-          </a:pPr>
-          <a:r>
-            <a:rPr lang="en-US" sz="2900" kern="1200" dirty="0"/>
-            <a:t>Introduction</a:t>
-          </a:r>
-        </a:p>
-      </dsp:txBody>
-      <dsp:txXfrm>
-        <a:off x="71632" y="275797"/>
-        <a:ext cx="2207399" cy="1269498"/>
-      </dsp:txXfrm>
-    </dsp:sp>
-    <dsp:sp modelId="{2D62EE5F-3CDD-4EED-8C71-9932C2AFCD18}">
-      <dsp:nvSpPr>
-        <dsp:cNvPr id="0" name=""/>
-        <dsp:cNvSpPr/>
-      </dsp:nvSpPr>
-      <dsp:spPr>
-        <a:xfrm>
-          <a:off x="2582184" y="207120"/>
-          <a:ext cx="2344753" cy="1406852"/>
-        </a:xfrm>
-        <a:prstGeom prst="roundRect">
-          <a:avLst/>
-        </a:prstGeom>
-        <a:solidFill>
-          <a:schemeClr val="accent1">
-            <a:hueOff val="0"/>
-            <a:satOff val="0"/>
-            <a:lumOff val="0"/>
-            <a:alphaOff val="0"/>
-          </a:schemeClr>
-        </a:solidFill>
-        <a:ln w="15875" cap="flat" cmpd="sng" algn="ctr">
-          <a:noFill/>
-          <a:prstDash val="solid"/>
-        </a:ln>
-        <a:effectLst>
-          <a:innerShdw blurRad="254000" dist="50800" dir="13500000">
-            <a:prstClr val="black">
-              <a:alpha val="27000"/>
-            </a:prstClr>
-          </a:innerShdw>
-          <a:reflection blurRad="25400" stA="49000" endPos="32000" dir="5400000" sy="-100000" algn="bl" rotWithShape="0"/>
-        </a:effectLst>
-      </dsp:spPr>
-      <dsp:style>
-        <a:lnRef idx="2">
-          <a:scrgbClr r="0" g="0" b="0"/>
-        </a:lnRef>
-        <a:fillRef idx="1">
-          <a:scrgbClr r="0" g="0" b="0"/>
-        </a:fillRef>
-        <a:effectRef idx="0">
-          <a:scrgbClr r="0" g="0" b="0"/>
-        </a:effectRef>
-        <a:fontRef idx="minor">
-          <a:schemeClr val="lt1"/>
-        </a:fontRef>
-      </dsp:style>
-      <dsp:txBody>
-        <a:bodyPr spcFirstLastPara="0" vert="horz" wrap="square" lIns="110490" tIns="110490" rIns="110490" bIns="110490" numCol="1" spcCol="1270" anchor="ctr" anchorCtr="0">
-          <a:noAutofit/>
-        </a:bodyPr>
-        <a:lstStyle/>
-        <a:p>
-          <a:pPr marL="0" lvl="0" indent="0" algn="ctr" defTabSz="1289050">
-            <a:lnSpc>
-              <a:spcPct val="90000"/>
-            </a:lnSpc>
-            <a:spcBef>
-              <a:spcPct val="0"/>
-            </a:spcBef>
-            <a:spcAft>
-              <a:spcPct val="35000"/>
-            </a:spcAft>
-            <a:buNone/>
-          </a:pPr>
-          <a:r>
-            <a:rPr lang="en-US" sz="2900" kern="1200" dirty="0"/>
-            <a:t>Project aims </a:t>
-          </a:r>
-        </a:p>
-      </dsp:txBody>
-      <dsp:txXfrm>
-        <a:off x="2650861" y="275797"/>
-        <a:ext cx="2207399" cy="1269498"/>
-      </dsp:txXfrm>
-    </dsp:sp>
-    <dsp:sp modelId="{CFC0049C-4AC3-4ED4-9B3A-75F5CC3D9CE0}">
-      <dsp:nvSpPr>
-        <dsp:cNvPr id="0" name=""/>
-        <dsp:cNvSpPr/>
-      </dsp:nvSpPr>
-      <dsp:spPr>
-        <a:xfrm>
-          <a:off x="5161414" y="207120"/>
-          <a:ext cx="2344753" cy="1406852"/>
-        </a:xfrm>
-        <a:prstGeom prst="roundRect">
-          <a:avLst/>
-        </a:prstGeom>
-        <a:solidFill>
-          <a:schemeClr val="accent1">
-            <a:hueOff val="0"/>
-            <a:satOff val="0"/>
-            <a:lumOff val="0"/>
-            <a:alphaOff val="0"/>
-          </a:schemeClr>
-        </a:solidFill>
-        <a:ln w="15875" cap="flat" cmpd="sng" algn="ctr">
-          <a:noFill/>
-          <a:prstDash val="solid"/>
-        </a:ln>
-        <a:effectLst>
-          <a:innerShdw blurRad="254000" dist="50800" dir="13500000">
-            <a:prstClr val="black">
-              <a:alpha val="27000"/>
-            </a:prstClr>
-          </a:innerShdw>
-          <a:reflection blurRad="25400" stA="49000" endPos="32000" dir="5400000" sy="-100000" algn="bl" rotWithShape="0"/>
-        </a:effectLst>
-      </dsp:spPr>
-      <dsp:style>
-        <a:lnRef idx="2">
-          <a:scrgbClr r="0" g="0" b="0"/>
-        </a:lnRef>
-        <a:fillRef idx="1">
-          <a:scrgbClr r="0" g="0" b="0"/>
-        </a:fillRef>
-        <a:effectRef idx="0">
-          <a:scrgbClr r="0" g="0" b="0"/>
-        </a:effectRef>
-        <a:fontRef idx="minor">
-          <a:schemeClr val="lt1"/>
-        </a:fontRef>
-      </dsp:style>
-      <dsp:txBody>
-        <a:bodyPr spcFirstLastPara="0" vert="horz" wrap="square" lIns="110490" tIns="110490" rIns="110490" bIns="110490" numCol="1" spcCol="1270" anchor="ctr" anchorCtr="0">
-          <a:noAutofit/>
-        </a:bodyPr>
-        <a:lstStyle/>
-        <a:p>
-          <a:pPr marL="0" lvl="0" indent="0" algn="ctr" defTabSz="1289050">
-            <a:lnSpc>
-              <a:spcPct val="90000"/>
-            </a:lnSpc>
-            <a:spcBef>
-              <a:spcPct val="0"/>
-            </a:spcBef>
-            <a:spcAft>
-              <a:spcPct val="35000"/>
-            </a:spcAft>
-            <a:buNone/>
-          </a:pPr>
-          <a:r>
-            <a:rPr lang="en-US" sz="2900" kern="1200" dirty="0"/>
-            <a:t>Research findings</a:t>
-          </a:r>
-        </a:p>
-      </dsp:txBody>
-      <dsp:txXfrm>
-        <a:off x="5230091" y="275797"/>
-        <a:ext cx="2207399" cy="1269498"/>
-      </dsp:txXfrm>
-    </dsp:sp>
-    <dsp:sp modelId="{C0336292-3D01-4662-AF09-5047347BD433}">
-      <dsp:nvSpPr>
-        <dsp:cNvPr id="0" name=""/>
-        <dsp:cNvSpPr/>
-      </dsp:nvSpPr>
-      <dsp:spPr>
-        <a:xfrm>
-          <a:off x="7740643" y="207120"/>
-          <a:ext cx="2344753" cy="1406852"/>
-        </a:xfrm>
-        <a:prstGeom prst="roundRect">
-          <a:avLst/>
-        </a:prstGeom>
-        <a:solidFill>
-          <a:schemeClr val="accent1">
-            <a:hueOff val="0"/>
-            <a:satOff val="0"/>
-            <a:lumOff val="0"/>
-            <a:alphaOff val="0"/>
-          </a:schemeClr>
-        </a:solidFill>
-        <a:ln w="15875" cap="flat" cmpd="sng" algn="ctr">
-          <a:noFill/>
-          <a:prstDash val="solid"/>
-        </a:ln>
-        <a:effectLst>
-          <a:innerShdw blurRad="254000" dist="50800" dir="13500000">
-            <a:prstClr val="black">
-              <a:alpha val="27000"/>
-            </a:prstClr>
-          </a:innerShdw>
-          <a:reflection blurRad="25400" stA="49000" endPos="32000" dir="5400000" sy="-100000" algn="bl" rotWithShape="0"/>
-        </a:effectLst>
-      </dsp:spPr>
-      <dsp:style>
-        <a:lnRef idx="2">
-          <a:scrgbClr r="0" g="0" b="0"/>
-        </a:lnRef>
-        <a:fillRef idx="1">
-          <a:scrgbClr r="0" g="0" b="0"/>
-        </a:fillRef>
-        <a:effectRef idx="0">
-          <a:scrgbClr r="0" g="0" b="0"/>
-        </a:effectRef>
-        <a:fontRef idx="minor">
-          <a:schemeClr val="lt1"/>
-        </a:fontRef>
-      </dsp:style>
-      <dsp:txBody>
-        <a:bodyPr spcFirstLastPara="0" vert="horz" wrap="square" lIns="110490" tIns="110490" rIns="110490" bIns="110490" numCol="1" spcCol="1270" anchor="ctr" anchorCtr="0">
-          <a:noAutofit/>
-        </a:bodyPr>
-        <a:lstStyle/>
-        <a:p>
-          <a:pPr marL="0" lvl="0" indent="0" algn="ctr" defTabSz="1289050">
-            <a:lnSpc>
-              <a:spcPct val="90000"/>
-            </a:lnSpc>
-            <a:spcBef>
-              <a:spcPct val="0"/>
-            </a:spcBef>
-            <a:spcAft>
-              <a:spcPct val="35000"/>
-            </a:spcAft>
-            <a:buNone/>
-          </a:pPr>
-          <a:r>
-            <a:rPr lang="en-US" sz="2900" kern="1200" dirty="0"/>
-            <a:t>Suggested solution</a:t>
-          </a:r>
-        </a:p>
-      </dsp:txBody>
-      <dsp:txXfrm>
-        <a:off x="7809320" y="275797"/>
-        <a:ext cx="2207399" cy="1269498"/>
-      </dsp:txXfrm>
-    </dsp:sp>
-    <dsp:sp modelId="{E1A1B507-79E9-4472-8FBC-379558576FEC}">
-      <dsp:nvSpPr>
-        <dsp:cNvPr id="0" name=""/>
-        <dsp:cNvSpPr/>
-      </dsp:nvSpPr>
-      <dsp:spPr>
-        <a:xfrm>
-          <a:off x="2955" y="1848448"/>
-          <a:ext cx="2344753" cy="1406852"/>
-        </a:xfrm>
-        <a:prstGeom prst="roundRect">
-          <a:avLst/>
-        </a:prstGeom>
-        <a:solidFill>
-          <a:schemeClr val="accent1">
-            <a:hueOff val="0"/>
-            <a:satOff val="0"/>
-            <a:lumOff val="0"/>
-            <a:alphaOff val="0"/>
-          </a:schemeClr>
-        </a:solidFill>
-        <a:ln w="15875" cap="flat" cmpd="sng" algn="ctr">
-          <a:noFill/>
-          <a:prstDash val="solid"/>
-        </a:ln>
-        <a:effectLst>
-          <a:innerShdw blurRad="254000" dist="50800" dir="13500000">
-            <a:prstClr val="black">
-              <a:alpha val="27000"/>
-            </a:prstClr>
-          </a:innerShdw>
-          <a:reflection blurRad="25400" stA="49000" endPos="32000" dir="5400000" sy="-100000" algn="bl" rotWithShape="0"/>
-        </a:effectLst>
-      </dsp:spPr>
-      <dsp:style>
-        <a:lnRef idx="2">
-          <a:scrgbClr r="0" g="0" b="0"/>
-        </a:lnRef>
-        <a:fillRef idx="1">
-          <a:scrgbClr r="0" g="0" b="0"/>
-        </a:fillRef>
-        <a:effectRef idx="0">
-          <a:scrgbClr r="0" g="0" b="0"/>
-        </a:effectRef>
-        <a:fontRef idx="minor">
-          <a:schemeClr val="lt1"/>
-        </a:fontRef>
-      </dsp:style>
-      <dsp:txBody>
-        <a:bodyPr spcFirstLastPara="0" vert="horz" wrap="square" lIns="110490" tIns="110490" rIns="110490" bIns="110490" numCol="1" spcCol="1270" anchor="ctr" anchorCtr="0">
-          <a:noAutofit/>
-        </a:bodyPr>
-        <a:lstStyle/>
-        <a:p>
-          <a:pPr marL="0" lvl="0" indent="0" algn="ctr" defTabSz="1289050">
-            <a:lnSpc>
-              <a:spcPct val="90000"/>
-            </a:lnSpc>
-            <a:spcBef>
-              <a:spcPct val="0"/>
-            </a:spcBef>
-            <a:spcAft>
-              <a:spcPct val="35000"/>
-            </a:spcAft>
-            <a:buNone/>
-          </a:pPr>
-          <a:r>
-            <a:rPr lang="en-US" sz="2900" kern="1200"/>
-            <a:t>Targeted users</a:t>
-          </a:r>
-        </a:p>
-      </dsp:txBody>
-      <dsp:txXfrm>
-        <a:off x="71632" y="1917125"/>
-        <a:ext cx="2207399" cy="1269498"/>
-      </dsp:txXfrm>
-    </dsp:sp>
-    <dsp:sp modelId="{A7447721-ED1A-49D0-A6E3-809B43652FFF}">
-      <dsp:nvSpPr>
-        <dsp:cNvPr id="0" name=""/>
-        <dsp:cNvSpPr/>
-      </dsp:nvSpPr>
-      <dsp:spPr>
-        <a:xfrm>
-          <a:off x="2582184" y="1848448"/>
-          <a:ext cx="2344753" cy="1406852"/>
-        </a:xfrm>
-        <a:prstGeom prst="roundRect">
-          <a:avLst/>
-        </a:prstGeom>
-        <a:solidFill>
-          <a:schemeClr val="accent1">
-            <a:hueOff val="0"/>
-            <a:satOff val="0"/>
-            <a:lumOff val="0"/>
-            <a:alphaOff val="0"/>
-          </a:schemeClr>
-        </a:solidFill>
-        <a:ln w="15875" cap="flat" cmpd="sng" algn="ctr">
-          <a:noFill/>
-          <a:prstDash val="solid"/>
-        </a:ln>
-        <a:effectLst>
-          <a:innerShdw blurRad="254000" dist="50800" dir="13500000">
-            <a:prstClr val="black">
-              <a:alpha val="27000"/>
-            </a:prstClr>
-          </a:innerShdw>
-          <a:reflection blurRad="25400" stA="49000" endPos="32000" dir="5400000" sy="-100000" algn="bl" rotWithShape="0"/>
-        </a:effectLst>
-      </dsp:spPr>
-      <dsp:style>
-        <a:lnRef idx="2">
-          <a:scrgbClr r="0" g="0" b="0"/>
-        </a:lnRef>
-        <a:fillRef idx="1">
-          <a:scrgbClr r="0" g="0" b="0"/>
-        </a:fillRef>
-        <a:effectRef idx="0">
-          <a:scrgbClr r="0" g="0" b="0"/>
-        </a:effectRef>
-        <a:fontRef idx="minor">
-          <a:schemeClr val="lt1"/>
-        </a:fontRef>
-      </dsp:style>
-      <dsp:txBody>
-        <a:bodyPr spcFirstLastPara="0" vert="horz" wrap="square" lIns="110490" tIns="110490" rIns="110490" bIns="110490" numCol="1" spcCol="1270" anchor="ctr" anchorCtr="0">
-          <a:noAutofit/>
-        </a:bodyPr>
-        <a:lstStyle/>
-        <a:p>
-          <a:pPr marL="0" lvl="0" indent="0" algn="ctr" defTabSz="1289050">
-            <a:lnSpc>
-              <a:spcPct val="90000"/>
-            </a:lnSpc>
-            <a:spcBef>
-              <a:spcPct val="0"/>
-            </a:spcBef>
-            <a:spcAft>
-              <a:spcPct val="35000"/>
-            </a:spcAft>
-            <a:buNone/>
-          </a:pPr>
-          <a:r>
-            <a:rPr lang="en-US" sz="2900" kern="1200"/>
-            <a:t>Requirements and Analysis </a:t>
-          </a:r>
-        </a:p>
-      </dsp:txBody>
-      <dsp:txXfrm>
-        <a:off x="2650861" y="1917125"/>
-        <a:ext cx="2207399" cy="1269498"/>
-      </dsp:txXfrm>
-    </dsp:sp>
-    <dsp:sp modelId="{272BBDD3-22E0-4B3B-B560-9152EBE6038B}">
-      <dsp:nvSpPr>
-        <dsp:cNvPr id="0" name=""/>
-        <dsp:cNvSpPr/>
-      </dsp:nvSpPr>
-      <dsp:spPr>
-        <a:xfrm>
-          <a:off x="5161414" y="1848448"/>
-          <a:ext cx="2344753" cy="1406852"/>
-        </a:xfrm>
-        <a:prstGeom prst="roundRect">
-          <a:avLst/>
-        </a:prstGeom>
-        <a:solidFill>
-          <a:schemeClr val="accent1">
-            <a:hueOff val="0"/>
-            <a:satOff val="0"/>
-            <a:lumOff val="0"/>
-            <a:alphaOff val="0"/>
-          </a:schemeClr>
-        </a:solidFill>
-        <a:ln w="15875" cap="flat" cmpd="sng" algn="ctr">
-          <a:noFill/>
-          <a:prstDash val="solid"/>
-        </a:ln>
-        <a:effectLst>
-          <a:innerShdw blurRad="254000" dist="50800" dir="13500000">
-            <a:prstClr val="black">
-              <a:alpha val="27000"/>
-            </a:prstClr>
-          </a:innerShdw>
-          <a:reflection blurRad="25400" stA="49000" endPos="32000" dir="5400000" sy="-100000" algn="bl" rotWithShape="0"/>
-        </a:effectLst>
-      </dsp:spPr>
-      <dsp:style>
-        <a:lnRef idx="2">
-          <a:scrgbClr r="0" g="0" b="0"/>
-        </a:lnRef>
-        <a:fillRef idx="1">
-          <a:scrgbClr r="0" g="0" b="0"/>
-        </a:fillRef>
-        <a:effectRef idx="0">
-          <a:scrgbClr r="0" g="0" b="0"/>
-        </a:effectRef>
-        <a:fontRef idx="minor">
-          <a:schemeClr val="lt1"/>
-        </a:fontRef>
-      </dsp:style>
-      <dsp:txBody>
-        <a:bodyPr spcFirstLastPara="0" vert="horz" wrap="square" lIns="110490" tIns="110490" rIns="110490" bIns="110490" numCol="1" spcCol="1270" anchor="ctr" anchorCtr="0">
-          <a:noAutofit/>
-        </a:bodyPr>
-        <a:lstStyle/>
-        <a:p>
-          <a:pPr marL="0" lvl="0" indent="0" algn="ctr" defTabSz="1289050">
-            <a:lnSpc>
-              <a:spcPct val="90000"/>
-            </a:lnSpc>
-            <a:spcBef>
-              <a:spcPct val="0"/>
-            </a:spcBef>
-            <a:spcAft>
-              <a:spcPct val="35000"/>
-            </a:spcAft>
-            <a:buNone/>
-          </a:pPr>
-          <a:r>
-            <a:rPr lang="en-US" sz="2900" kern="1200"/>
-            <a:t>System design</a:t>
-          </a:r>
-        </a:p>
-      </dsp:txBody>
-      <dsp:txXfrm>
-        <a:off x="5230091" y="1917125"/>
-        <a:ext cx="2207399" cy="1269498"/>
-      </dsp:txXfrm>
-    </dsp:sp>
-    <dsp:sp modelId="{C4DBC421-0D16-4716-AD59-2ACBF3AE62C0}">
-      <dsp:nvSpPr>
-        <dsp:cNvPr id="0" name=""/>
-        <dsp:cNvSpPr/>
-      </dsp:nvSpPr>
-      <dsp:spPr>
-        <a:xfrm>
-          <a:off x="7740643" y="1848448"/>
-          <a:ext cx="2344753" cy="1406852"/>
-        </a:xfrm>
-        <a:prstGeom prst="roundRect">
-          <a:avLst/>
-        </a:prstGeom>
-        <a:solidFill>
-          <a:schemeClr val="accent1">
-            <a:hueOff val="0"/>
-            <a:satOff val="0"/>
-            <a:lumOff val="0"/>
-            <a:alphaOff val="0"/>
-          </a:schemeClr>
-        </a:solidFill>
-        <a:ln w="15875" cap="flat" cmpd="sng" algn="ctr">
-          <a:noFill/>
-          <a:prstDash val="solid"/>
-        </a:ln>
-        <a:effectLst>
-          <a:innerShdw blurRad="254000" dist="50800" dir="13500000">
-            <a:prstClr val="black">
-              <a:alpha val="27000"/>
-            </a:prstClr>
-          </a:innerShdw>
-          <a:reflection blurRad="25400" stA="49000" endPos="32000" dir="5400000" sy="-100000" algn="bl" rotWithShape="0"/>
-        </a:effectLst>
-      </dsp:spPr>
-      <dsp:style>
-        <a:lnRef idx="2">
-          <a:scrgbClr r="0" g="0" b="0"/>
-        </a:lnRef>
-        <a:fillRef idx="1">
-          <a:scrgbClr r="0" g="0" b="0"/>
-        </a:fillRef>
-        <a:effectRef idx="0">
-          <a:scrgbClr r="0" g="0" b="0"/>
-        </a:effectRef>
-        <a:fontRef idx="minor">
-          <a:schemeClr val="lt1"/>
-        </a:fontRef>
-      </dsp:style>
-      <dsp:txBody>
-        <a:bodyPr spcFirstLastPara="0" vert="horz" wrap="square" lIns="110490" tIns="110490" rIns="110490" bIns="110490" numCol="1" spcCol="1270" anchor="ctr" anchorCtr="0">
-          <a:noAutofit/>
-        </a:bodyPr>
-        <a:lstStyle/>
-        <a:p>
-          <a:pPr marL="0" lvl="0" indent="0" algn="ctr" defTabSz="1289050">
-            <a:lnSpc>
-              <a:spcPct val="90000"/>
-            </a:lnSpc>
-            <a:spcBef>
-              <a:spcPct val="0"/>
-            </a:spcBef>
-            <a:spcAft>
-              <a:spcPct val="35000"/>
-            </a:spcAft>
-            <a:buNone/>
-          </a:pPr>
-          <a:r>
-            <a:rPr lang="en-US" sz="2900" kern="1200" dirty="0"/>
-            <a:t>User Interface</a:t>
-          </a:r>
-        </a:p>
-      </dsp:txBody>
-      <dsp:txXfrm>
-        <a:off x="7809320" y="1917125"/>
-        <a:ext cx="2207399" cy="1269498"/>
-      </dsp:txXfrm>
-    </dsp:sp>
-  </dsp:spTree>
-</dsp:drawing>
-</file>
-
-<file path=ppt/diagrams/drawing2.xml><?xml version="1.0" encoding="utf-8"?>
-<dsp:drawing xmlns:dgm="http://schemas.openxmlformats.org/drawingml/2006/diagram" xmlns:dsp="http://schemas.microsoft.com/office/drawing/2008/diagram" xmlns:a="http://schemas.openxmlformats.org/drawingml/2006/main">
-  <dsp:spTree>
-    <dsp:nvGrpSpPr>
-      <dsp:cNvPr id="0" name=""/>
-      <dsp:cNvGrpSpPr/>
-    </dsp:nvGrpSpPr>
-    <dsp:grpSpPr/>
     <dsp:sp modelId="{85916DE6-D00D-4E2A-A130-412E29E9E992}">
       <dsp:nvSpPr>
         <dsp:cNvPr id="0" name=""/>
@@ -8343,7 +6391,7 @@
 </dsp:drawing>
 </file>
 
-<file path=ppt/diagrams/drawing3.xml><?xml version="1.0" encoding="utf-8"?>
+<file path=ppt/diagrams/drawing2.xml><?xml version="1.0" encoding="utf-8"?>
 <dsp:drawing xmlns:dgm="http://schemas.openxmlformats.org/drawingml/2006/diagram" xmlns:dsp="http://schemas.microsoft.com/office/drawing/2008/diagram" xmlns:a="http://schemas.openxmlformats.org/drawingml/2006/main">
   <dsp:spTree>
     <dsp:nvGrpSpPr>
@@ -8693,7 +6741,7 @@
 </dsp:drawing>
 </file>
 
-<file path=ppt/diagrams/drawing4.xml><?xml version="1.0" encoding="utf-8"?>
+<file path=ppt/diagrams/drawing3.xml><?xml version="1.0" encoding="utf-8"?>
 <dsp:drawing xmlns:dgm="http://schemas.openxmlformats.org/drawingml/2006/diagram" xmlns:dsp="http://schemas.microsoft.com/office/drawing/2008/diagram" xmlns:a="http://schemas.openxmlformats.org/drawingml/2006/main">
   <dsp:spTree>
     <dsp:nvGrpSpPr>
@@ -9710,7 +7758,7 @@
 </dsp:drawing>
 </file>
 
-<file path=ppt/diagrams/drawing5.xml><?xml version="1.0" encoding="utf-8"?>
+<file path=ppt/diagrams/drawing4.xml><?xml version="1.0" encoding="utf-8"?>
 <dsp:drawing xmlns:dgm="http://schemas.openxmlformats.org/drawingml/2006/diagram" xmlns:dsp="http://schemas.microsoft.com/office/drawing/2008/diagram" xmlns:a="http://schemas.openxmlformats.org/drawingml/2006/main">
   <dsp:spTree>
     <dsp:nvGrpSpPr>
@@ -10591,153 +8639,6 @@
 </file>
 
 <file path=ppt/diagrams/layout1.xml><?xml version="1.0" encoding="utf-8"?>
-<dgm:layoutDef xmlns:dgm="http://schemas.openxmlformats.org/drawingml/2006/diagram" xmlns:a="http://schemas.openxmlformats.org/drawingml/2006/main" uniqueId="urn:microsoft.com/office/officeart/2005/8/layout/default">
-  <dgm:title val=""/>
-  <dgm:desc val=""/>
-  <dgm:catLst>
-    <dgm:cat type="list" pri="400"/>
-  </dgm:catLst>
-  <dgm:sampData>
-    <dgm:dataModel>
-      <dgm:ptLst>
-        <dgm:pt modelId="0" type="doc"/>
-        <dgm:pt modelId="1">
-          <dgm:prSet phldr="1"/>
-        </dgm:pt>
-        <dgm:pt modelId="2">
-          <dgm:prSet phldr="1"/>
-        </dgm:pt>
-        <dgm:pt modelId="3">
-          <dgm:prSet phldr="1"/>
-        </dgm:pt>
-        <dgm:pt modelId="4">
-          <dgm:prSet phldr="1"/>
-        </dgm:pt>
-        <dgm:pt modelId="5">
-          <dgm:prSet phldr="1"/>
-        </dgm:pt>
-      </dgm:ptLst>
-      <dgm:cxnLst>
-        <dgm:cxn modelId="6" srcId="0" destId="1" srcOrd="0" destOrd="0"/>
-        <dgm:cxn modelId="7" srcId="0" destId="2" srcOrd="1" destOrd="0"/>
-        <dgm:cxn modelId="8" srcId="0" destId="3" srcOrd="2" destOrd="0"/>
-        <dgm:cxn modelId="9" srcId="0" destId="4" srcOrd="3" destOrd="0"/>
-        <dgm:cxn modelId="10" srcId="0" destId="5" srcOrd="4" destOrd="0"/>
-      </dgm:cxnLst>
-      <dgm:bg/>
-      <dgm:whole/>
-    </dgm:dataModel>
-  </dgm:sampData>
-  <dgm:styleData>
-    <dgm:dataModel>
-      <dgm:ptLst>
-        <dgm:pt modelId="0" type="doc"/>
-        <dgm:pt modelId="1"/>
-        <dgm:pt modelId="2"/>
-      </dgm:ptLst>
-      <dgm:cxnLst>
-        <dgm:cxn modelId="3" srcId="0" destId="1" srcOrd="0" destOrd="0"/>
-        <dgm:cxn modelId="4" srcId="0" destId="2" srcOrd="1" destOrd="0"/>
-      </dgm:cxnLst>
-      <dgm:bg/>
-      <dgm:whole/>
-    </dgm:dataModel>
-  </dgm:styleData>
-  <dgm:clrData>
-    <dgm:dataModel>
-      <dgm:ptLst>
-        <dgm:pt modelId="0" type="doc"/>
-        <dgm:pt modelId="1"/>
-        <dgm:pt modelId="2"/>
-        <dgm:pt modelId="3"/>
-        <dgm:pt modelId="4"/>
-        <dgm:pt modelId="5"/>
-        <dgm:pt modelId="6"/>
-      </dgm:ptLst>
-      <dgm:cxnLst>
-        <dgm:cxn modelId="7" srcId="0" destId="1" srcOrd="0" destOrd="0"/>
-        <dgm:cxn modelId="8" srcId="0" destId="2" srcOrd="1" destOrd="0"/>
-        <dgm:cxn modelId="9" srcId="0" destId="3" srcOrd="2" destOrd="0"/>
-        <dgm:cxn modelId="10" srcId="0" destId="4" srcOrd="3" destOrd="0"/>
-        <dgm:cxn modelId="11" srcId="0" destId="5" srcOrd="4" destOrd="0"/>
-        <dgm:cxn modelId="12" srcId="0" destId="6" srcOrd="5" destOrd="0"/>
-      </dgm:cxnLst>
-      <dgm:bg/>
-      <dgm:whole/>
-    </dgm:dataModel>
-  </dgm:clrData>
-  <dgm:layoutNode name="diagram">
-    <dgm:varLst>
-      <dgm:dir/>
-      <dgm:resizeHandles val="exact"/>
-    </dgm:varLst>
-    <dgm:choose name="Name0">
-      <dgm:if name="Name1" func="var" arg="dir" op="equ" val="norm">
-        <dgm:alg type="snake">
-          <dgm:param type="grDir" val="tL"/>
-          <dgm:param type="flowDir" val="row"/>
-          <dgm:param type="contDir" val="sameDir"/>
-          <dgm:param type="off" val="ctr"/>
-        </dgm:alg>
-      </dgm:if>
-      <dgm:else name="Name2">
-        <dgm:alg type="snake">
-          <dgm:param type="grDir" val="tR"/>
-          <dgm:param type="flowDir" val="row"/>
-          <dgm:param type="contDir" val="sameDir"/>
-          <dgm:param type="off" val="ctr"/>
-        </dgm:alg>
-      </dgm:else>
-    </dgm:choose>
-    <dgm:shape xmlns:r="http://schemas.openxmlformats.org/officeDocument/2006/relationships" r:blip="">
-      <dgm:adjLst/>
-    </dgm:shape>
-    <dgm:presOf/>
-    <dgm:constrLst>
-      <dgm:constr type="w" for="ch" forName="node" refType="w"/>
-      <dgm:constr type="h" for="ch" forName="node" refType="w" refFor="ch" refForName="node" fact="0.6"/>
-      <dgm:constr type="w" for="ch" forName="sibTrans" refType="w" refFor="ch" refForName="node" fact="0.1"/>
-      <dgm:constr type="sp" refType="w" refFor="ch" refForName="sibTrans"/>
-      <dgm:constr type="primFontSz" for="ch" forName="node" op="equ" val="65"/>
-    </dgm:constrLst>
-    <dgm:ruleLst/>
-    <dgm:forEach name="Name3" axis="ch" ptType="node">
-      <dgm:layoutNode name="node">
-        <dgm:varLst>
-          <dgm:bulletEnabled val="1"/>
-        </dgm:varLst>
-        <dgm:alg type="tx"/>
-        <dgm:shape xmlns:r="http://schemas.openxmlformats.org/officeDocument/2006/relationships" type="rect" r:blip="">
-          <dgm:adjLst/>
-        </dgm:shape>
-        <dgm:presOf axis="desOrSelf" ptType="node"/>
-        <dgm:constrLst>
-          <dgm:constr type="lMarg" refType="primFontSz" fact="0.3"/>
-          <dgm:constr type="rMarg" refType="primFontSz" fact="0.3"/>
-          <dgm:constr type="tMarg" refType="primFontSz" fact="0.3"/>
-          <dgm:constr type="bMarg" refType="primFontSz" fact="0.3"/>
-        </dgm:constrLst>
-        <dgm:ruleLst>
-          <dgm:rule type="primFontSz" val="5" fact="NaN" max="NaN"/>
-        </dgm:ruleLst>
-      </dgm:layoutNode>
-      <dgm:forEach name="Name4" axis="followSib" ptType="sibTrans" cnt="1">
-        <dgm:layoutNode name="sibTrans">
-          <dgm:alg type="sp"/>
-          <dgm:shape xmlns:r="http://schemas.openxmlformats.org/officeDocument/2006/relationships" r:blip="">
-            <dgm:adjLst/>
-          </dgm:shape>
-          <dgm:presOf/>
-          <dgm:constrLst/>
-          <dgm:ruleLst/>
-        </dgm:layoutNode>
-      </dgm:forEach>
-    </dgm:forEach>
-  </dgm:layoutNode>
-</dgm:layoutDef>
-</file>
-
-<file path=ppt/diagrams/layout2.xml><?xml version="1.0" encoding="utf-8"?>
 <dgm:layoutDef xmlns:dgm="http://schemas.openxmlformats.org/drawingml/2006/diagram" xmlns:a="http://schemas.openxmlformats.org/drawingml/2006/main" uniqueId="urn:microsoft.com/office/officeart/2018/5/layout/CenteredIconLabelDescriptionList">
   <dgm:title val="Centered Icon Label Description List"/>
   <dgm:desc val="Use to show non-sequential or grouped chunks of information. The placeholder holds an icon or small picture, and corresponding text boxes show Level 1 and Level 2 text respectively. Works well for minimal Level 1 text accompanied by lengthier Level two text."/>
@@ -10932,6 +8833,196 @@
             <a:spcPct val="100000"/>
           </a:lnSpc>
         </a:lvl2pPr>
+      </dgm1612:lstStyle>
+    </a:ext>
+  </dgm:extLst>
+</dgm:layoutDef>
+</file>
+
+<file path=ppt/diagrams/layout2.xml><?xml version="1.0" encoding="utf-8"?>
+<dgm:layoutDef xmlns:dgm="http://schemas.openxmlformats.org/drawingml/2006/diagram" xmlns:a="http://schemas.openxmlformats.org/drawingml/2006/main" uniqueId="urn:microsoft.com/office/officeart/2018/2/layout/IconLabelList">
+  <dgm:title val="Icon Label List"/>
+  <dgm:desc val="Use to show non-sequential or grouped chunks of information accompanied by a related visuals. Works best with icons or small pictures with short text captions."/>
+  <dgm:catLst>
+    <dgm:cat type="icon" pri="500"/>
+  </dgm:catLst>
+  <dgm:sampData useDef="1">
+    <dgm:dataModel>
+      <dgm:ptLst/>
+      <dgm:bg/>
+      <dgm:whole/>
+    </dgm:dataModel>
+  </dgm:sampData>
+  <dgm:styleData useDef="1">
+    <dgm:dataModel>
+      <dgm:ptLst/>
+      <dgm:bg/>
+      <dgm:whole/>
+    </dgm:dataModel>
+  </dgm:styleData>
+  <dgm:clrData useDef="1">
+    <dgm:dataModel>
+      <dgm:ptLst/>
+      <dgm:bg/>
+      <dgm:whole/>
+    </dgm:dataModel>
+  </dgm:clrData>
+  <dgm:layoutNode name="root">
+    <dgm:varLst>
+      <dgm:dir/>
+      <dgm:resizeHandles val="exact"/>
+    </dgm:varLst>
+    <dgm:choose name="Name0">
+      <dgm:if name="Name1" axis="self" func="var" arg="dir" op="equ" val="norm">
+        <dgm:alg type="snake">
+          <dgm:param type="grDir" val="tL"/>
+          <dgm:param type="flowDir" val="row"/>
+          <dgm:param type="contDir" val="sameDir"/>
+          <dgm:param type="off" val="ctr"/>
+          <dgm:param type="vertAlign" val="mid"/>
+          <dgm:param type="horzAlign" val="ctr"/>
+        </dgm:alg>
+      </dgm:if>
+      <dgm:else name="Name2">
+        <dgm:alg type="snake">
+          <dgm:param type="grDir" val="tR"/>
+          <dgm:param type="flowDir" val="row"/>
+          <dgm:param type="contDir" val="sameDir"/>
+          <dgm:param type="off" val="ctr"/>
+          <dgm:param type="vertAlign" val="mid"/>
+          <dgm:param type="horzAlign" val="ctr"/>
+        </dgm:alg>
+      </dgm:else>
+    </dgm:choose>
+    <dgm:shape xmlns:r="http://schemas.openxmlformats.org/officeDocument/2006/relationships" r:blip="">
+      <dgm:adjLst/>
+    </dgm:shape>
+    <dgm:presOf/>
+    <dgm:choose name="Name3">
+      <dgm:if name="Name4" axis="ch" ptType="node" func="cnt" op="lte" val="2">
+        <dgm:constrLst>
+          <dgm:constr type="h" for="ch" forName="compNode" refType="h" fact="0.4"/>
+          <dgm:constr type="w" for="ch" forName="compNode" val="120"/>
+          <dgm:constr type="w" for="ch" forName="sibTrans" refType="w" refFor="ch" refForName="compNode" fact="0.175"/>
+          <dgm:constr type="sp" refType="w" refFor="ch" refForName="compNode" op="equ" fact="0.25"/>
+          <dgm:constr type="primFontSz" for="des" ptType="node" op="equ" val="50"/>
+          <dgm:constr type="h" for="des" forName="compNode" op="equ"/>
+          <dgm:constr type="h" for="des" forName="textRect" op="equ"/>
+        </dgm:constrLst>
+      </dgm:if>
+      <dgm:if name="Name5" axis="ch" ptType="node" func="cnt" op="lte" val="4">
+        <dgm:constrLst>
+          <dgm:constr type="h" for="ch" forName="compNode" refType="h" fact="0.4"/>
+          <dgm:constr type="w" for="ch" forName="compNode" refType="w"/>
+          <dgm:constr type="w" for="ch" forName="sibTrans" refType="w" refFor="ch" refForName="compNode" fact="0.175"/>
+          <dgm:constr type="sp" refType="w" refFor="ch" refForName="compNode" op="equ" fact="0.25"/>
+          <dgm:constr type="primFontSz" for="des" ptType="node" op="equ" val="36"/>
+          <dgm:constr type="h" for="des" forName="compNode" op="equ"/>
+          <dgm:constr type="h" for="des" forName="textRect" op="equ"/>
+        </dgm:constrLst>
+      </dgm:if>
+      <dgm:else name="Name6">
+        <dgm:constrLst>
+          <dgm:constr type="h" for="ch" forName="compNode" refType="h" fact="0.4"/>
+          <dgm:constr type="w" for="ch" forName="compNode" refType="w"/>
+          <dgm:constr type="w" for="ch" forName="sibTrans" refType="w" refFor="ch" refForName="compNode" fact="0.175"/>
+          <dgm:constr type="sp" refType="w" refFor="ch" refForName="compNode" op="equ" fact="0.25"/>
+          <dgm:constr type="primFontSz" for="des" ptType="node" op="equ" val="24"/>
+          <dgm:constr type="h" for="des" forName="compNode" op="equ"/>
+          <dgm:constr type="h" for="des" forName="textRect" op="equ"/>
+        </dgm:constrLst>
+      </dgm:else>
+    </dgm:choose>
+    <dgm:ruleLst>
+      <dgm:rule type="w" for="ch" forName="compNode" val="50" fact="NaN" max="NaN"/>
+    </dgm:ruleLst>
+    <dgm:forEach name="Name7" axis="ch" ptType="node">
+      <dgm:layoutNode name="compNode">
+        <dgm:alg type="composite"/>
+        <dgm:shape xmlns:r="http://schemas.openxmlformats.org/officeDocument/2006/relationships" r:blip="">
+          <dgm:adjLst/>
+        </dgm:shape>
+        <dgm:presOf axis="self"/>
+        <dgm:constrLst>
+          <dgm:constr type="w" for="ch" forName="iconRect" refType="w" fact="0.45"/>
+          <dgm:constr type="h" for="ch" forName="iconRect" refType="w" refFor="ch" refForName="iconRect"/>
+          <dgm:constr type="ctrX" for="ch" forName="iconRect" refType="w" fact="0.5"/>
+          <dgm:constr type="t" for="ch" forName="iconRect"/>
+          <dgm:constr type="h" for="ch" forName="spaceRect" refType="h" fact="0.15"/>
+          <dgm:constr type="w" for="ch" forName="spaceRect" refType="w"/>
+          <dgm:constr type="l" for="ch" forName="spaceRect"/>
+          <dgm:constr type="t" for="ch" forName="spaceRect" refType="b" refFor="ch" refForName="iconRect"/>
+          <dgm:constr type="h" for="ch" forName="textRect" val="20"/>
+          <dgm:constr type="w" for="ch" forName="textRect" refType="w"/>
+          <dgm:constr type="l" for="ch" forName="textRect"/>
+          <dgm:constr type="t" for="ch" forName="textRect" refType="b" refFor="ch" refForName="spaceRect"/>
+        </dgm:constrLst>
+        <dgm:ruleLst>
+          <dgm:rule type="h" val="INF" fact="NaN" max="NaN"/>
+        </dgm:ruleLst>
+        <dgm:layoutNode name="iconRect" styleLbl="node1">
+          <dgm:alg type="sp"/>
+          <dgm:shape xmlns:r="http://schemas.openxmlformats.org/officeDocument/2006/relationships" type="rect" r:blip="" blipPhldr="1">
+            <dgm:adjLst/>
+          </dgm:shape>
+          <dgm:presOf/>
+          <dgm:constrLst/>
+          <dgm:ruleLst/>
+        </dgm:layoutNode>
+        <dgm:layoutNode name="spaceRect">
+          <dgm:alg type="sp"/>
+          <dgm:shape xmlns:r="http://schemas.openxmlformats.org/officeDocument/2006/relationships" r:blip="">
+            <dgm:adjLst/>
+          </dgm:shape>
+          <dgm:presOf/>
+          <dgm:constrLst/>
+          <dgm:ruleLst/>
+        </dgm:layoutNode>
+        <dgm:layoutNode name="textRect" styleLbl="revTx">
+          <dgm:varLst>
+            <dgm:chMax val="1"/>
+            <dgm:chPref val="1"/>
+          </dgm:varLst>
+          <dgm:alg type="tx">
+            <dgm:param type="txAnchorVert" val="t"/>
+          </dgm:alg>
+          <dgm:shape xmlns:r="http://schemas.openxmlformats.org/officeDocument/2006/relationships" type="rect" r:blip="">
+            <dgm:adjLst/>
+          </dgm:shape>
+          <dgm:presOf axis="self" ptType="node"/>
+          <dgm:constrLst>
+            <dgm:constr type="lMarg"/>
+            <dgm:constr type="rMarg"/>
+            <dgm:constr type="tMarg"/>
+            <dgm:constr type="bMarg"/>
+          </dgm:constrLst>
+          <dgm:ruleLst>
+            <dgm:rule type="primFontSz" val="11" fact="NaN" max="NaN"/>
+            <dgm:rule type="h" val="INF" fact="NaN" max="NaN"/>
+          </dgm:ruleLst>
+        </dgm:layoutNode>
+      </dgm:layoutNode>
+      <dgm:forEach name="Name8" axis="followSib" ptType="sibTrans" cnt="1">
+        <dgm:layoutNode name="sibTrans">
+          <dgm:alg type="sp"/>
+          <dgm:shape xmlns:r="http://schemas.openxmlformats.org/officeDocument/2006/relationships" r:blip="">
+            <dgm:adjLst/>
+          </dgm:shape>
+          <dgm:presOf axis="self"/>
+          <dgm:constrLst/>
+          <dgm:ruleLst/>
+        </dgm:layoutNode>
+      </dgm:forEach>
+    </dgm:forEach>
+  </dgm:layoutNode>
+  <dgm:extLst>
+    <a:ext uri="{68A01E43-0DF5-4B5B-8FA6-DAF915123BFB}">
+      <dgm1612:lstStyle xmlns:dgm1612="http://schemas.microsoft.com/office/drawing/2016/12/diagram">
+        <a:lvl1pPr>
+          <a:lnSpc>
+            <a:spcPct val="100000"/>
+          </a:lnSpc>
+        </a:lvl1pPr>
       </dgm1612:lstStyle>
     </a:ext>
   </dgm:extLst>
@@ -11318,196 +9409,6 @@
 </dgm:layoutDef>
 </file>
 
-<file path=ppt/diagrams/layout5.xml><?xml version="1.0" encoding="utf-8"?>
-<dgm:layoutDef xmlns:dgm="http://schemas.openxmlformats.org/drawingml/2006/diagram" xmlns:a="http://schemas.openxmlformats.org/drawingml/2006/main" uniqueId="urn:microsoft.com/office/officeart/2018/2/layout/IconLabelList">
-  <dgm:title val="Icon Label List"/>
-  <dgm:desc val="Use to show non-sequential or grouped chunks of information accompanied by a related visuals. Works best with icons or small pictures with short text captions."/>
-  <dgm:catLst>
-    <dgm:cat type="icon" pri="500"/>
-  </dgm:catLst>
-  <dgm:sampData useDef="1">
-    <dgm:dataModel>
-      <dgm:ptLst/>
-      <dgm:bg/>
-      <dgm:whole/>
-    </dgm:dataModel>
-  </dgm:sampData>
-  <dgm:styleData useDef="1">
-    <dgm:dataModel>
-      <dgm:ptLst/>
-      <dgm:bg/>
-      <dgm:whole/>
-    </dgm:dataModel>
-  </dgm:styleData>
-  <dgm:clrData useDef="1">
-    <dgm:dataModel>
-      <dgm:ptLst/>
-      <dgm:bg/>
-      <dgm:whole/>
-    </dgm:dataModel>
-  </dgm:clrData>
-  <dgm:layoutNode name="root">
-    <dgm:varLst>
-      <dgm:dir/>
-      <dgm:resizeHandles val="exact"/>
-    </dgm:varLst>
-    <dgm:choose name="Name0">
-      <dgm:if name="Name1" axis="self" func="var" arg="dir" op="equ" val="norm">
-        <dgm:alg type="snake">
-          <dgm:param type="grDir" val="tL"/>
-          <dgm:param type="flowDir" val="row"/>
-          <dgm:param type="contDir" val="sameDir"/>
-          <dgm:param type="off" val="ctr"/>
-          <dgm:param type="vertAlign" val="mid"/>
-          <dgm:param type="horzAlign" val="ctr"/>
-        </dgm:alg>
-      </dgm:if>
-      <dgm:else name="Name2">
-        <dgm:alg type="snake">
-          <dgm:param type="grDir" val="tR"/>
-          <dgm:param type="flowDir" val="row"/>
-          <dgm:param type="contDir" val="sameDir"/>
-          <dgm:param type="off" val="ctr"/>
-          <dgm:param type="vertAlign" val="mid"/>
-          <dgm:param type="horzAlign" val="ctr"/>
-        </dgm:alg>
-      </dgm:else>
-    </dgm:choose>
-    <dgm:shape xmlns:r="http://schemas.openxmlformats.org/officeDocument/2006/relationships" r:blip="">
-      <dgm:adjLst/>
-    </dgm:shape>
-    <dgm:presOf/>
-    <dgm:choose name="Name3">
-      <dgm:if name="Name4" axis="ch" ptType="node" func="cnt" op="lte" val="2">
-        <dgm:constrLst>
-          <dgm:constr type="h" for="ch" forName="compNode" refType="h" fact="0.4"/>
-          <dgm:constr type="w" for="ch" forName="compNode" val="120"/>
-          <dgm:constr type="w" for="ch" forName="sibTrans" refType="w" refFor="ch" refForName="compNode" fact="0.175"/>
-          <dgm:constr type="sp" refType="w" refFor="ch" refForName="compNode" op="equ" fact="0.25"/>
-          <dgm:constr type="primFontSz" for="des" ptType="node" op="equ" val="50"/>
-          <dgm:constr type="h" for="des" forName="compNode" op="equ"/>
-          <dgm:constr type="h" for="des" forName="textRect" op="equ"/>
-        </dgm:constrLst>
-      </dgm:if>
-      <dgm:if name="Name5" axis="ch" ptType="node" func="cnt" op="lte" val="4">
-        <dgm:constrLst>
-          <dgm:constr type="h" for="ch" forName="compNode" refType="h" fact="0.4"/>
-          <dgm:constr type="w" for="ch" forName="compNode" refType="w"/>
-          <dgm:constr type="w" for="ch" forName="sibTrans" refType="w" refFor="ch" refForName="compNode" fact="0.175"/>
-          <dgm:constr type="sp" refType="w" refFor="ch" refForName="compNode" op="equ" fact="0.25"/>
-          <dgm:constr type="primFontSz" for="des" ptType="node" op="equ" val="36"/>
-          <dgm:constr type="h" for="des" forName="compNode" op="equ"/>
-          <dgm:constr type="h" for="des" forName="textRect" op="equ"/>
-        </dgm:constrLst>
-      </dgm:if>
-      <dgm:else name="Name6">
-        <dgm:constrLst>
-          <dgm:constr type="h" for="ch" forName="compNode" refType="h" fact="0.4"/>
-          <dgm:constr type="w" for="ch" forName="compNode" refType="w"/>
-          <dgm:constr type="w" for="ch" forName="sibTrans" refType="w" refFor="ch" refForName="compNode" fact="0.175"/>
-          <dgm:constr type="sp" refType="w" refFor="ch" refForName="compNode" op="equ" fact="0.25"/>
-          <dgm:constr type="primFontSz" for="des" ptType="node" op="equ" val="24"/>
-          <dgm:constr type="h" for="des" forName="compNode" op="equ"/>
-          <dgm:constr type="h" for="des" forName="textRect" op="equ"/>
-        </dgm:constrLst>
-      </dgm:else>
-    </dgm:choose>
-    <dgm:ruleLst>
-      <dgm:rule type="w" for="ch" forName="compNode" val="50" fact="NaN" max="NaN"/>
-    </dgm:ruleLst>
-    <dgm:forEach name="Name7" axis="ch" ptType="node">
-      <dgm:layoutNode name="compNode">
-        <dgm:alg type="composite"/>
-        <dgm:shape xmlns:r="http://schemas.openxmlformats.org/officeDocument/2006/relationships" r:blip="">
-          <dgm:adjLst/>
-        </dgm:shape>
-        <dgm:presOf axis="self"/>
-        <dgm:constrLst>
-          <dgm:constr type="w" for="ch" forName="iconRect" refType="w" fact="0.45"/>
-          <dgm:constr type="h" for="ch" forName="iconRect" refType="w" refFor="ch" refForName="iconRect"/>
-          <dgm:constr type="ctrX" for="ch" forName="iconRect" refType="w" fact="0.5"/>
-          <dgm:constr type="t" for="ch" forName="iconRect"/>
-          <dgm:constr type="h" for="ch" forName="spaceRect" refType="h" fact="0.15"/>
-          <dgm:constr type="w" for="ch" forName="spaceRect" refType="w"/>
-          <dgm:constr type="l" for="ch" forName="spaceRect"/>
-          <dgm:constr type="t" for="ch" forName="spaceRect" refType="b" refFor="ch" refForName="iconRect"/>
-          <dgm:constr type="h" for="ch" forName="textRect" val="20"/>
-          <dgm:constr type="w" for="ch" forName="textRect" refType="w"/>
-          <dgm:constr type="l" for="ch" forName="textRect"/>
-          <dgm:constr type="t" for="ch" forName="textRect" refType="b" refFor="ch" refForName="spaceRect"/>
-        </dgm:constrLst>
-        <dgm:ruleLst>
-          <dgm:rule type="h" val="INF" fact="NaN" max="NaN"/>
-        </dgm:ruleLst>
-        <dgm:layoutNode name="iconRect" styleLbl="node1">
-          <dgm:alg type="sp"/>
-          <dgm:shape xmlns:r="http://schemas.openxmlformats.org/officeDocument/2006/relationships" type="rect" r:blip="" blipPhldr="1">
-            <dgm:adjLst/>
-          </dgm:shape>
-          <dgm:presOf/>
-          <dgm:constrLst/>
-          <dgm:ruleLst/>
-        </dgm:layoutNode>
-        <dgm:layoutNode name="spaceRect">
-          <dgm:alg type="sp"/>
-          <dgm:shape xmlns:r="http://schemas.openxmlformats.org/officeDocument/2006/relationships" r:blip="">
-            <dgm:adjLst/>
-          </dgm:shape>
-          <dgm:presOf/>
-          <dgm:constrLst/>
-          <dgm:ruleLst/>
-        </dgm:layoutNode>
-        <dgm:layoutNode name="textRect" styleLbl="revTx">
-          <dgm:varLst>
-            <dgm:chMax val="1"/>
-            <dgm:chPref val="1"/>
-          </dgm:varLst>
-          <dgm:alg type="tx">
-            <dgm:param type="txAnchorVert" val="t"/>
-          </dgm:alg>
-          <dgm:shape xmlns:r="http://schemas.openxmlformats.org/officeDocument/2006/relationships" type="rect" r:blip="">
-            <dgm:adjLst/>
-          </dgm:shape>
-          <dgm:presOf axis="self" ptType="node"/>
-          <dgm:constrLst>
-            <dgm:constr type="lMarg"/>
-            <dgm:constr type="rMarg"/>
-            <dgm:constr type="tMarg"/>
-            <dgm:constr type="bMarg"/>
-          </dgm:constrLst>
-          <dgm:ruleLst>
-            <dgm:rule type="primFontSz" val="11" fact="NaN" max="NaN"/>
-            <dgm:rule type="h" val="INF" fact="NaN" max="NaN"/>
-          </dgm:ruleLst>
-        </dgm:layoutNode>
-      </dgm:layoutNode>
-      <dgm:forEach name="Name8" axis="followSib" ptType="sibTrans" cnt="1">
-        <dgm:layoutNode name="sibTrans">
-          <dgm:alg type="sp"/>
-          <dgm:shape xmlns:r="http://schemas.openxmlformats.org/officeDocument/2006/relationships" r:blip="">
-            <dgm:adjLst/>
-          </dgm:shape>
-          <dgm:presOf axis="self"/>
-          <dgm:constrLst/>
-          <dgm:ruleLst/>
-        </dgm:layoutNode>
-      </dgm:forEach>
-    </dgm:forEach>
-  </dgm:layoutNode>
-  <dgm:extLst>
-    <a:ext uri="{68A01E43-0DF5-4B5B-8FA6-DAF915123BFB}">
-      <dgm1612:lstStyle xmlns:dgm1612="http://schemas.microsoft.com/office/drawing/2016/12/diagram">
-        <a:lvl1pPr>
-          <a:lnSpc>
-            <a:spcPct val="100000"/>
-          </a:lnSpc>
-        </a:lvl1pPr>
-      </dgm1612:lstStyle>
-    </a:ext>
-  </dgm:extLst>
-</dgm:layoutDef>
-</file>
-
 <file path=ppt/diagrams/quickStyle1.xml><?xml version="1.0" encoding="utf-8"?>
 <dgm:styleDef xmlns:dgm="http://schemas.openxmlformats.org/drawingml/2006/diagram" xmlns:a="http://schemas.openxmlformats.org/drawingml/2006/main" uniqueId="urn:microsoft.com/office/officeart/2005/8/quickstyle/simple1">
   <dgm:title val=""/>
@@ -14611,1040 +12512,6 @@
 </file>
 
 <file path=ppt/diagrams/quickStyle4.xml><?xml version="1.0" encoding="utf-8"?>
-<dgm:styleDef xmlns:dgm="http://schemas.openxmlformats.org/drawingml/2006/diagram" xmlns:a="http://schemas.openxmlformats.org/drawingml/2006/main" uniqueId="urn:microsoft.com/office/officeart/2005/8/quickstyle/simple1">
-  <dgm:title val=""/>
-  <dgm:desc val=""/>
-  <dgm:catLst>
-    <dgm:cat type="simple" pri="10100"/>
-  </dgm:catLst>
-  <dgm:scene3d>
-    <a:camera prst="orthographicFront"/>
-    <a:lightRig rig="threePt" dir="t"/>
-  </dgm:scene3d>
-  <dgm:styleLbl name="node0">
-    <dgm:scene3d>
-      <a:camera prst="orthographicFront"/>
-      <a:lightRig rig="threePt" dir="t"/>
-    </dgm:scene3d>
-    <dgm:sp3d/>
-    <dgm:txPr/>
-    <dgm:style>
-      <a:lnRef idx="2">
-        <a:scrgbClr r="0" g="0" b="0"/>
-      </a:lnRef>
-      <a:fillRef idx="1">
-        <a:scrgbClr r="0" g="0" b="0"/>
-      </a:fillRef>
-      <a:effectRef idx="0">
-        <a:scrgbClr r="0" g="0" b="0"/>
-      </a:effectRef>
-      <a:fontRef idx="minor">
-        <a:schemeClr val="lt1"/>
-      </a:fontRef>
-    </dgm:style>
-  </dgm:styleLbl>
-  <dgm:styleLbl name="lnNode1">
-    <dgm:scene3d>
-      <a:camera prst="orthographicFront"/>
-      <a:lightRig rig="threePt" dir="t"/>
-    </dgm:scene3d>
-    <dgm:sp3d/>
-    <dgm:txPr/>
-    <dgm:style>
-      <a:lnRef idx="2">
-        <a:scrgbClr r="0" g="0" b="0"/>
-      </a:lnRef>
-      <a:fillRef idx="1">
-        <a:scrgbClr r="0" g="0" b="0"/>
-      </a:fillRef>
-      <a:effectRef idx="0">
-        <a:scrgbClr r="0" g="0" b="0"/>
-      </a:effectRef>
-      <a:fontRef idx="minor">
-        <a:schemeClr val="lt1"/>
-      </a:fontRef>
-    </dgm:style>
-  </dgm:styleLbl>
-  <dgm:styleLbl name="vennNode1">
-    <dgm:scene3d>
-      <a:camera prst="orthographicFront"/>
-      <a:lightRig rig="threePt" dir="t"/>
-    </dgm:scene3d>
-    <dgm:sp3d/>
-    <dgm:txPr/>
-    <dgm:style>
-      <a:lnRef idx="2">
-        <a:scrgbClr r="0" g="0" b="0"/>
-      </a:lnRef>
-      <a:fillRef idx="1">
-        <a:scrgbClr r="0" g="0" b="0"/>
-      </a:fillRef>
-      <a:effectRef idx="0">
-        <a:scrgbClr r="0" g="0" b="0"/>
-      </a:effectRef>
-      <a:fontRef idx="minor">
-        <a:schemeClr val="tx1"/>
-      </a:fontRef>
-    </dgm:style>
-  </dgm:styleLbl>
-  <dgm:styleLbl name="alignNode1">
-    <dgm:scene3d>
-      <a:camera prst="orthographicFront"/>
-      <a:lightRig rig="threePt" dir="t"/>
-    </dgm:scene3d>
-    <dgm:sp3d/>
-    <dgm:txPr/>
-    <dgm:style>
-      <a:lnRef idx="2">
-        <a:scrgbClr r="0" g="0" b="0"/>
-      </a:lnRef>
-      <a:fillRef idx="1">
-        <a:scrgbClr r="0" g="0" b="0"/>
-      </a:fillRef>
-      <a:effectRef idx="0">
-        <a:scrgbClr r="0" g="0" b="0"/>
-      </a:effectRef>
-      <a:fontRef idx="minor">
-        <a:schemeClr val="lt1"/>
-      </a:fontRef>
-    </dgm:style>
-  </dgm:styleLbl>
-  <dgm:styleLbl name="node1">
-    <dgm:scene3d>
-      <a:camera prst="orthographicFront"/>
-      <a:lightRig rig="threePt" dir="t"/>
-    </dgm:scene3d>
-    <dgm:sp3d/>
-    <dgm:txPr/>
-    <dgm:style>
-      <a:lnRef idx="2">
-        <a:scrgbClr r="0" g="0" b="0"/>
-      </a:lnRef>
-      <a:fillRef idx="1">
-        <a:scrgbClr r="0" g="0" b="0"/>
-      </a:fillRef>
-      <a:effectRef idx="0">
-        <a:scrgbClr r="0" g="0" b="0"/>
-      </a:effectRef>
-      <a:fontRef idx="minor">
-        <a:schemeClr val="lt1"/>
-      </a:fontRef>
-    </dgm:style>
-  </dgm:styleLbl>
-  <dgm:styleLbl name="node2">
-    <dgm:scene3d>
-      <a:camera prst="orthographicFront"/>
-      <a:lightRig rig="threePt" dir="t"/>
-    </dgm:scene3d>
-    <dgm:sp3d/>
-    <dgm:txPr/>
-    <dgm:style>
-      <a:lnRef idx="2">
-        <a:scrgbClr r="0" g="0" b="0"/>
-      </a:lnRef>
-      <a:fillRef idx="1">
-        <a:scrgbClr r="0" g="0" b="0"/>
-      </a:fillRef>
-      <a:effectRef idx="0">
-        <a:scrgbClr r="0" g="0" b="0"/>
-      </a:effectRef>
-      <a:fontRef idx="minor">
-        <a:schemeClr val="lt1"/>
-      </a:fontRef>
-    </dgm:style>
-  </dgm:styleLbl>
-  <dgm:styleLbl name="node3">
-    <dgm:scene3d>
-      <a:camera prst="orthographicFront"/>
-      <a:lightRig rig="threePt" dir="t"/>
-    </dgm:scene3d>
-    <dgm:sp3d/>
-    <dgm:txPr/>
-    <dgm:style>
-      <a:lnRef idx="2">
-        <a:scrgbClr r="0" g="0" b="0"/>
-      </a:lnRef>
-      <a:fillRef idx="1">
-        <a:scrgbClr r="0" g="0" b="0"/>
-      </a:fillRef>
-      <a:effectRef idx="0">
-        <a:scrgbClr r="0" g="0" b="0"/>
-      </a:effectRef>
-      <a:fontRef idx="minor">
-        <a:schemeClr val="lt1"/>
-      </a:fontRef>
-    </dgm:style>
-  </dgm:styleLbl>
-  <dgm:styleLbl name="node4">
-    <dgm:scene3d>
-      <a:camera prst="orthographicFront"/>
-      <a:lightRig rig="threePt" dir="t"/>
-    </dgm:scene3d>
-    <dgm:sp3d/>
-    <dgm:txPr/>
-    <dgm:style>
-      <a:lnRef idx="2">
-        <a:scrgbClr r="0" g="0" b="0"/>
-      </a:lnRef>
-      <a:fillRef idx="1">
-        <a:scrgbClr r="0" g="0" b="0"/>
-      </a:fillRef>
-      <a:effectRef idx="0">
-        <a:scrgbClr r="0" g="0" b="0"/>
-      </a:effectRef>
-      <a:fontRef idx="minor">
-        <a:schemeClr val="lt1"/>
-      </a:fontRef>
-    </dgm:style>
-  </dgm:styleLbl>
-  <dgm:styleLbl name="fgImgPlace1">
-    <dgm:scene3d>
-      <a:camera prst="orthographicFront"/>
-      <a:lightRig rig="threePt" dir="t"/>
-    </dgm:scene3d>
-    <dgm:sp3d/>
-    <dgm:txPr/>
-    <dgm:style>
-      <a:lnRef idx="2">
-        <a:scrgbClr r="0" g="0" b="0"/>
-      </a:lnRef>
-      <a:fillRef idx="1">
-        <a:scrgbClr r="0" g="0" b="0"/>
-      </a:fillRef>
-      <a:effectRef idx="0">
-        <a:scrgbClr r="0" g="0" b="0"/>
-      </a:effectRef>
-      <a:fontRef idx="minor"/>
-    </dgm:style>
-  </dgm:styleLbl>
-  <dgm:styleLbl name="alignImgPlace1">
-    <dgm:scene3d>
-      <a:camera prst="orthographicFront"/>
-      <a:lightRig rig="threePt" dir="t"/>
-    </dgm:scene3d>
-    <dgm:sp3d/>
-    <dgm:txPr/>
-    <dgm:style>
-      <a:lnRef idx="2">
-        <a:scrgbClr r="0" g="0" b="0"/>
-      </a:lnRef>
-      <a:fillRef idx="1">
-        <a:scrgbClr r="0" g="0" b="0"/>
-      </a:fillRef>
-      <a:effectRef idx="0">
-        <a:scrgbClr r="0" g="0" b="0"/>
-      </a:effectRef>
-      <a:fontRef idx="minor"/>
-    </dgm:style>
-  </dgm:styleLbl>
-  <dgm:styleLbl name="bgImgPlace1">
-    <dgm:scene3d>
-      <a:camera prst="orthographicFront"/>
-      <a:lightRig rig="threePt" dir="t"/>
-    </dgm:scene3d>
-    <dgm:sp3d/>
-    <dgm:txPr/>
-    <dgm:style>
-      <a:lnRef idx="2">
-        <a:scrgbClr r="0" g="0" b="0"/>
-      </a:lnRef>
-      <a:fillRef idx="1">
-        <a:scrgbClr r="0" g="0" b="0"/>
-      </a:fillRef>
-      <a:effectRef idx="0">
-        <a:scrgbClr r="0" g="0" b="0"/>
-      </a:effectRef>
-      <a:fontRef idx="minor"/>
-    </dgm:style>
-  </dgm:styleLbl>
-  <dgm:styleLbl name="sibTrans2D1">
-    <dgm:scene3d>
-      <a:camera prst="orthographicFront"/>
-      <a:lightRig rig="threePt" dir="t"/>
-    </dgm:scene3d>
-    <dgm:sp3d/>
-    <dgm:txPr/>
-    <dgm:style>
-      <a:lnRef idx="0">
-        <a:scrgbClr r="0" g="0" b="0"/>
-      </a:lnRef>
-      <a:fillRef idx="1">
-        <a:scrgbClr r="0" g="0" b="0"/>
-      </a:fillRef>
-      <a:effectRef idx="0">
-        <a:scrgbClr r="0" g="0" b="0"/>
-      </a:effectRef>
-      <a:fontRef idx="minor">
-        <a:schemeClr val="lt1"/>
-      </a:fontRef>
-    </dgm:style>
-  </dgm:styleLbl>
-  <dgm:styleLbl name="fgSibTrans2D1">
-    <dgm:scene3d>
-      <a:camera prst="orthographicFront"/>
-      <a:lightRig rig="threePt" dir="t"/>
-    </dgm:scene3d>
-    <dgm:sp3d/>
-    <dgm:txPr/>
-    <dgm:style>
-      <a:lnRef idx="0">
-        <a:scrgbClr r="0" g="0" b="0"/>
-      </a:lnRef>
-      <a:fillRef idx="1">
-        <a:scrgbClr r="0" g="0" b="0"/>
-      </a:fillRef>
-      <a:effectRef idx="0">
-        <a:scrgbClr r="0" g="0" b="0"/>
-      </a:effectRef>
-      <a:fontRef idx="minor">
-        <a:schemeClr val="lt1"/>
-      </a:fontRef>
-    </dgm:style>
-  </dgm:styleLbl>
-  <dgm:styleLbl name="bgSibTrans2D1">
-    <dgm:scene3d>
-      <a:camera prst="orthographicFront"/>
-      <a:lightRig rig="threePt" dir="t"/>
-    </dgm:scene3d>
-    <dgm:sp3d/>
-    <dgm:txPr/>
-    <dgm:style>
-      <a:lnRef idx="0">
-        <a:scrgbClr r="0" g="0" b="0"/>
-      </a:lnRef>
-      <a:fillRef idx="1">
-        <a:scrgbClr r="0" g="0" b="0"/>
-      </a:fillRef>
-      <a:effectRef idx="0">
-        <a:scrgbClr r="0" g="0" b="0"/>
-      </a:effectRef>
-      <a:fontRef idx="minor">
-        <a:schemeClr val="lt1"/>
-      </a:fontRef>
-    </dgm:style>
-  </dgm:styleLbl>
-  <dgm:styleLbl name="sibTrans1D1">
-    <dgm:scene3d>
-      <a:camera prst="orthographicFront"/>
-      <a:lightRig rig="threePt" dir="t"/>
-    </dgm:scene3d>
-    <dgm:sp3d/>
-    <dgm:txPr/>
-    <dgm:style>
-      <a:lnRef idx="1">
-        <a:scrgbClr r="0" g="0" b="0"/>
-      </a:lnRef>
-      <a:fillRef idx="0">
-        <a:scrgbClr r="0" g="0" b="0"/>
-      </a:fillRef>
-      <a:effectRef idx="0">
-        <a:scrgbClr r="0" g="0" b="0"/>
-      </a:effectRef>
-      <a:fontRef idx="minor"/>
-    </dgm:style>
-  </dgm:styleLbl>
-  <dgm:styleLbl name="callout">
-    <dgm:scene3d>
-      <a:camera prst="orthographicFront"/>
-      <a:lightRig rig="threePt" dir="t"/>
-    </dgm:scene3d>
-    <dgm:sp3d/>
-    <dgm:txPr/>
-    <dgm:style>
-      <a:lnRef idx="2">
-        <a:scrgbClr r="0" g="0" b="0"/>
-      </a:lnRef>
-      <a:fillRef idx="1">
-        <a:scrgbClr r="0" g="0" b="0"/>
-      </a:fillRef>
-      <a:effectRef idx="0">
-        <a:scrgbClr r="0" g="0" b="0"/>
-      </a:effectRef>
-      <a:fontRef idx="minor"/>
-    </dgm:style>
-  </dgm:styleLbl>
-  <dgm:styleLbl name="asst0">
-    <dgm:scene3d>
-      <a:camera prst="orthographicFront"/>
-      <a:lightRig rig="threePt" dir="t"/>
-    </dgm:scene3d>
-    <dgm:sp3d/>
-    <dgm:txPr/>
-    <dgm:style>
-      <a:lnRef idx="2">
-        <a:scrgbClr r="0" g="0" b="0"/>
-      </a:lnRef>
-      <a:fillRef idx="1">
-        <a:scrgbClr r="0" g="0" b="0"/>
-      </a:fillRef>
-      <a:effectRef idx="0">
-        <a:scrgbClr r="0" g="0" b="0"/>
-      </a:effectRef>
-      <a:fontRef idx="minor">
-        <a:schemeClr val="lt1"/>
-      </a:fontRef>
-    </dgm:style>
-  </dgm:styleLbl>
-  <dgm:styleLbl name="asst1">
-    <dgm:scene3d>
-      <a:camera prst="orthographicFront"/>
-      <a:lightRig rig="threePt" dir="t"/>
-    </dgm:scene3d>
-    <dgm:sp3d/>
-    <dgm:txPr/>
-    <dgm:style>
-      <a:lnRef idx="2">
-        <a:scrgbClr r="0" g="0" b="0"/>
-      </a:lnRef>
-      <a:fillRef idx="1">
-        <a:scrgbClr r="0" g="0" b="0"/>
-      </a:fillRef>
-      <a:effectRef idx="0">
-        <a:scrgbClr r="0" g="0" b="0"/>
-      </a:effectRef>
-      <a:fontRef idx="minor">
-        <a:schemeClr val="lt1"/>
-      </a:fontRef>
-    </dgm:style>
-  </dgm:styleLbl>
-  <dgm:styleLbl name="asst2">
-    <dgm:scene3d>
-      <a:camera prst="orthographicFront"/>
-      <a:lightRig rig="threePt" dir="t"/>
-    </dgm:scene3d>
-    <dgm:sp3d/>
-    <dgm:txPr/>
-    <dgm:style>
-      <a:lnRef idx="2">
-        <a:scrgbClr r="0" g="0" b="0"/>
-      </a:lnRef>
-      <a:fillRef idx="1">
-        <a:scrgbClr r="0" g="0" b="0"/>
-      </a:fillRef>
-      <a:effectRef idx="0">
-        <a:scrgbClr r="0" g="0" b="0"/>
-      </a:effectRef>
-      <a:fontRef idx="minor">
-        <a:schemeClr val="lt1"/>
-      </a:fontRef>
-    </dgm:style>
-  </dgm:styleLbl>
-  <dgm:styleLbl name="asst3">
-    <dgm:scene3d>
-      <a:camera prst="orthographicFront"/>
-      <a:lightRig rig="threePt" dir="t"/>
-    </dgm:scene3d>
-    <dgm:sp3d/>
-    <dgm:txPr/>
-    <dgm:style>
-      <a:lnRef idx="2">
-        <a:scrgbClr r="0" g="0" b="0"/>
-      </a:lnRef>
-      <a:fillRef idx="1">
-        <a:scrgbClr r="0" g="0" b="0"/>
-      </a:fillRef>
-      <a:effectRef idx="0">
-        <a:scrgbClr r="0" g="0" b="0"/>
-      </a:effectRef>
-      <a:fontRef idx="minor">
-        <a:schemeClr val="lt1"/>
-      </a:fontRef>
-    </dgm:style>
-  </dgm:styleLbl>
-  <dgm:styleLbl name="asst4">
-    <dgm:scene3d>
-      <a:camera prst="orthographicFront"/>
-      <a:lightRig rig="threePt" dir="t"/>
-    </dgm:scene3d>
-    <dgm:sp3d/>
-    <dgm:txPr/>
-    <dgm:style>
-      <a:lnRef idx="2">
-        <a:scrgbClr r="0" g="0" b="0"/>
-      </a:lnRef>
-      <a:fillRef idx="1">
-        <a:scrgbClr r="0" g="0" b="0"/>
-      </a:fillRef>
-      <a:effectRef idx="0">
-        <a:scrgbClr r="0" g="0" b="0"/>
-      </a:effectRef>
-      <a:fontRef idx="minor">
-        <a:schemeClr val="lt1"/>
-      </a:fontRef>
-    </dgm:style>
-  </dgm:styleLbl>
-  <dgm:styleLbl name="parChTrans2D1">
-    <dgm:scene3d>
-      <a:camera prst="orthographicFront"/>
-      <a:lightRig rig="threePt" dir="t"/>
-    </dgm:scene3d>
-    <dgm:sp3d/>
-    <dgm:txPr/>
-    <dgm:style>
-      <a:lnRef idx="2">
-        <a:scrgbClr r="0" g="0" b="0"/>
-      </a:lnRef>
-      <a:fillRef idx="1">
-        <a:scrgbClr r="0" g="0" b="0"/>
-      </a:fillRef>
-      <a:effectRef idx="0">
-        <a:scrgbClr r="0" g="0" b="0"/>
-      </a:effectRef>
-      <a:fontRef idx="minor">
-        <a:schemeClr val="lt1"/>
-      </a:fontRef>
-    </dgm:style>
-  </dgm:styleLbl>
-  <dgm:styleLbl name="parChTrans2D2">
-    <dgm:scene3d>
-      <a:camera prst="orthographicFront"/>
-      <a:lightRig rig="threePt" dir="t"/>
-    </dgm:scene3d>
-    <dgm:sp3d/>
-    <dgm:txPr/>
-    <dgm:style>
-      <a:lnRef idx="2">
-        <a:scrgbClr r="0" g="0" b="0"/>
-      </a:lnRef>
-      <a:fillRef idx="1">
-        <a:scrgbClr r="0" g="0" b="0"/>
-      </a:fillRef>
-      <a:effectRef idx="0">
-        <a:scrgbClr r="0" g="0" b="0"/>
-      </a:effectRef>
-      <a:fontRef idx="minor">
-        <a:schemeClr val="lt1"/>
-      </a:fontRef>
-    </dgm:style>
-  </dgm:styleLbl>
-  <dgm:styleLbl name="parChTrans2D3">
-    <dgm:scene3d>
-      <a:camera prst="orthographicFront"/>
-      <a:lightRig rig="threePt" dir="t"/>
-    </dgm:scene3d>
-    <dgm:sp3d/>
-    <dgm:txPr/>
-    <dgm:style>
-      <a:lnRef idx="2">
-        <a:scrgbClr r="0" g="0" b="0"/>
-      </a:lnRef>
-      <a:fillRef idx="1">
-        <a:scrgbClr r="0" g="0" b="0"/>
-      </a:fillRef>
-      <a:effectRef idx="0">
-        <a:scrgbClr r="0" g="0" b="0"/>
-      </a:effectRef>
-      <a:fontRef idx="minor">
-        <a:schemeClr val="lt1"/>
-      </a:fontRef>
-    </dgm:style>
-  </dgm:styleLbl>
-  <dgm:styleLbl name="parChTrans2D4">
-    <dgm:scene3d>
-      <a:camera prst="orthographicFront"/>
-      <a:lightRig rig="threePt" dir="t"/>
-    </dgm:scene3d>
-    <dgm:sp3d/>
-    <dgm:txPr/>
-    <dgm:style>
-      <a:lnRef idx="2">
-        <a:scrgbClr r="0" g="0" b="0"/>
-      </a:lnRef>
-      <a:fillRef idx="1">
-        <a:scrgbClr r="0" g="0" b="0"/>
-      </a:fillRef>
-      <a:effectRef idx="0">
-        <a:scrgbClr r="0" g="0" b="0"/>
-      </a:effectRef>
-      <a:fontRef idx="minor">
-        <a:schemeClr val="lt1"/>
-      </a:fontRef>
-    </dgm:style>
-  </dgm:styleLbl>
-  <dgm:styleLbl name="parChTrans1D1">
-    <dgm:scene3d>
-      <a:camera prst="orthographicFront"/>
-      <a:lightRig rig="threePt" dir="t"/>
-    </dgm:scene3d>
-    <dgm:sp3d/>
-    <dgm:txPr/>
-    <dgm:style>
-      <a:lnRef idx="2">
-        <a:scrgbClr r="0" g="0" b="0"/>
-      </a:lnRef>
-      <a:fillRef idx="0">
-        <a:scrgbClr r="0" g="0" b="0"/>
-      </a:fillRef>
-      <a:effectRef idx="0">
-        <a:scrgbClr r="0" g="0" b="0"/>
-      </a:effectRef>
-      <a:fontRef idx="minor"/>
-    </dgm:style>
-  </dgm:styleLbl>
-  <dgm:styleLbl name="parChTrans1D2">
-    <dgm:scene3d>
-      <a:camera prst="orthographicFront"/>
-      <a:lightRig rig="threePt" dir="t"/>
-    </dgm:scene3d>
-    <dgm:sp3d/>
-    <dgm:txPr/>
-    <dgm:style>
-      <a:lnRef idx="2">
-        <a:scrgbClr r="0" g="0" b="0"/>
-      </a:lnRef>
-      <a:fillRef idx="0">
-        <a:scrgbClr r="0" g="0" b="0"/>
-      </a:fillRef>
-      <a:effectRef idx="0">
-        <a:scrgbClr r="0" g="0" b="0"/>
-      </a:effectRef>
-      <a:fontRef idx="minor"/>
-    </dgm:style>
-  </dgm:styleLbl>
-  <dgm:styleLbl name="parChTrans1D3">
-    <dgm:scene3d>
-      <a:camera prst="orthographicFront"/>
-      <a:lightRig rig="threePt" dir="t"/>
-    </dgm:scene3d>
-    <dgm:sp3d/>
-    <dgm:txPr/>
-    <dgm:style>
-      <a:lnRef idx="2">
-        <a:scrgbClr r="0" g="0" b="0"/>
-      </a:lnRef>
-      <a:fillRef idx="0">
-        <a:scrgbClr r="0" g="0" b="0"/>
-      </a:fillRef>
-      <a:effectRef idx="0">
-        <a:scrgbClr r="0" g="0" b="0"/>
-      </a:effectRef>
-      <a:fontRef idx="minor"/>
-    </dgm:style>
-  </dgm:styleLbl>
-  <dgm:styleLbl name="parChTrans1D4">
-    <dgm:scene3d>
-      <a:camera prst="orthographicFront"/>
-      <a:lightRig rig="threePt" dir="t"/>
-    </dgm:scene3d>
-    <dgm:sp3d/>
-    <dgm:txPr/>
-    <dgm:style>
-      <a:lnRef idx="2">
-        <a:scrgbClr r="0" g="0" b="0"/>
-      </a:lnRef>
-      <a:fillRef idx="0">
-        <a:scrgbClr r="0" g="0" b="0"/>
-      </a:fillRef>
-      <a:effectRef idx="0">
-        <a:scrgbClr r="0" g="0" b="0"/>
-      </a:effectRef>
-      <a:fontRef idx="minor"/>
-    </dgm:style>
-  </dgm:styleLbl>
-  <dgm:styleLbl name="fgAcc1">
-    <dgm:scene3d>
-      <a:camera prst="orthographicFront"/>
-      <a:lightRig rig="threePt" dir="t"/>
-    </dgm:scene3d>
-    <dgm:sp3d/>
-    <dgm:txPr/>
-    <dgm:style>
-      <a:lnRef idx="2">
-        <a:scrgbClr r="0" g="0" b="0"/>
-      </a:lnRef>
-      <a:fillRef idx="1">
-        <a:scrgbClr r="0" g="0" b="0"/>
-      </a:fillRef>
-      <a:effectRef idx="0">
-        <a:scrgbClr r="0" g="0" b="0"/>
-      </a:effectRef>
-      <a:fontRef idx="minor"/>
-    </dgm:style>
-  </dgm:styleLbl>
-  <dgm:styleLbl name="conFgAcc1">
-    <dgm:scene3d>
-      <a:camera prst="orthographicFront"/>
-      <a:lightRig rig="threePt" dir="t"/>
-    </dgm:scene3d>
-    <dgm:sp3d/>
-    <dgm:txPr/>
-    <dgm:style>
-      <a:lnRef idx="2">
-        <a:scrgbClr r="0" g="0" b="0"/>
-      </a:lnRef>
-      <a:fillRef idx="1">
-        <a:scrgbClr r="0" g="0" b="0"/>
-      </a:fillRef>
-      <a:effectRef idx="0">
-        <a:scrgbClr r="0" g="0" b="0"/>
-      </a:effectRef>
-      <a:fontRef idx="minor"/>
-    </dgm:style>
-  </dgm:styleLbl>
-  <dgm:styleLbl name="alignAcc1">
-    <dgm:scene3d>
-      <a:camera prst="orthographicFront"/>
-      <a:lightRig rig="threePt" dir="t"/>
-    </dgm:scene3d>
-    <dgm:sp3d/>
-    <dgm:txPr/>
-    <dgm:style>
-      <a:lnRef idx="2">
-        <a:scrgbClr r="0" g="0" b="0"/>
-      </a:lnRef>
-      <a:fillRef idx="1">
-        <a:scrgbClr r="0" g="0" b="0"/>
-      </a:fillRef>
-      <a:effectRef idx="0">
-        <a:scrgbClr r="0" g="0" b="0"/>
-      </a:effectRef>
-      <a:fontRef idx="minor"/>
-    </dgm:style>
-  </dgm:styleLbl>
-  <dgm:styleLbl name="trAlignAcc1">
-    <dgm:scene3d>
-      <a:camera prst="orthographicFront"/>
-      <a:lightRig rig="threePt" dir="t"/>
-    </dgm:scene3d>
-    <dgm:sp3d/>
-    <dgm:txPr/>
-    <dgm:style>
-      <a:lnRef idx="1">
-        <a:scrgbClr r="0" g="0" b="0"/>
-      </a:lnRef>
-      <a:fillRef idx="1">
-        <a:scrgbClr r="0" g="0" b="0"/>
-      </a:fillRef>
-      <a:effectRef idx="0">
-        <a:scrgbClr r="0" g="0" b="0"/>
-      </a:effectRef>
-      <a:fontRef idx="minor"/>
-    </dgm:style>
-  </dgm:styleLbl>
-  <dgm:styleLbl name="bgAcc1">
-    <dgm:scene3d>
-      <a:camera prst="orthographicFront"/>
-      <a:lightRig rig="threePt" dir="t"/>
-    </dgm:scene3d>
-    <dgm:sp3d/>
-    <dgm:txPr/>
-    <dgm:style>
-      <a:lnRef idx="2">
-        <a:scrgbClr r="0" g="0" b="0"/>
-      </a:lnRef>
-      <a:fillRef idx="1">
-        <a:scrgbClr r="0" g="0" b="0"/>
-      </a:fillRef>
-      <a:effectRef idx="0">
-        <a:scrgbClr r="0" g="0" b="0"/>
-      </a:effectRef>
-      <a:fontRef idx="minor"/>
-    </dgm:style>
-  </dgm:styleLbl>
-  <dgm:styleLbl name="solidFgAcc1">
-    <dgm:scene3d>
-      <a:camera prst="orthographicFront"/>
-      <a:lightRig rig="threePt" dir="t"/>
-    </dgm:scene3d>
-    <dgm:sp3d/>
-    <dgm:txPr/>
-    <dgm:style>
-      <a:lnRef idx="2">
-        <a:scrgbClr r="0" g="0" b="0"/>
-      </a:lnRef>
-      <a:fillRef idx="1">
-        <a:scrgbClr r="0" g="0" b="0"/>
-      </a:fillRef>
-      <a:effectRef idx="0">
-        <a:scrgbClr r="0" g="0" b="0"/>
-      </a:effectRef>
-      <a:fontRef idx="minor"/>
-    </dgm:style>
-  </dgm:styleLbl>
-  <dgm:styleLbl name="solidAlignAcc1">
-    <dgm:scene3d>
-      <a:camera prst="orthographicFront"/>
-      <a:lightRig rig="threePt" dir="t"/>
-    </dgm:scene3d>
-    <dgm:sp3d/>
-    <dgm:txPr/>
-    <dgm:style>
-      <a:lnRef idx="2">
-        <a:scrgbClr r="0" g="0" b="0"/>
-      </a:lnRef>
-      <a:fillRef idx="1">
-        <a:scrgbClr r="0" g="0" b="0"/>
-      </a:fillRef>
-      <a:effectRef idx="0">
-        <a:scrgbClr r="0" g="0" b="0"/>
-      </a:effectRef>
-      <a:fontRef idx="minor"/>
-    </dgm:style>
-  </dgm:styleLbl>
-  <dgm:styleLbl name="solidBgAcc1">
-    <dgm:scene3d>
-      <a:camera prst="orthographicFront"/>
-      <a:lightRig rig="threePt" dir="t"/>
-    </dgm:scene3d>
-    <dgm:sp3d/>
-    <dgm:txPr/>
-    <dgm:style>
-      <a:lnRef idx="2">
-        <a:scrgbClr r="0" g="0" b="0"/>
-      </a:lnRef>
-      <a:fillRef idx="1">
-        <a:scrgbClr r="0" g="0" b="0"/>
-      </a:fillRef>
-      <a:effectRef idx="0">
-        <a:scrgbClr r="0" g="0" b="0"/>
-      </a:effectRef>
-      <a:fontRef idx="minor"/>
-    </dgm:style>
-  </dgm:styleLbl>
-  <dgm:styleLbl name="fgAccFollowNode1">
-    <dgm:scene3d>
-      <a:camera prst="orthographicFront"/>
-      <a:lightRig rig="threePt" dir="t"/>
-    </dgm:scene3d>
-    <dgm:sp3d/>
-    <dgm:txPr/>
-    <dgm:style>
-      <a:lnRef idx="2">
-        <a:scrgbClr r="0" g="0" b="0"/>
-      </a:lnRef>
-      <a:fillRef idx="1">
-        <a:scrgbClr r="0" g="0" b="0"/>
-      </a:fillRef>
-      <a:effectRef idx="0">
-        <a:scrgbClr r="0" g="0" b="0"/>
-      </a:effectRef>
-      <a:fontRef idx="minor"/>
-    </dgm:style>
-  </dgm:styleLbl>
-  <dgm:styleLbl name="alignAccFollowNode1">
-    <dgm:scene3d>
-      <a:camera prst="orthographicFront"/>
-      <a:lightRig rig="threePt" dir="t"/>
-    </dgm:scene3d>
-    <dgm:sp3d/>
-    <dgm:txPr/>
-    <dgm:style>
-      <a:lnRef idx="2">
-        <a:scrgbClr r="0" g="0" b="0"/>
-      </a:lnRef>
-      <a:fillRef idx="1">
-        <a:scrgbClr r="0" g="0" b="0"/>
-      </a:fillRef>
-      <a:effectRef idx="0">
-        <a:scrgbClr r="0" g="0" b="0"/>
-      </a:effectRef>
-      <a:fontRef idx="minor"/>
-    </dgm:style>
-  </dgm:styleLbl>
-  <dgm:styleLbl name="bgAccFollowNode1">
-    <dgm:scene3d>
-      <a:camera prst="orthographicFront"/>
-      <a:lightRig rig="threePt" dir="t"/>
-    </dgm:scene3d>
-    <dgm:sp3d/>
-    <dgm:txPr/>
-    <dgm:style>
-      <a:lnRef idx="2">
-        <a:scrgbClr r="0" g="0" b="0"/>
-      </a:lnRef>
-      <a:fillRef idx="1">
-        <a:scrgbClr r="0" g="0" b="0"/>
-      </a:fillRef>
-      <a:effectRef idx="0">
-        <a:scrgbClr r="0" g="0" b="0"/>
-      </a:effectRef>
-      <a:fontRef idx="minor"/>
-    </dgm:style>
-  </dgm:styleLbl>
-  <dgm:styleLbl name="fgAcc0">
-    <dgm:scene3d>
-      <a:camera prst="orthographicFront"/>
-      <a:lightRig rig="threePt" dir="t"/>
-    </dgm:scene3d>
-    <dgm:sp3d/>
-    <dgm:txPr/>
-    <dgm:style>
-      <a:lnRef idx="2">
-        <a:scrgbClr r="0" g="0" b="0"/>
-      </a:lnRef>
-      <a:fillRef idx="1">
-        <a:scrgbClr r="0" g="0" b="0"/>
-      </a:fillRef>
-      <a:effectRef idx="0">
-        <a:scrgbClr r="0" g="0" b="0"/>
-      </a:effectRef>
-      <a:fontRef idx="minor"/>
-    </dgm:style>
-  </dgm:styleLbl>
-  <dgm:styleLbl name="fgAcc2">
-    <dgm:scene3d>
-      <a:camera prst="orthographicFront"/>
-      <a:lightRig rig="threePt" dir="t"/>
-    </dgm:scene3d>
-    <dgm:sp3d/>
-    <dgm:txPr/>
-    <dgm:style>
-      <a:lnRef idx="2">
-        <a:scrgbClr r="0" g="0" b="0"/>
-      </a:lnRef>
-      <a:fillRef idx="1">
-        <a:scrgbClr r="0" g="0" b="0"/>
-      </a:fillRef>
-      <a:effectRef idx="0">
-        <a:scrgbClr r="0" g="0" b="0"/>
-      </a:effectRef>
-      <a:fontRef idx="minor"/>
-    </dgm:style>
-  </dgm:styleLbl>
-  <dgm:styleLbl name="fgAcc3">
-    <dgm:scene3d>
-      <a:camera prst="orthographicFront"/>
-      <a:lightRig rig="threePt" dir="t"/>
-    </dgm:scene3d>
-    <dgm:sp3d/>
-    <dgm:txPr/>
-    <dgm:style>
-      <a:lnRef idx="2">
-        <a:scrgbClr r="0" g="0" b="0"/>
-      </a:lnRef>
-      <a:fillRef idx="1">
-        <a:scrgbClr r="0" g="0" b="0"/>
-      </a:fillRef>
-      <a:effectRef idx="0">
-        <a:scrgbClr r="0" g="0" b="0"/>
-      </a:effectRef>
-      <a:fontRef idx="minor"/>
-    </dgm:style>
-  </dgm:styleLbl>
-  <dgm:styleLbl name="fgAcc4">
-    <dgm:scene3d>
-      <a:camera prst="orthographicFront"/>
-      <a:lightRig rig="threePt" dir="t"/>
-    </dgm:scene3d>
-    <dgm:sp3d/>
-    <dgm:txPr/>
-    <dgm:style>
-      <a:lnRef idx="2">
-        <a:scrgbClr r="0" g="0" b="0"/>
-      </a:lnRef>
-      <a:fillRef idx="1">
-        <a:scrgbClr r="0" g="0" b="0"/>
-      </a:fillRef>
-      <a:effectRef idx="0">
-        <a:scrgbClr r="0" g="0" b="0"/>
-      </a:effectRef>
-      <a:fontRef idx="minor"/>
-    </dgm:style>
-  </dgm:styleLbl>
-  <dgm:styleLbl name="bgShp">
-    <dgm:scene3d>
-      <a:camera prst="orthographicFront"/>
-      <a:lightRig rig="threePt" dir="t"/>
-    </dgm:scene3d>
-    <dgm:sp3d/>
-    <dgm:txPr/>
-    <dgm:style>
-      <a:lnRef idx="0">
-        <a:scrgbClr r="0" g="0" b="0"/>
-      </a:lnRef>
-      <a:fillRef idx="1">
-        <a:scrgbClr r="0" g="0" b="0"/>
-      </a:fillRef>
-      <a:effectRef idx="0">
-        <a:scrgbClr r="0" g="0" b="0"/>
-      </a:effectRef>
-      <a:fontRef idx="minor"/>
-    </dgm:style>
-  </dgm:styleLbl>
-  <dgm:styleLbl name="dkBgShp">
-    <dgm:scene3d>
-      <a:camera prst="orthographicFront"/>
-      <a:lightRig rig="threePt" dir="t"/>
-    </dgm:scene3d>
-    <dgm:sp3d/>
-    <dgm:txPr/>
-    <dgm:style>
-      <a:lnRef idx="0">
-        <a:scrgbClr r="0" g="0" b="0"/>
-      </a:lnRef>
-      <a:fillRef idx="1">
-        <a:scrgbClr r="0" g="0" b="0"/>
-      </a:fillRef>
-      <a:effectRef idx="0">
-        <a:scrgbClr r="0" g="0" b="0"/>
-      </a:effectRef>
-      <a:fontRef idx="minor"/>
-    </dgm:style>
-  </dgm:styleLbl>
-  <dgm:styleLbl name="trBgShp">
-    <dgm:scene3d>
-      <a:camera prst="orthographicFront"/>
-      <a:lightRig rig="threePt" dir="t"/>
-    </dgm:scene3d>
-    <dgm:sp3d/>
-    <dgm:txPr/>
-    <dgm:style>
-      <a:lnRef idx="0">
-        <a:scrgbClr r="0" g="0" b="0"/>
-      </a:lnRef>
-      <a:fillRef idx="1">
-        <a:scrgbClr r="0" g="0" b="0"/>
-      </a:fillRef>
-      <a:effectRef idx="0">
-        <a:scrgbClr r="0" g="0" b="0"/>
-      </a:effectRef>
-      <a:fontRef idx="minor"/>
-    </dgm:style>
-  </dgm:styleLbl>
-  <dgm:styleLbl name="fgShp">
-    <dgm:scene3d>
-      <a:camera prst="orthographicFront"/>
-      <a:lightRig rig="threePt" dir="t"/>
-    </dgm:scene3d>
-    <dgm:sp3d/>
-    <dgm:txPr/>
-    <dgm:style>
-      <a:lnRef idx="2">
-        <a:scrgbClr r="0" g="0" b="0"/>
-      </a:lnRef>
-      <a:fillRef idx="1">
-        <a:scrgbClr r="0" g="0" b="0"/>
-      </a:fillRef>
-      <a:effectRef idx="0">
-        <a:scrgbClr r="0" g="0" b="0"/>
-      </a:effectRef>
-      <a:fontRef idx="minor"/>
-    </dgm:style>
-  </dgm:styleLbl>
-  <dgm:styleLbl name="revTx">
-    <dgm:scene3d>
-      <a:camera prst="orthographicFront"/>
-      <a:lightRig rig="threePt" dir="t"/>
-    </dgm:scene3d>
-    <dgm:sp3d/>
-    <dgm:txPr/>
-    <dgm:style>
-      <a:lnRef idx="0">
-        <a:scrgbClr r="0" g="0" b="0"/>
-      </a:lnRef>
-      <a:fillRef idx="0">
-        <a:scrgbClr r="0" g="0" b="0"/>
-      </a:fillRef>
-      <a:effectRef idx="0">
-        <a:scrgbClr r="0" g="0" b="0"/>
-      </a:effectRef>
-      <a:fontRef idx="minor"/>
-    </dgm:style>
-  </dgm:styleLbl>
-</dgm:styleDef>
-</file>
-
-<file path=ppt/diagrams/quickStyle5.xml><?xml version="1.0" encoding="utf-8"?>
 <dgm:styleDef xmlns:dgm="http://schemas.openxmlformats.org/drawingml/2006/diagram" xmlns:a="http://schemas.openxmlformats.org/drawingml/2006/main" uniqueId="urn:microsoft.com/office/officeart/2005/8/quickstyle/simple1">
   <dgm:title val=""/>
   <dgm:desc val=""/>
@@ -17092,7 +13959,7 @@
           <a:p>
             <a:fld id="{DC0D42F3-CDD5-4B19-B3DB-7C5223465AF0}" type="slidenum">
               <a:rPr lang="en-US" smtClean="0"/>
-              <a:t>7</a:t>
+              <a:t>6</a:t>
             </a:fld>
             <a:endParaRPr lang="en-US" dirty="0"/>
           </a:p>
@@ -17176,7 +14043,7 @@
           <a:p>
             <a:fld id="{DC0D42F3-CDD5-4B19-B3DB-7C5223465AF0}" type="slidenum">
               <a:rPr lang="en-US" smtClean="0"/>
-              <a:t>8</a:t>
+              <a:t>7</a:t>
             </a:fld>
             <a:endParaRPr lang="en-US" dirty="0"/>
           </a:p>
@@ -17260,7 +14127,7 @@
           <a:p>
             <a:fld id="{DC0D42F3-CDD5-4B19-B3DB-7C5223465AF0}" type="slidenum">
               <a:rPr lang="en-US" smtClean="0"/>
-              <a:t>10</a:t>
+              <a:t>9</a:t>
             </a:fld>
             <a:endParaRPr lang="en-US" dirty="0"/>
           </a:p>
@@ -17368,7 +14235,7 @@
           <a:p>
             <a:fld id="{DC0D42F3-CDD5-4B19-B3DB-7C5223465AF0}" type="slidenum">
               <a:rPr lang="en-US" smtClean="0"/>
-              <a:t>11</a:t>
+              <a:t>10</a:t>
             </a:fld>
             <a:endParaRPr lang="en-US" dirty="0"/>
           </a:p>
@@ -24759,108 +21626,6 @@
         <p:cNvPr id="1" name="">
           <a:extLst>
             <a:ext uri="{FF2B5EF4-FFF2-40B4-BE49-F238E27FC236}">
-              <a16:creationId xmlns:a16="http://schemas.microsoft.com/office/drawing/2014/main" id="{0CB52369-B04C-C2C9-51B5-5614C2F35052}"/>
-            </a:ext>
-          </a:extLst>
-        </p:cNvPr>
-        <p:cNvGrpSpPr/>
-        <p:nvPr/>
-      </p:nvGrpSpPr>
-      <p:grpSpPr>
-        <a:xfrm>
-          <a:off x="0" y="0"/>
-          <a:ext cx="0" cy="0"/>
-          <a:chOff x="0" y="0"/>
-          <a:chExt cx="0" cy="0"/>
-        </a:xfrm>
-      </p:grpSpPr>
-      <p:sp>
-        <p:nvSpPr>
-          <p:cNvPr id="15" name="Title 14">
-            <a:extLst>
-              <a:ext uri="{FF2B5EF4-FFF2-40B4-BE49-F238E27FC236}">
-                <a16:creationId xmlns:a16="http://schemas.microsoft.com/office/drawing/2014/main" id="{A11AE03E-A139-0CA5-BAE2-173FA8B0E0C2}"/>
-              </a:ext>
-            </a:extLst>
-          </p:cNvPr>
-          <p:cNvSpPr>
-            <a:spLocks noGrp="1"/>
-          </p:cNvSpPr>
-          <p:nvPr>
-            <p:ph type="title"/>
-          </p:nvPr>
-        </p:nvSpPr>
-        <p:spPr/>
-        <p:txBody>
-          <a:bodyPr>
-            <a:normAutofit/>
-          </a:bodyPr>
-          <a:lstStyle/>
-          <a:p>
-            <a:r>
-              <a:rPr lang="en-US" dirty="0"/>
-              <a:t>~ </a:t>
-            </a:r>
-            <a:r>
-              <a:rPr lang="en-GB" dirty="0"/>
-              <a:t>Functional Requirements </a:t>
-            </a:r>
-            <a:r>
-              <a:rPr lang="en-US" dirty="0"/>
-              <a:t>~</a:t>
-            </a:r>
-          </a:p>
-        </p:txBody>
-      </p:sp>
-      <p:graphicFrame>
-        <p:nvGraphicFramePr>
-          <p:cNvPr id="19" name="Text Placeholder 16">
-            <a:extLst>
-              <a:ext uri="{FF2B5EF4-FFF2-40B4-BE49-F238E27FC236}">
-                <a16:creationId xmlns:a16="http://schemas.microsoft.com/office/drawing/2014/main" id="{D6C29C33-791D-62A9-1E9E-96FB10000C2B}"/>
-              </a:ext>
-            </a:extLst>
-          </p:cNvPr>
-          <p:cNvGraphicFramePr/>
-          <p:nvPr>
-            <p:extLst>
-              <p:ext uri="{D42A27DB-BD31-4B8C-83A1-F6EECF244321}">
-                <p14:modId xmlns:p14="http://schemas.microsoft.com/office/powerpoint/2010/main" val="858922307"/>
-              </p:ext>
-            </p:extLst>
-          </p:nvPr>
-        </p:nvGraphicFramePr>
-        <p:xfrm>
-          <a:off x="1379040" y="2032912"/>
-          <a:ext cx="9425449" cy="4266960"/>
-        </p:xfrm>
-        <a:graphic>
-          <a:graphicData uri="http://schemas.openxmlformats.org/drawingml/2006/diagram">
-            <dgm:relIds xmlns:dgm="http://schemas.openxmlformats.org/drawingml/2006/diagram" xmlns:r="http://schemas.openxmlformats.org/officeDocument/2006/relationships" r:dm="rId3" r:lo="rId4" r:qs="rId5" r:cs="rId6"/>
-          </a:graphicData>
-        </a:graphic>
-      </p:graphicFrame>
-    </p:spTree>
-    <p:extLst>
-      <p:ext uri="{BB962C8B-B14F-4D97-AF65-F5344CB8AC3E}">
-        <p14:creationId xmlns:p14="http://schemas.microsoft.com/office/powerpoint/2010/main" val="1382077199"/>
-      </p:ext>
-    </p:extLst>
-  </p:cSld>
-  <p:clrMapOvr>
-    <a:masterClrMapping/>
-  </p:clrMapOvr>
-</p:sld>
-</file>
-
-<file path=ppt/slides/slide11.xml><?xml version="1.0" encoding="utf-8"?>
-<p:sld xmlns:a="http://schemas.openxmlformats.org/drawingml/2006/main" xmlns:r="http://schemas.openxmlformats.org/officeDocument/2006/relationships" xmlns:p="http://schemas.openxmlformats.org/presentationml/2006/main">
-  <p:cSld>
-    <p:spTree>
-      <p:nvGrpSpPr>
-        <p:cNvPr id="1" name="">
-          <a:extLst>
-            <a:ext uri="{FF2B5EF4-FFF2-40B4-BE49-F238E27FC236}">
               <a16:creationId xmlns:a16="http://schemas.microsoft.com/office/drawing/2014/main" id="{333CA710-6CFC-6208-4A97-590C71129499}"/>
             </a:ext>
           </a:extLst>
@@ -24955,7 +21720,7 @@
 </p:sld>
 </file>
 
-<file path=ppt/slides/slide12.xml><?xml version="1.0" encoding="utf-8"?>
+<file path=ppt/slides/slide11.xml><?xml version="1.0" encoding="utf-8"?>
 <p:sld xmlns:a="http://schemas.openxmlformats.org/drawingml/2006/main" xmlns:r="http://schemas.openxmlformats.org/officeDocument/2006/relationships" xmlns:p="http://schemas.openxmlformats.org/presentationml/2006/main">
   <p:cSld>
     <p:spTree>
@@ -25106,7 +21871,7 @@
 </p:sld>
 </file>
 
-<file path=ppt/slides/slide13.xml><?xml version="1.0" encoding="utf-8"?>
+<file path=ppt/slides/slide12.xml><?xml version="1.0" encoding="utf-8"?>
 <p:sld xmlns:a="http://schemas.openxmlformats.org/drawingml/2006/main" xmlns:r="http://schemas.openxmlformats.org/officeDocument/2006/relationships" xmlns:p="http://schemas.openxmlformats.org/presentationml/2006/main">
   <p:cSld>
     <p:spTree>
@@ -25178,7 +21943,7 @@
 </p:sld>
 </file>
 
-<file path=ppt/slides/slide14.xml><?xml version="1.0" encoding="utf-8"?>
+<file path=ppt/slides/slide13.xml><?xml version="1.0" encoding="utf-8"?>
 <p:sld xmlns:a="http://schemas.openxmlformats.org/drawingml/2006/main" xmlns:r="http://schemas.openxmlformats.org/officeDocument/2006/relationships" xmlns:p="http://schemas.openxmlformats.org/presentationml/2006/main">
   <p:cSld>
     <p:spTree>
@@ -25279,7 +22044,7 @@
 </p:sld>
 </file>
 
-<file path=ppt/slides/slide15.xml><?xml version="1.0" encoding="utf-8"?>
+<file path=ppt/slides/slide14.xml><?xml version="1.0" encoding="utf-8"?>
 <p:sld xmlns:a="http://schemas.openxmlformats.org/drawingml/2006/main" xmlns:r="http://schemas.openxmlformats.org/officeDocument/2006/relationships" xmlns:p="http://schemas.openxmlformats.org/presentationml/2006/main">
   <p:cSld>
     <p:spTree>
@@ -25373,7 +22138,7 @@
 </p:sld>
 </file>
 
-<file path=ppt/slides/slide16.xml><?xml version="1.0" encoding="utf-8"?>
+<file path=ppt/slides/slide15.xml><?xml version="1.0" encoding="utf-8"?>
 <p:sld xmlns:a="http://schemas.openxmlformats.org/drawingml/2006/main" xmlns:r="http://schemas.openxmlformats.org/officeDocument/2006/relationships" xmlns:p="http://schemas.openxmlformats.org/presentationml/2006/main">
   <p:cSld>
     <p:spTree>
@@ -25473,7 +22238,7 @@
 </p:sld>
 </file>
 
-<file path=ppt/slides/slide17.xml><?xml version="1.0" encoding="utf-8"?>
+<file path=ppt/slides/slide16.xml><?xml version="1.0" encoding="utf-8"?>
 <p:sld xmlns:a="http://schemas.openxmlformats.org/drawingml/2006/main" xmlns:r="http://schemas.openxmlformats.org/officeDocument/2006/relationships" xmlns:p="http://schemas.openxmlformats.org/presentationml/2006/main">
   <p:cSld>
     <p:spTree>
@@ -25573,7 +22338,7 @@
 </p:sld>
 </file>
 
-<file path=ppt/slides/slide18.xml><?xml version="1.0" encoding="utf-8"?>
+<file path=ppt/slides/slide17.xml><?xml version="1.0" encoding="utf-8"?>
 <p:sld xmlns:a="http://schemas.openxmlformats.org/drawingml/2006/main" xmlns:r="http://schemas.openxmlformats.org/officeDocument/2006/relationships" xmlns:p="http://schemas.openxmlformats.org/presentationml/2006/main">
   <p:cSld>
     <p:spTree>
@@ -25673,7 +22438,7 @@
 </p:sld>
 </file>
 
-<file path=ppt/slides/slide19.xml><?xml version="1.0" encoding="utf-8"?>
+<file path=ppt/slides/slide18.xml><?xml version="1.0" encoding="utf-8"?>
 <p:sld xmlns:a="http://schemas.openxmlformats.org/drawingml/2006/main" xmlns:r="http://schemas.openxmlformats.org/officeDocument/2006/relationships" xmlns:p="http://schemas.openxmlformats.org/presentationml/2006/main">
   <p:cSld>
     <p:spTree>
@@ -25965,128 +22730,7 @@
 </p:sld>
 </file>
 
-<file path=ppt/slides/slide2.xml><?xml version="1.0" encoding="utf-8"?>
-<p:sld xmlns:a="http://schemas.openxmlformats.org/drawingml/2006/main" xmlns:r="http://schemas.openxmlformats.org/officeDocument/2006/relationships" xmlns:p="http://schemas.openxmlformats.org/presentationml/2006/main">
-  <p:cSld>
-    <p:spTree>
-      <p:nvGrpSpPr>
-        <p:cNvPr id="1" name=""/>
-        <p:cNvGrpSpPr/>
-        <p:nvPr/>
-      </p:nvGrpSpPr>
-      <p:grpSpPr>
-        <a:xfrm>
-          <a:off x="0" y="0"/>
-          <a:ext cx="0" cy="0"/>
-          <a:chOff x="0" y="0"/>
-          <a:chExt cx="0" cy="0"/>
-        </a:xfrm>
-      </p:grpSpPr>
-      <p:sp>
-        <p:nvSpPr>
-          <p:cNvPr id="22" name="TextBox 21">
-            <a:extLst>
-              <a:ext uri="{FF2B5EF4-FFF2-40B4-BE49-F238E27FC236}">
-                <a16:creationId xmlns:a16="http://schemas.microsoft.com/office/drawing/2014/main" id="{C73B92BC-AD80-2DBF-3251-6293794FA7EF}"/>
-              </a:ext>
-            </a:extLst>
-          </p:cNvPr>
-          <p:cNvSpPr txBox="1"/>
-          <p:nvPr/>
-        </p:nvSpPr>
-        <p:spPr>
-          <a:xfrm>
-            <a:off x="3055172" y="3124661"/>
-            <a:ext cx="6110342" cy="646331"/>
-          </a:xfrm>
-          <a:prstGeom prst="rect">
-            <a:avLst/>
-          </a:prstGeom>
-          <a:noFill/>
-        </p:spPr>
-        <p:txBody>
-          <a:bodyPr wrap="square">
-            <a:spAutoFit/>
-          </a:bodyPr>
-          <a:lstStyle/>
-          <a:p>
-            <a:br>
-              <a:rPr lang="en-US"/>
-            </a:br>
-            <a:endParaRPr lang="en-US" dirty="0"/>
-          </a:p>
-        </p:txBody>
-      </p:sp>
-      <p:sp>
-        <p:nvSpPr>
-          <p:cNvPr id="32" name="Title 31">
-            <a:extLst>
-              <a:ext uri="{FF2B5EF4-FFF2-40B4-BE49-F238E27FC236}">
-                <a16:creationId xmlns:a16="http://schemas.microsoft.com/office/drawing/2014/main" id="{0BAFF2D8-A2DB-8307-044B-5F69514CA011}"/>
-              </a:ext>
-            </a:extLst>
-          </p:cNvPr>
-          <p:cNvSpPr>
-            <a:spLocks noGrp="1"/>
-          </p:cNvSpPr>
-          <p:nvPr>
-            <p:ph type="title"/>
-          </p:nvPr>
-        </p:nvSpPr>
-        <p:spPr/>
-        <p:txBody>
-          <a:bodyPr/>
-          <a:lstStyle/>
-          <a:p>
-            <a:r>
-              <a:rPr lang="en-US" dirty="0"/>
-              <a:t>~ Agenda ~</a:t>
-            </a:r>
-          </a:p>
-        </p:txBody>
-      </p:sp>
-      <p:graphicFrame>
-        <p:nvGraphicFramePr>
-          <p:cNvPr id="39" name="Text Placeholder 33">
-            <a:extLst>
-              <a:ext uri="{FF2B5EF4-FFF2-40B4-BE49-F238E27FC236}">
-                <a16:creationId xmlns:a16="http://schemas.microsoft.com/office/drawing/2014/main" id="{FDCE3B2F-0BAF-7D78-9371-7D77DC9A51A1}"/>
-              </a:ext>
-            </a:extLst>
-          </p:cNvPr>
-          <p:cNvGraphicFramePr/>
-          <p:nvPr>
-            <p:extLst>
-              <p:ext uri="{D42A27DB-BD31-4B8C-83A1-F6EECF244321}">
-                <p14:modId xmlns:p14="http://schemas.microsoft.com/office/powerpoint/2010/main" val="4262603709"/>
-              </p:ext>
-            </p:extLst>
-          </p:nvPr>
-        </p:nvGraphicFramePr>
-        <p:xfrm>
-          <a:off x="1051823" y="2250120"/>
-          <a:ext cx="10088353" cy="3462422"/>
-        </p:xfrm>
-        <a:graphic>
-          <a:graphicData uri="http://schemas.openxmlformats.org/drawingml/2006/diagram">
-            <dgm:relIds xmlns:dgm="http://schemas.openxmlformats.org/drawingml/2006/diagram" xmlns:r="http://schemas.openxmlformats.org/officeDocument/2006/relationships" r:dm="rId2" r:lo="rId3" r:qs="rId4" r:cs="rId5"/>
-          </a:graphicData>
-        </a:graphic>
-      </p:graphicFrame>
-    </p:spTree>
-    <p:extLst>
-      <p:ext uri="{BB962C8B-B14F-4D97-AF65-F5344CB8AC3E}">
-        <p14:creationId xmlns:p14="http://schemas.microsoft.com/office/powerpoint/2010/main" val="2915912272"/>
-      </p:ext>
-    </p:extLst>
-  </p:cSld>
-  <p:clrMapOvr>
-    <a:masterClrMapping/>
-  </p:clrMapOvr>
-</p:sld>
-</file>
-
-<file path=ppt/slides/slide20.xml><?xml version="1.0" encoding="utf-8"?>
+<file path=ppt/slides/slide19.xml><?xml version="1.0" encoding="utf-8"?>
 <p:sld xmlns:a="http://schemas.openxmlformats.org/drawingml/2006/main" xmlns:r="http://schemas.openxmlformats.org/officeDocument/2006/relationships" xmlns:p="http://schemas.openxmlformats.org/presentationml/2006/main">
   <p:cSld>
     <p:spTree>
@@ -26186,276 +22830,7 @@
 </p:sld>
 </file>
 
-<file path=ppt/slides/slide21.xml><?xml version="1.0" encoding="utf-8"?>
-<p:sld xmlns:a="http://schemas.openxmlformats.org/drawingml/2006/main" xmlns:r="http://schemas.openxmlformats.org/officeDocument/2006/relationships" xmlns:p="http://schemas.openxmlformats.org/presentationml/2006/main">
-  <p:cSld>
-    <p:spTree>
-      <p:nvGrpSpPr>
-        <p:cNvPr id="1" name="">
-          <a:extLst>
-            <a:ext uri="{FF2B5EF4-FFF2-40B4-BE49-F238E27FC236}">
-              <a16:creationId xmlns:a16="http://schemas.microsoft.com/office/drawing/2014/main" id="{5EC5FF81-2C38-9635-1C9A-C3572A21C92D}"/>
-            </a:ext>
-          </a:extLst>
-        </p:cNvPr>
-        <p:cNvGrpSpPr/>
-        <p:nvPr/>
-      </p:nvGrpSpPr>
-      <p:grpSpPr>
-        <a:xfrm>
-          <a:off x="0" y="0"/>
-          <a:ext cx="0" cy="0"/>
-          <a:chOff x="0" y="0"/>
-          <a:chExt cx="0" cy="0"/>
-        </a:xfrm>
-      </p:grpSpPr>
-      <p:sp>
-        <p:nvSpPr>
-          <p:cNvPr id="5" name="Title 4">
-            <a:extLst>
-              <a:ext uri="{FF2B5EF4-FFF2-40B4-BE49-F238E27FC236}">
-                <a16:creationId xmlns:a16="http://schemas.microsoft.com/office/drawing/2014/main" id="{D625F2EF-E6F8-99B2-D293-DD3F6D1FFAA2}"/>
-              </a:ext>
-            </a:extLst>
-          </p:cNvPr>
-          <p:cNvSpPr>
-            <a:spLocks noGrp="1"/>
-          </p:cNvSpPr>
-          <p:nvPr>
-            <p:ph type="title"/>
-          </p:nvPr>
-        </p:nvSpPr>
-        <p:spPr>
-          <a:xfrm>
-            <a:off x="0" y="0"/>
-            <a:ext cx="12192000" cy="432619"/>
-          </a:xfrm>
-        </p:spPr>
-        <p:txBody>
-          <a:bodyPr>
-            <a:noAutofit/>
-          </a:bodyPr>
-          <a:lstStyle/>
-          <a:p>
-            <a:r>
-              <a:rPr lang="en-US" sz="2000" dirty="0"/>
-              <a:t>~ Design Diagram – State Diagram ~</a:t>
-            </a:r>
-          </a:p>
-        </p:txBody>
-      </p:sp>
-      <p:pic>
-        <p:nvPicPr>
-          <p:cNvPr id="3" name="Picture 2">
-            <a:extLst>
-              <a:ext uri="{FF2B5EF4-FFF2-40B4-BE49-F238E27FC236}">
-                <a16:creationId xmlns:a16="http://schemas.microsoft.com/office/drawing/2014/main" id="{D805DC71-449C-8A22-697A-563DFC055321}"/>
-              </a:ext>
-            </a:extLst>
-          </p:cNvPr>
-          <p:cNvPicPr>
-            <a:picLocks noChangeAspect="1"/>
-          </p:cNvPicPr>
-          <p:nvPr/>
-        </p:nvPicPr>
-        <p:blipFill>
-          <a:blip r:embed="rId2"/>
-          <a:srcRect/>
-          <a:stretch/>
-        </p:blipFill>
-        <p:spPr>
-          <a:xfrm>
-            <a:off x="2885786" y="615075"/>
-            <a:ext cx="6420426" cy="5746396"/>
-          </a:xfrm>
-          <a:prstGeom prst="rect">
-            <a:avLst/>
-          </a:prstGeom>
-        </p:spPr>
-      </p:pic>
-    </p:spTree>
-    <p:extLst>
-      <p:ext uri="{BB962C8B-B14F-4D97-AF65-F5344CB8AC3E}">
-        <p14:creationId xmlns:p14="http://schemas.microsoft.com/office/powerpoint/2010/main" val="1843695874"/>
-      </p:ext>
-    </p:extLst>
-  </p:cSld>
-  <p:clrMapOvr>
-    <a:masterClrMapping/>
-  </p:clrMapOvr>
-</p:sld>
-</file>
-
-<file path=ppt/slides/slide22.xml><?xml version="1.0" encoding="utf-8"?>
-<p:sld xmlns:a="http://schemas.openxmlformats.org/drawingml/2006/main" xmlns:r="http://schemas.openxmlformats.org/officeDocument/2006/relationships" xmlns:p="http://schemas.openxmlformats.org/presentationml/2006/main">
-  <p:cSld>
-    <p:spTree>
-      <p:nvGrpSpPr>
-        <p:cNvPr id="1" name="">
-          <a:extLst>
-            <a:ext uri="{FF2B5EF4-FFF2-40B4-BE49-F238E27FC236}">
-              <a16:creationId xmlns:a16="http://schemas.microsoft.com/office/drawing/2014/main" id="{F0B5B925-C048-D258-AFE6-613388F51C8A}"/>
-            </a:ext>
-          </a:extLst>
-        </p:cNvPr>
-        <p:cNvGrpSpPr/>
-        <p:nvPr/>
-      </p:nvGrpSpPr>
-      <p:grpSpPr>
-        <a:xfrm>
-          <a:off x="0" y="0"/>
-          <a:ext cx="0" cy="0"/>
-          <a:chOff x="0" y="0"/>
-          <a:chExt cx="0" cy="0"/>
-        </a:xfrm>
-      </p:grpSpPr>
-      <p:sp>
-        <p:nvSpPr>
-          <p:cNvPr id="5" name="Title 4">
-            <a:extLst>
-              <a:ext uri="{FF2B5EF4-FFF2-40B4-BE49-F238E27FC236}">
-                <a16:creationId xmlns:a16="http://schemas.microsoft.com/office/drawing/2014/main" id="{540F71C5-36D9-5349-68EC-FDEE748146E2}"/>
-              </a:ext>
-            </a:extLst>
-          </p:cNvPr>
-          <p:cNvSpPr>
-            <a:spLocks noGrp="1"/>
-          </p:cNvSpPr>
-          <p:nvPr>
-            <p:ph type="title"/>
-          </p:nvPr>
-        </p:nvSpPr>
-        <p:spPr>
-          <a:xfrm>
-            <a:off x="0" y="0"/>
-            <a:ext cx="12192000" cy="432619"/>
-          </a:xfrm>
-        </p:spPr>
-        <p:txBody>
-          <a:bodyPr>
-            <a:noAutofit/>
-          </a:bodyPr>
-          <a:lstStyle/>
-          <a:p>
-            <a:r>
-              <a:rPr lang="en-US" sz="2000" dirty="0"/>
-              <a:t>~ Design Diagram – Data Flow Diagram ~</a:t>
-            </a:r>
-          </a:p>
-        </p:txBody>
-      </p:sp>
-      <p:pic>
-        <p:nvPicPr>
-          <p:cNvPr id="3" name="Picture 2">
-            <a:extLst>
-              <a:ext uri="{FF2B5EF4-FFF2-40B4-BE49-F238E27FC236}">
-                <a16:creationId xmlns:a16="http://schemas.microsoft.com/office/drawing/2014/main" id="{4F0C48AF-F410-E0BE-DF4B-87B4C26CC3D8}"/>
-              </a:ext>
-            </a:extLst>
-          </p:cNvPr>
-          <p:cNvPicPr>
-            <a:picLocks noChangeAspect="1"/>
-          </p:cNvPicPr>
-          <p:nvPr/>
-        </p:nvPicPr>
-        <p:blipFill>
-          <a:blip r:embed="rId2"/>
-          <a:srcRect/>
-          <a:stretch/>
-        </p:blipFill>
-        <p:spPr>
-          <a:xfrm>
-            <a:off x="2751234" y="717494"/>
-            <a:ext cx="6689531" cy="5560746"/>
-          </a:xfrm>
-          <a:prstGeom prst="rect">
-            <a:avLst/>
-          </a:prstGeom>
-        </p:spPr>
-      </p:pic>
-    </p:spTree>
-    <p:extLst>
-      <p:ext uri="{BB962C8B-B14F-4D97-AF65-F5344CB8AC3E}">
-        <p14:creationId xmlns:p14="http://schemas.microsoft.com/office/powerpoint/2010/main" val="2487518773"/>
-      </p:ext>
-    </p:extLst>
-  </p:cSld>
-  <p:clrMapOvr>
-    <a:masterClrMapping/>
-  </p:clrMapOvr>
-</p:sld>
-</file>
-
-<file path=ppt/slides/slide23.xml><?xml version="1.0" encoding="utf-8"?>
-<p:sld xmlns:a="http://schemas.openxmlformats.org/drawingml/2006/main" xmlns:r="http://schemas.openxmlformats.org/officeDocument/2006/relationships" xmlns:p="http://schemas.openxmlformats.org/presentationml/2006/main">
-  <p:cSld>
-    <p:spTree>
-      <p:nvGrpSpPr>
-        <p:cNvPr id="1" name="">
-          <a:extLst>
-            <a:ext uri="{FF2B5EF4-FFF2-40B4-BE49-F238E27FC236}">
-              <a16:creationId xmlns:a16="http://schemas.microsoft.com/office/drawing/2014/main" id="{39E9DC12-B16C-FFFA-EF63-8326B8B5DE3C}"/>
-            </a:ext>
-          </a:extLst>
-        </p:cNvPr>
-        <p:cNvGrpSpPr/>
-        <p:nvPr/>
-      </p:nvGrpSpPr>
-      <p:grpSpPr>
-        <a:xfrm>
-          <a:off x="0" y="0"/>
-          <a:ext cx="0" cy="0"/>
-          <a:chOff x="0" y="0"/>
-          <a:chExt cx="0" cy="0"/>
-        </a:xfrm>
-      </p:grpSpPr>
-      <p:sp>
-        <p:nvSpPr>
-          <p:cNvPr id="2" name="Title 1">
-            <a:extLst>
-              <a:ext uri="{FF2B5EF4-FFF2-40B4-BE49-F238E27FC236}">
-                <a16:creationId xmlns:a16="http://schemas.microsoft.com/office/drawing/2014/main" id="{C4A466C9-5E3B-43D1-503D-4E6AB530D3F5}"/>
-              </a:ext>
-            </a:extLst>
-          </p:cNvPr>
-          <p:cNvSpPr>
-            <a:spLocks noGrp="1"/>
-          </p:cNvSpPr>
-          <p:nvPr>
-            <p:ph type="title"/>
-          </p:nvPr>
-        </p:nvSpPr>
-        <p:spPr>
-          <a:xfrm>
-            <a:off x="507539" y="881807"/>
-            <a:ext cx="11176922" cy="5094386"/>
-          </a:xfrm>
-        </p:spPr>
-        <p:txBody>
-          <a:bodyPr/>
-          <a:lstStyle/>
-          <a:p>
-            <a:r>
-              <a:rPr lang="en-US" dirty="0"/>
-              <a:t>Thank you</a:t>
-            </a:r>
-          </a:p>
-        </p:txBody>
-      </p:sp>
-    </p:spTree>
-    <p:extLst>
-      <p:ext uri="{BB962C8B-B14F-4D97-AF65-F5344CB8AC3E}">
-        <p14:creationId xmlns:p14="http://schemas.microsoft.com/office/powerpoint/2010/main" val="3869475363"/>
-      </p:ext>
-    </p:extLst>
-  </p:cSld>
-  <p:clrMapOvr>
-    <a:masterClrMapping/>
-  </p:clrMapOvr>
-</p:sld>
-</file>
-
-<file path=ppt/slides/slide3.xml><?xml version="1.0" encoding="utf-8"?>
+<file path=ppt/slides/slide2.xml><?xml version="1.0" encoding="utf-8"?>
 <p:sld xmlns:a="http://schemas.openxmlformats.org/drawingml/2006/main" xmlns:r="http://schemas.openxmlformats.org/officeDocument/2006/relationships" xmlns:p="http://schemas.openxmlformats.org/presentationml/2006/main">
   <p:cSld>
     <p:spTree>
@@ -26661,7 +23036,276 @@
 </p:sld>
 </file>
 
-<file path=ppt/slides/slide4.xml><?xml version="1.0" encoding="utf-8"?>
+<file path=ppt/slides/slide20.xml><?xml version="1.0" encoding="utf-8"?>
+<p:sld xmlns:a="http://schemas.openxmlformats.org/drawingml/2006/main" xmlns:r="http://schemas.openxmlformats.org/officeDocument/2006/relationships" xmlns:p="http://schemas.openxmlformats.org/presentationml/2006/main">
+  <p:cSld>
+    <p:spTree>
+      <p:nvGrpSpPr>
+        <p:cNvPr id="1" name="">
+          <a:extLst>
+            <a:ext uri="{FF2B5EF4-FFF2-40B4-BE49-F238E27FC236}">
+              <a16:creationId xmlns:a16="http://schemas.microsoft.com/office/drawing/2014/main" id="{5EC5FF81-2C38-9635-1C9A-C3572A21C92D}"/>
+            </a:ext>
+          </a:extLst>
+        </p:cNvPr>
+        <p:cNvGrpSpPr/>
+        <p:nvPr/>
+      </p:nvGrpSpPr>
+      <p:grpSpPr>
+        <a:xfrm>
+          <a:off x="0" y="0"/>
+          <a:ext cx="0" cy="0"/>
+          <a:chOff x="0" y="0"/>
+          <a:chExt cx="0" cy="0"/>
+        </a:xfrm>
+      </p:grpSpPr>
+      <p:sp>
+        <p:nvSpPr>
+          <p:cNvPr id="5" name="Title 4">
+            <a:extLst>
+              <a:ext uri="{FF2B5EF4-FFF2-40B4-BE49-F238E27FC236}">
+                <a16:creationId xmlns:a16="http://schemas.microsoft.com/office/drawing/2014/main" id="{D625F2EF-E6F8-99B2-D293-DD3F6D1FFAA2}"/>
+              </a:ext>
+            </a:extLst>
+          </p:cNvPr>
+          <p:cNvSpPr>
+            <a:spLocks noGrp="1"/>
+          </p:cNvSpPr>
+          <p:nvPr>
+            <p:ph type="title"/>
+          </p:nvPr>
+        </p:nvSpPr>
+        <p:spPr>
+          <a:xfrm>
+            <a:off x="0" y="0"/>
+            <a:ext cx="12192000" cy="432619"/>
+          </a:xfrm>
+        </p:spPr>
+        <p:txBody>
+          <a:bodyPr>
+            <a:noAutofit/>
+          </a:bodyPr>
+          <a:lstStyle/>
+          <a:p>
+            <a:r>
+              <a:rPr lang="en-US" sz="2000" dirty="0"/>
+              <a:t>~ Design Diagram – State Diagram ~</a:t>
+            </a:r>
+          </a:p>
+        </p:txBody>
+      </p:sp>
+      <p:pic>
+        <p:nvPicPr>
+          <p:cNvPr id="3" name="Picture 2">
+            <a:extLst>
+              <a:ext uri="{FF2B5EF4-FFF2-40B4-BE49-F238E27FC236}">
+                <a16:creationId xmlns:a16="http://schemas.microsoft.com/office/drawing/2014/main" id="{D805DC71-449C-8A22-697A-563DFC055321}"/>
+              </a:ext>
+            </a:extLst>
+          </p:cNvPr>
+          <p:cNvPicPr>
+            <a:picLocks noChangeAspect="1"/>
+          </p:cNvPicPr>
+          <p:nvPr/>
+        </p:nvPicPr>
+        <p:blipFill>
+          <a:blip r:embed="rId2"/>
+          <a:srcRect/>
+          <a:stretch/>
+        </p:blipFill>
+        <p:spPr>
+          <a:xfrm>
+            <a:off x="2885786" y="615075"/>
+            <a:ext cx="6420426" cy="5746396"/>
+          </a:xfrm>
+          <a:prstGeom prst="rect">
+            <a:avLst/>
+          </a:prstGeom>
+        </p:spPr>
+      </p:pic>
+    </p:spTree>
+    <p:extLst>
+      <p:ext uri="{BB962C8B-B14F-4D97-AF65-F5344CB8AC3E}">
+        <p14:creationId xmlns:p14="http://schemas.microsoft.com/office/powerpoint/2010/main" val="1843695874"/>
+      </p:ext>
+    </p:extLst>
+  </p:cSld>
+  <p:clrMapOvr>
+    <a:masterClrMapping/>
+  </p:clrMapOvr>
+</p:sld>
+</file>
+
+<file path=ppt/slides/slide21.xml><?xml version="1.0" encoding="utf-8"?>
+<p:sld xmlns:a="http://schemas.openxmlformats.org/drawingml/2006/main" xmlns:r="http://schemas.openxmlformats.org/officeDocument/2006/relationships" xmlns:p="http://schemas.openxmlformats.org/presentationml/2006/main">
+  <p:cSld>
+    <p:spTree>
+      <p:nvGrpSpPr>
+        <p:cNvPr id="1" name="">
+          <a:extLst>
+            <a:ext uri="{FF2B5EF4-FFF2-40B4-BE49-F238E27FC236}">
+              <a16:creationId xmlns:a16="http://schemas.microsoft.com/office/drawing/2014/main" id="{F0B5B925-C048-D258-AFE6-613388F51C8A}"/>
+            </a:ext>
+          </a:extLst>
+        </p:cNvPr>
+        <p:cNvGrpSpPr/>
+        <p:nvPr/>
+      </p:nvGrpSpPr>
+      <p:grpSpPr>
+        <a:xfrm>
+          <a:off x="0" y="0"/>
+          <a:ext cx="0" cy="0"/>
+          <a:chOff x="0" y="0"/>
+          <a:chExt cx="0" cy="0"/>
+        </a:xfrm>
+      </p:grpSpPr>
+      <p:sp>
+        <p:nvSpPr>
+          <p:cNvPr id="5" name="Title 4">
+            <a:extLst>
+              <a:ext uri="{FF2B5EF4-FFF2-40B4-BE49-F238E27FC236}">
+                <a16:creationId xmlns:a16="http://schemas.microsoft.com/office/drawing/2014/main" id="{540F71C5-36D9-5349-68EC-FDEE748146E2}"/>
+              </a:ext>
+            </a:extLst>
+          </p:cNvPr>
+          <p:cNvSpPr>
+            <a:spLocks noGrp="1"/>
+          </p:cNvSpPr>
+          <p:nvPr>
+            <p:ph type="title"/>
+          </p:nvPr>
+        </p:nvSpPr>
+        <p:spPr>
+          <a:xfrm>
+            <a:off x="0" y="0"/>
+            <a:ext cx="12192000" cy="432619"/>
+          </a:xfrm>
+        </p:spPr>
+        <p:txBody>
+          <a:bodyPr>
+            <a:noAutofit/>
+          </a:bodyPr>
+          <a:lstStyle/>
+          <a:p>
+            <a:r>
+              <a:rPr lang="en-US" sz="2000" dirty="0"/>
+              <a:t>~ Design Diagram – Data Flow Diagram ~</a:t>
+            </a:r>
+          </a:p>
+        </p:txBody>
+      </p:sp>
+      <p:pic>
+        <p:nvPicPr>
+          <p:cNvPr id="3" name="Picture 2">
+            <a:extLst>
+              <a:ext uri="{FF2B5EF4-FFF2-40B4-BE49-F238E27FC236}">
+                <a16:creationId xmlns:a16="http://schemas.microsoft.com/office/drawing/2014/main" id="{4F0C48AF-F410-E0BE-DF4B-87B4C26CC3D8}"/>
+              </a:ext>
+            </a:extLst>
+          </p:cNvPr>
+          <p:cNvPicPr>
+            <a:picLocks noChangeAspect="1"/>
+          </p:cNvPicPr>
+          <p:nvPr/>
+        </p:nvPicPr>
+        <p:blipFill>
+          <a:blip r:embed="rId2"/>
+          <a:srcRect/>
+          <a:stretch/>
+        </p:blipFill>
+        <p:spPr>
+          <a:xfrm>
+            <a:off x="2751234" y="717494"/>
+            <a:ext cx="6689531" cy="5560746"/>
+          </a:xfrm>
+          <a:prstGeom prst="rect">
+            <a:avLst/>
+          </a:prstGeom>
+        </p:spPr>
+      </p:pic>
+    </p:spTree>
+    <p:extLst>
+      <p:ext uri="{BB962C8B-B14F-4D97-AF65-F5344CB8AC3E}">
+        <p14:creationId xmlns:p14="http://schemas.microsoft.com/office/powerpoint/2010/main" val="2487518773"/>
+      </p:ext>
+    </p:extLst>
+  </p:cSld>
+  <p:clrMapOvr>
+    <a:masterClrMapping/>
+  </p:clrMapOvr>
+</p:sld>
+</file>
+
+<file path=ppt/slides/slide22.xml><?xml version="1.0" encoding="utf-8"?>
+<p:sld xmlns:a="http://schemas.openxmlformats.org/drawingml/2006/main" xmlns:r="http://schemas.openxmlformats.org/officeDocument/2006/relationships" xmlns:p="http://schemas.openxmlformats.org/presentationml/2006/main">
+  <p:cSld>
+    <p:spTree>
+      <p:nvGrpSpPr>
+        <p:cNvPr id="1" name="">
+          <a:extLst>
+            <a:ext uri="{FF2B5EF4-FFF2-40B4-BE49-F238E27FC236}">
+              <a16:creationId xmlns:a16="http://schemas.microsoft.com/office/drawing/2014/main" id="{39E9DC12-B16C-FFFA-EF63-8326B8B5DE3C}"/>
+            </a:ext>
+          </a:extLst>
+        </p:cNvPr>
+        <p:cNvGrpSpPr/>
+        <p:nvPr/>
+      </p:nvGrpSpPr>
+      <p:grpSpPr>
+        <a:xfrm>
+          <a:off x="0" y="0"/>
+          <a:ext cx="0" cy="0"/>
+          <a:chOff x="0" y="0"/>
+          <a:chExt cx="0" cy="0"/>
+        </a:xfrm>
+      </p:grpSpPr>
+      <p:sp>
+        <p:nvSpPr>
+          <p:cNvPr id="2" name="Title 1">
+            <a:extLst>
+              <a:ext uri="{FF2B5EF4-FFF2-40B4-BE49-F238E27FC236}">
+                <a16:creationId xmlns:a16="http://schemas.microsoft.com/office/drawing/2014/main" id="{C4A466C9-5E3B-43D1-503D-4E6AB530D3F5}"/>
+              </a:ext>
+            </a:extLst>
+          </p:cNvPr>
+          <p:cNvSpPr>
+            <a:spLocks noGrp="1"/>
+          </p:cNvSpPr>
+          <p:nvPr>
+            <p:ph type="title"/>
+          </p:nvPr>
+        </p:nvSpPr>
+        <p:spPr>
+          <a:xfrm>
+            <a:off x="507539" y="881807"/>
+            <a:ext cx="11176922" cy="5094386"/>
+          </a:xfrm>
+        </p:spPr>
+        <p:txBody>
+          <a:bodyPr/>
+          <a:lstStyle/>
+          <a:p>
+            <a:r>
+              <a:rPr lang="en-US" dirty="0"/>
+              <a:t>Thank you</a:t>
+            </a:r>
+          </a:p>
+        </p:txBody>
+      </p:sp>
+    </p:spTree>
+    <p:extLst>
+      <p:ext uri="{BB962C8B-B14F-4D97-AF65-F5344CB8AC3E}">
+        <p14:creationId xmlns:p14="http://schemas.microsoft.com/office/powerpoint/2010/main" val="3869475363"/>
+      </p:ext>
+    </p:extLst>
+  </p:cSld>
+  <p:clrMapOvr>
+    <a:masterClrMapping/>
+  </p:clrMapOvr>
+</p:sld>
+</file>
+
+<file path=ppt/slides/slide3.xml><?xml version="1.0" encoding="utf-8"?>
 <p:sld xmlns:a="http://schemas.openxmlformats.org/drawingml/2006/main" xmlns:r="http://schemas.openxmlformats.org/officeDocument/2006/relationships" xmlns:p="http://schemas.openxmlformats.org/presentationml/2006/main">
   <p:cSld>
     <p:spTree>
@@ -26786,7 +23430,7 @@
 </p:sld>
 </file>
 
-<file path=ppt/slides/slide5.xml><?xml version="1.0" encoding="utf-8"?>
+<file path=ppt/slides/slide4.xml><?xml version="1.0" encoding="utf-8"?>
 <p:sld xmlns:a="http://schemas.openxmlformats.org/drawingml/2006/main" xmlns:r="http://schemas.openxmlformats.org/officeDocument/2006/relationships" xmlns:p="http://schemas.openxmlformats.org/presentationml/2006/main">
   <p:cSld>
     <p:spTree>
@@ -26979,7 +23623,7 @@
 </p:sld>
 </file>
 
-<file path=ppt/slides/slide6.xml><?xml version="1.0" encoding="utf-8"?>
+<file path=ppt/slides/slide5.xml><?xml version="1.0" encoding="utf-8"?>
 <p:sld xmlns:a="http://schemas.openxmlformats.org/drawingml/2006/main" xmlns:r="http://schemas.openxmlformats.org/officeDocument/2006/relationships" xmlns:p="http://schemas.openxmlformats.org/presentationml/2006/main">
   <p:cSld>
     <p:spTree>
@@ -27148,7 +23792,7 @@
 </p:sld>
 </file>
 
-<file path=ppt/slides/slide7.xml><?xml version="1.0" encoding="utf-8"?>
+<file path=ppt/slides/slide6.xml><?xml version="1.0" encoding="utf-8"?>
 <p:sld xmlns:a="http://schemas.openxmlformats.org/drawingml/2006/main" xmlns:r="http://schemas.openxmlformats.org/officeDocument/2006/relationships" xmlns:p="http://schemas.openxmlformats.org/presentationml/2006/main">
   <p:cSld>
     <p:spTree>
@@ -27298,7 +23942,7 @@
 </p:sld>
 </file>
 
-<file path=ppt/slides/slide8.xml><?xml version="1.0" encoding="utf-8"?>
+<file path=ppt/slides/slide7.xml><?xml version="1.0" encoding="utf-8"?>
 <p:sld xmlns:a="http://schemas.openxmlformats.org/drawingml/2006/main" xmlns:r="http://schemas.openxmlformats.org/officeDocument/2006/relationships" xmlns:p="http://schemas.openxmlformats.org/presentationml/2006/main">
   <p:cSld>
     <p:spTree>
@@ -27390,7 +24034,7 @@
 </p:sld>
 </file>
 
-<file path=ppt/slides/slide9.xml><?xml version="1.0" encoding="utf-8"?>
+<file path=ppt/slides/slide8.xml><?xml version="1.0" encoding="utf-8"?>
 <p:sld xmlns:a="http://schemas.openxmlformats.org/drawingml/2006/main" xmlns:r="http://schemas.openxmlformats.org/officeDocument/2006/relationships" xmlns:p="http://schemas.openxmlformats.org/presentationml/2006/main">
   <p:cSld>
     <p:spTree>
@@ -27475,6 +24119,108 @@
     <p:extLst>
       <p:ext uri="{BB962C8B-B14F-4D97-AF65-F5344CB8AC3E}">
         <p14:creationId xmlns:p14="http://schemas.microsoft.com/office/powerpoint/2010/main" val="143192751"/>
+      </p:ext>
+    </p:extLst>
+  </p:cSld>
+  <p:clrMapOvr>
+    <a:masterClrMapping/>
+  </p:clrMapOvr>
+</p:sld>
+</file>
+
+<file path=ppt/slides/slide9.xml><?xml version="1.0" encoding="utf-8"?>
+<p:sld xmlns:a="http://schemas.openxmlformats.org/drawingml/2006/main" xmlns:r="http://schemas.openxmlformats.org/officeDocument/2006/relationships" xmlns:p="http://schemas.openxmlformats.org/presentationml/2006/main">
+  <p:cSld>
+    <p:spTree>
+      <p:nvGrpSpPr>
+        <p:cNvPr id="1" name="">
+          <a:extLst>
+            <a:ext uri="{FF2B5EF4-FFF2-40B4-BE49-F238E27FC236}">
+              <a16:creationId xmlns:a16="http://schemas.microsoft.com/office/drawing/2014/main" id="{0CB52369-B04C-C2C9-51B5-5614C2F35052}"/>
+            </a:ext>
+          </a:extLst>
+        </p:cNvPr>
+        <p:cNvGrpSpPr/>
+        <p:nvPr/>
+      </p:nvGrpSpPr>
+      <p:grpSpPr>
+        <a:xfrm>
+          <a:off x="0" y="0"/>
+          <a:ext cx="0" cy="0"/>
+          <a:chOff x="0" y="0"/>
+          <a:chExt cx="0" cy="0"/>
+        </a:xfrm>
+      </p:grpSpPr>
+      <p:sp>
+        <p:nvSpPr>
+          <p:cNvPr id="15" name="Title 14">
+            <a:extLst>
+              <a:ext uri="{FF2B5EF4-FFF2-40B4-BE49-F238E27FC236}">
+                <a16:creationId xmlns:a16="http://schemas.microsoft.com/office/drawing/2014/main" id="{A11AE03E-A139-0CA5-BAE2-173FA8B0E0C2}"/>
+              </a:ext>
+            </a:extLst>
+          </p:cNvPr>
+          <p:cNvSpPr>
+            <a:spLocks noGrp="1"/>
+          </p:cNvSpPr>
+          <p:nvPr>
+            <p:ph type="title"/>
+          </p:nvPr>
+        </p:nvSpPr>
+        <p:spPr/>
+        <p:txBody>
+          <a:bodyPr>
+            <a:normAutofit/>
+          </a:bodyPr>
+          <a:lstStyle/>
+          <a:p>
+            <a:r>
+              <a:rPr lang="en-US" dirty="0"/>
+              <a:t>~ </a:t>
+            </a:r>
+            <a:r>
+              <a:rPr lang="en-GB" dirty="0"/>
+              <a:t>Functional Requirements </a:t>
+            </a:r>
+            <a:r>
+              <a:rPr lang="en-US" dirty="0"/>
+              <a:t>~</a:t>
+            </a:r>
+          </a:p>
+        </p:txBody>
+      </p:sp>
+      <p:graphicFrame>
+        <p:nvGraphicFramePr>
+          <p:cNvPr id="19" name="Text Placeholder 16">
+            <a:extLst>
+              <a:ext uri="{FF2B5EF4-FFF2-40B4-BE49-F238E27FC236}">
+                <a16:creationId xmlns:a16="http://schemas.microsoft.com/office/drawing/2014/main" id="{D6C29C33-791D-62A9-1E9E-96FB10000C2B}"/>
+              </a:ext>
+            </a:extLst>
+          </p:cNvPr>
+          <p:cNvGraphicFramePr/>
+          <p:nvPr>
+            <p:extLst>
+              <p:ext uri="{D42A27DB-BD31-4B8C-83A1-F6EECF244321}">
+                <p14:modId xmlns:p14="http://schemas.microsoft.com/office/powerpoint/2010/main" val="858922307"/>
+              </p:ext>
+            </p:extLst>
+          </p:nvPr>
+        </p:nvGraphicFramePr>
+        <p:xfrm>
+          <a:off x="1379040" y="2032912"/>
+          <a:ext cx="9425449" cy="4266960"/>
+        </p:xfrm>
+        <a:graphic>
+          <a:graphicData uri="http://schemas.openxmlformats.org/drawingml/2006/diagram">
+            <dgm:relIds xmlns:dgm="http://schemas.openxmlformats.org/drawingml/2006/diagram" xmlns:r="http://schemas.openxmlformats.org/officeDocument/2006/relationships" r:dm="rId3" r:lo="rId4" r:qs="rId5" r:cs="rId6"/>
+          </a:graphicData>
+        </a:graphic>
+      </p:graphicFrame>
+    </p:spTree>
+    <p:extLst>
+      <p:ext uri="{BB962C8B-B14F-4D97-AF65-F5344CB8AC3E}">
+        <p14:creationId xmlns:p14="http://schemas.microsoft.com/office/powerpoint/2010/main" val="1382077199"/>
       </p:ext>
     </p:extLst>
   </p:cSld>
@@ -28013,6 +24759,15 @@
 </file>
 
 <file path=customXml/item1.xml><?xml version="1.0" encoding="utf-8"?>
+<?mso-contentType ?>
+<FormTemplates xmlns="http://schemas.microsoft.com/sharepoint/v3/contenttype/forms">
+  <Display>DocumentLibraryForm</Display>
+  <Edit>DocumentLibraryForm</Edit>
+  <New>DocumentLibraryForm</New>
+</FormTemplates>
+</file>
+
+<file path=customXml/item2.xml><?xml version="1.0" encoding="utf-8"?>
 <p:properties xmlns:p="http://schemas.microsoft.com/office/2006/metadata/properties" xmlns:xsi="http://www.w3.org/2001/XMLSchema-instance" xmlns:pc="http://schemas.microsoft.com/office/infopath/2007/PartnerControls">
   <documentManagement>
     <_ip_UnifiedCompliancePolicyUIAction xmlns="http://schemas.microsoft.com/sharepoint/v3" xsi:nil="true"/>
@@ -28030,15 +24785,6 @@
     <MediaServiceKeyPoints xmlns="71af3243-3dd4-4a8d-8c0d-dd76da1f02a5" xsi:nil="true"/>
   </documentManagement>
 </p:properties>
-</file>
-
-<file path=customXml/item2.xml><?xml version="1.0" encoding="utf-8"?>
-<?mso-contentType ?>
-<FormTemplates xmlns="http://schemas.microsoft.com/sharepoint/v3/contenttype/forms">
-  <Display>DocumentLibraryForm</Display>
-  <Edit>DocumentLibraryForm</Edit>
-  <New>DocumentLibraryForm</New>
-</FormTemplates>
 </file>
 
 <file path=customXml/item3.xml><?xml version="1.0" encoding="utf-8"?>
@@ -28354,6 +25100,14 @@
 </file>
 
 <file path=customXml/itemProps1.xml><?xml version="1.0" encoding="utf-8"?>
+<ds:datastoreItem xmlns:ds="http://schemas.openxmlformats.org/officeDocument/2006/customXml" ds:itemID="{EF746E38-3E45-40EB-917C-6C82B8DF19AC}">
+  <ds:schemaRefs>
+    <ds:schemaRef ds:uri="http://schemas.microsoft.com/sharepoint/v3/contenttype/forms"/>
+  </ds:schemaRefs>
+</ds:datastoreItem>
+</file>
+
+<file path=customXml/itemProps2.xml><?xml version="1.0" encoding="utf-8"?>
 <ds:datastoreItem xmlns:ds="http://schemas.openxmlformats.org/officeDocument/2006/customXml" ds:itemID="{C0FBC208-84B5-4BA7-8306-5BDC2F8CE14B}">
   <ds:schemaRefs>
     <ds:schemaRef ds:uri="http://schemas.microsoft.com/office/2006/metadata/properties"/>
@@ -28361,14 +25115,6 @@
     <ds:schemaRef ds:uri="http://schemas.microsoft.com/sharepoint/v3"/>
     <ds:schemaRef ds:uri="71af3243-3dd4-4a8d-8c0d-dd76da1f02a5"/>
     <ds:schemaRef ds:uri="230e9df3-be65-4c73-a93b-d1236ebd677e"/>
-  </ds:schemaRefs>
-</ds:datastoreItem>
-</file>
-
-<file path=customXml/itemProps2.xml><?xml version="1.0" encoding="utf-8"?>
-<ds:datastoreItem xmlns:ds="http://schemas.openxmlformats.org/officeDocument/2006/customXml" ds:itemID="{EF746E38-3E45-40EB-917C-6C82B8DF19AC}">
-  <ds:schemaRefs>
-    <ds:schemaRef ds:uri="http://schemas.microsoft.com/sharepoint/v3/contenttype/forms"/>
   </ds:schemaRefs>
 </ds:datastoreItem>
 </file>

</xml_diff>